<commit_message>
fix: draw deck bar charts as shapes so they render in any viewer
Co-Authored-By: Claude Sonnet 5.5 <noreply@anthropic.com>
Claude-Session: https://claude.ai/code/session_019HCofad21LeZFq9nZLaJgG
</commit_message>
<xml_diff>
--- a/public/papers/milp-acceleration-v2.pptx
+++ b/public/papers/milp-acceleration-v2.pptx
@@ -130,600 +130,6 @@
     </a:lvl9pPr>
   </p:defaultTextStyle>
 </p:presentation>
-</file>
-
-<file path=ppt/charts/chart1.xml><?xml version="1.0" encoding="utf-8"?>
-<c:chartSpace xmlns:c="http://schemas.openxmlformats.org/drawingml/2006/chart" xmlns:a="http://schemas.openxmlformats.org/drawingml/2006/main" xmlns:r="http://schemas.openxmlformats.org/officeDocument/2006/relationships">
-  <c:date1904 val="0"/>
-  <c:roundedCorners val="1"/>
-  <c:chart>
-    <c:title>
-      <c:tx>
-        <c:rich>
-          <a:bodyPr/>
-          <a:lstStyle/>
-          <a:p>
-            <a:pPr>
-              <a:defRPr sz="1400" b="0" i="0" u="none" strike="noStrike">
-                <a:solidFill>
-                  <a:srgbClr val="123C4A"/>
-                </a:solidFill>
-                <a:latin typeface="Apple SD Gothic Neo"/>
-              </a:defRPr>
-            </a:pPr>
-            <a:r>
-              <a:rPr sz="1400" b="0" i="0" u="none" strike="noStrike">
-                <a:solidFill>
-                  <a:srgbClr val="123C4A"/>
-                </a:solidFill>
-                <a:latin typeface="Apple SD Gothic Neo"/>
-              </a:rPr>
-              <a:t>끄면 느려지는 배수 (시간 비)</a:t>
-            </a:r>
-          </a:p>
-        </c:rich>
-      </c:tx>
-      <c:layout/>
-      <c:overlay val="0"/>
-    </c:title>
-    <c:autoTitleDeleted val="0"/>
-    <c:plotArea>
-      <c:layout/>
-      <c:barChart>
-        <c:barDir val="bar"/>
-        <c:grouping val="clustered"/>
-        <c:varyColors val="0"/>
-        <c:ser>
-          <c:idx val="0"/>
-          <c:order val="0"/>
-          <c:tx>
-            <c:strRef>
-              <c:f>Sheet1!$B$1</c:f>
-              <c:strCache>
-                <c:ptCount val="1"/>
-                <c:pt idx="0">
-                  <c:v>끄면 느려지는 배수</c:v>
-                </c:pt>
-              </c:strCache>
-            </c:strRef>
-          </c:tx>
-          <c:spPr>
-            <a:solidFill>
-              <a:srgbClr val="0F7B8A"/>
-            </a:solidFill>
-            <a:effectLst/>
-          </c:spPr>
-          <c:invertIfNegative val="0"/>
-          <c:dLbls>
-            <c:numFmt formatCode="0.00" sourceLinked="0"/>
-            <c:txPr>
-              <a:bodyPr/>
-              <a:lstStyle/>
-              <a:p>
-                <a:pPr>
-                  <a:defRPr b="0" i="0" strike="noStrike" sz="1200" u="none">
-                    <a:solidFill>
-                      <a:srgbClr val="000000"/>
-                    </a:solidFill>
-                    <a:latin typeface="Apple SD Gothic Neo"/>
-                  </a:defRPr>
-                </a:pPr>
-              </a:p>
-            </c:txPr>
-            <c:showLegendKey val="0"/>
-            <c:showVal val="1"/>
-            <c:showCatName val="0"/>
-            <c:showSerName val="0"/>
-            <c:showPercent val="0"/>
-            <c:showBubbleSize val="0"/>
-            <c:showLeaderLines val="0"/>
-          </c:dLbls>
-          <c:cat>
-            <c:multiLvlStrRef>
-              <c:f>Sheet1!$A$2:$A$8</c:f>
-              <c:multiLvlStrCache>
-                <c:ptCount val="7"/>
-                <c:lvl>
-                  <c:pt idx="0">
-                    <c:v>모델 정리</c:v>
-                  </c:pt>
-                  <c:pt idx="1">
-                    <c:v>경계 강화</c:v>
-                  </c:pt>
-                  <c:pt idx="2">
-                    <c:v>계수 강화</c:v>
-                  </c:pt>
-                  <c:pt idx="3">
-                    <c:v>Chvátal-Gomory</c:v>
-                  </c:pt>
-                  <c:pt idx="4">
-                    <c:v>이중 고정</c:v>
-                  </c:pt>
-                  <c:pt idx="5">
-                    <c:v>대칭 변수 병합</c:v>
-                  </c:pt>
-                  <c:pt idx="6">
-                    <c:v>Orbital fixing</c:v>
-                  </c:pt>
-                </c:lvl>
-              </c:multiLvlStrCache>
-            </c:multiLvlStrRef>
-          </c:cat>
-          <c:val>
-            <c:numRef>
-              <c:f>Sheet1!$B$2:$B$8</c:f>
-              <c:numCache>
-                <c:formatCode>General</c:formatCode>
-                <c:ptCount val="7"/>
-                <c:pt idx="0">
-                  <c:v>1.1</c:v>
-                </c:pt>
-                <c:pt idx="1">
-                  <c:v>1.09</c:v>
-                </c:pt>
-                <c:pt idx="2">
-                  <c:v>1.06</c:v>
-                </c:pt>
-                <c:pt idx="3">
-                  <c:v>1</c:v>
-                </c:pt>
-                <c:pt idx="4">
-                  <c:v>1.04</c:v>
-                </c:pt>
-                <c:pt idx="5">
-                  <c:v>1.03</c:v>
-                </c:pt>
-                <c:pt idx="6">
-                  <c:v>1.2</c:v>
-                </c:pt>
-              </c:numCache>
-            </c:numRef>
-          </c:val>
-        </c:ser>
-        <c:dLbls>
-          <c:numFmt formatCode="0.00" sourceLinked="0"/>
-          <c:txPr>
-            <a:bodyPr/>
-            <a:lstStyle/>
-            <a:p>
-              <a:pPr>
-                <a:defRPr b="0" i="0" strike="noStrike" sz="1200" u="none">
-                  <a:solidFill>
-                    <a:srgbClr val="000000"/>
-                  </a:solidFill>
-                  <a:latin typeface="Apple SD Gothic Neo"/>
-                </a:defRPr>
-              </a:pPr>
-            </a:p>
-          </c:txPr>
-          <c:showLegendKey val="0"/>
-          <c:showVal val="1"/>
-          <c:showCatName val="0"/>
-          <c:showSerName val="0"/>
-          <c:showPercent val="0"/>
-          <c:showBubbleSize val="0"/>
-          <c:showLeaderLines val="0"/>
-        </c:dLbls>
-        <c:gapWidth val="150"/>
-        <c:overlap val="0"/>
-        <c:axId val="2094734554"/>
-        <c:axId val="2094734552"/>
-        <c:axId val="2094734556"/>
-      </c:barChart>
-      <c:catAx>
-        <c:axId val="2094734554"/>
-        <c:scaling>
-          <c:orientation val="minMax"/>
-        </c:scaling>
-        <c:delete val="0"/>
-        <c:axPos val="l"/>
-        <c:numFmt formatCode="General" sourceLinked="1"/>
-        <c:majorTickMark val="out"/>
-        <c:minorTickMark val="none"/>
-        <c:tickLblPos val="nextTo"/>
-        <c:spPr>
-          <a:ln w="12700" cap="flat">
-            <a:solidFill>
-              <a:srgbClr val="888888"/>
-            </a:solidFill>
-            <a:prstDash val="solid"/>
-            <a:round/>
-          </a:ln>
-        </c:spPr>
-        <c:txPr>
-          <a:bodyPr/>
-          <a:lstStyle/>
-          <a:p>
-            <a:pPr>
-              <a:defRPr sz="1300" b="0" i="0" u="none" strike="noStrike">
-                <a:solidFill>
-                  <a:srgbClr val="1B1F2A"/>
-                </a:solidFill>
-                <a:latin typeface="Apple SD Gothic Neo"/>
-              </a:defRPr>
-            </a:pPr>
-            <a:endParaRPr lang="en-US"/>
-          </a:p>
-        </c:txPr>
-        <c:crossAx val="2094734552"/>
-        <c:crosses val="autoZero"/>
-        <c:auto val="1"/>
-        <c:lblAlgn val="ctr"/>
-        <c:noMultiLvlLbl val="1"/>
-      </c:catAx>
-      <c:valAx>
-        <c:axId val="2094734552"/>
-        <c:scaling>
-          <c:orientation val="minMax"/>
-          <c:max val="1.3"/>
-          <c:min val="0.9"/>
-        </c:scaling>
-        <c:delete val="0"/>
-        <c:axPos val="b"/>
-        <c:majorGridlines>
-          <c:spPr>
-            <a:ln w="6350" cap="flat">
-              <a:solidFill>
-                <a:srgbClr val="D5DDE0"/>
-              </a:solidFill>
-              <a:prstDash val="solid"/>
-              <a:round/>
-            </a:ln>
-          </c:spPr>
-        </c:majorGridlines>
-        <c:numFmt formatCode="General" sourceLinked="0"/>
-        <c:majorTickMark val="out"/>
-        <c:minorTickMark val="none"/>
-        <c:tickLblPos val="low"/>
-        <c:spPr>
-          <a:ln w="12700" cap="flat">
-            <a:solidFill>
-              <a:srgbClr val="888888"/>
-            </a:solidFill>
-            <a:prstDash val="solid"/>
-            <a:round/>
-          </a:ln>
-        </c:spPr>
-        <c:txPr>
-          <a:bodyPr/>
-          <a:lstStyle/>
-          <a:p>
-            <a:pPr>
-              <a:defRPr sz="1100" b="0" i="0" u="none" strike="noStrike">
-                <a:solidFill>
-                  <a:srgbClr val="5B6B7A"/>
-                </a:solidFill>
-                <a:latin typeface="Apple SD Gothic Neo"/>
-              </a:defRPr>
-            </a:pPr>
-            <a:endParaRPr lang="en-US"/>
-          </a:p>
-        </c:txPr>
-        <c:crossAx val="2094734554"/>
-        <c:crosses val="autoZero"/>
-        <c:crossBetween val="between"/>
-      </c:valAx>
-      <c:spPr>
-        <a:noFill/>
-        <a:ln>
-          <a:noFill/>
-        </a:ln>
-        <a:effectLst/>
-      </c:spPr>
-    </c:plotArea>
-    <c:plotVisOnly val="1"/>
-    <c:dispBlanksAs val="span"/>
-  </c:chart>
-  <c:spPr>
-    <a:noFill/>
-    <a:ln>
-      <a:noFill/>
-    </a:ln>
-    <a:effectLst/>
-  </c:spPr>
-  <c:externalData r:id="rId1">
-    <c:autoUpdate val="0"/>
-  </c:externalData>
-</c:chartSpace>
-</file>
-
-<file path=ppt/charts/chart2.xml><?xml version="1.0" encoding="utf-8"?>
-<c:chartSpace xmlns:c="http://schemas.openxmlformats.org/drawingml/2006/chart" xmlns:a="http://schemas.openxmlformats.org/drawingml/2006/main" xmlns:r="http://schemas.openxmlformats.org/officeDocument/2006/relationships">
-  <c:date1904 val="0"/>
-  <c:roundedCorners val="1"/>
-  <c:chart>
-    <c:title>
-      <c:tx>
-        <c:rich>
-          <a:bodyPr/>
-          <a:lstStyle/>
-          <a:p>
-            <a:pPr>
-              <a:defRPr sz="1400" b="0" i="0" u="none" strike="noStrike">
-                <a:solidFill>
-                  <a:srgbClr val="123C4A"/>
-                </a:solidFill>
-                <a:latin typeface="Apple SD Gothic Neo"/>
-              </a:defRPr>
-            </a:pPr>
-            <a:r>
-              <a:rPr sz="1400" b="0" i="0" u="none" strike="noStrike">
-                <a:solidFill>
-                  <a:srgbClr val="123C4A"/>
-                </a:solidFill>
-                <a:latin typeface="Apple SD Gothic Neo"/>
-              </a:rPr>
-              <a:t>기하평균 풀이 시간 (초)</a:t>
-            </a:r>
-          </a:p>
-        </c:rich>
-      </c:tx>
-      <c:layout/>
-      <c:overlay val="0"/>
-    </c:title>
-    <c:autoTitleDeleted val="0"/>
-    <c:plotArea>
-      <c:layout/>
-      <c:barChart>
-        <c:barDir val="col"/>
-        <c:grouping val="clustered"/>
-        <c:varyColors val="0"/>
-        <c:ser>
-          <c:idx val="0"/>
-          <c:order val="0"/>
-          <c:tx>
-            <c:strRef>
-              <c:f>Sheet1!$B$1</c:f>
-              <c:strCache>
-                <c:ptCount val="1"/>
-                <c:pt idx="0">
-                  <c:v>기하평균 시간(초)</c:v>
-                </c:pt>
-              </c:strCache>
-            </c:strRef>
-          </c:tx>
-          <c:spPr>
-            <a:solidFill>
-              <a:srgbClr val="0F7B8A"/>
-            </a:solidFill>
-            <a:effectLst/>
-          </c:spPr>
-          <c:invertIfNegative val="0"/>
-          <c:dLbls>
-            <c:numFmt formatCode="0" sourceLinked="0"/>
-            <c:txPr>
-              <a:bodyPr/>
-              <a:lstStyle/>
-              <a:p>
-                <a:pPr>
-                  <a:defRPr b="0" i="0" strike="noStrike" sz="1200" u="none">
-                    <a:solidFill>
-                      <a:srgbClr val="000000"/>
-                    </a:solidFill>
-                    <a:latin typeface="Apple SD Gothic Neo"/>
-                  </a:defRPr>
-                </a:pPr>
-              </a:p>
-            </c:txPr>
-            <c:showLegendKey val="0"/>
-            <c:showVal val="1"/>
-            <c:showCatName val="0"/>
-            <c:showSerName val="0"/>
-            <c:showPercent val="0"/>
-            <c:showBubbleSize val="0"/>
-            <c:showLeaderLines val="0"/>
-          </c:dLbls>
-          <c:cat>
-            <c:multiLvlStrRef>
-              <c:f>Sheet1!$A$2:$A$9</c:f>
-              <c:multiLvlStrCache>
-                <c:ptCount val="8"/>
-                <c:lvl>
-                  <c:pt idx="0">
-                    <c:v>random</c:v>
-                  </c:pt>
-                  <c:pt idx="1">
-                    <c:v>pseudocost</c:v>
-                  </c:pt>
-                  <c:pt idx="2">
-                    <c:v>full strong</c:v>
-                  </c:pt>
-                  <c:pt idx="3">
-                    <c:v>strong/ps(10)</c:v>
-                  </c:pt>
-                  <c:pt idx="4">
-                    <c:v>reliab.(1)</c:v>
-                  </c:pt>
-                  <c:pt idx="5">
-                    <c:v>reliab.(4)</c:v>
-                  </c:pt>
-                  <c:pt idx="6">
-                    <c:v>reliab.(8)</c:v>
-                  </c:pt>
-                  <c:pt idx="7">
-                    <c:v>reliab.(16)</c:v>
-                  </c:pt>
-                </c:lvl>
-              </c:multiLvlStrCache>
-            </c:multiLvlStrRef>
-          </c:cat>
-          <c:val>
-            <c:numRef>
-              <c:f>Sheet1!$B$2:$B$9</c:f>
-              <c:numCache>
-                <c:formatCode>General</c:formatCode>
-                <c:ptCount val="8"/>
-                <c:pt idx="0">
-                  <c:v>923.6</c:v>
-                </c:pt>
-                <c:pt idx="1">
-                  <c:v>283.4</c:v>
-                </c:pt>
-                <c:pt idx="2">
-                  <c:v>504.4</c:v>
-                </c:pt>
-                <c:pt idx="3">
-                  <c:v>229.6</c:v>
-                </c:pt>
-                <c:pt idx="4">
-                  <c:v>216.4</c:v>
-                </c:pt>
-                <c:pt idx="5">
-                  <c:v>178.2</c:v>
-                </c:pt>
-                <c:pt idx="6">
-                  <c:v>170.5</c:v>
-                </c:pt>
-                <c:pt idx="7">
-                  <c:v>179</c:v>
-                </c:pt>
-              </c:numCache>
-            </c:numRef>
-          </c:val>
-        </c:ser>
-        <c:dLbls>
-          <c:numFmt formatCode="0" sourceLinked="0"/>
-          <c:txPr>
-            <a:bodyPr/>
-            <a:lstStyle/>
-            <a:p>
-              <a:pPr>
-                <a:defRPr b="0" i="0" strike="noStrike" sz="1200" u="none">
-                  <a:solidFill>
-                    <a:srgbClr val="000000"/>
-                  </a:solidFill>
-                  <a:latin typeface="Apple SD Gothic Neo"/>
-                </a:defRPr>
-              </a:pPr>
-            </a:p>
-          </c:txPr>
-          <c:showLegendKey val="0"/>
-          <c:showVal val="1"/>
-          <c:showCatName val="0"/>
-          <c:showSerName val="0"/>
-          <c:showPercent val="0"/>
-          <c:showBubbleSize val="0"/>
-          <c:showLeaderLines val="0"/>
-        </c:dLbls>
-        <c:gapWidth val="150"/>
-        <c:overlap val="0"/>
-        <c:axId val="2094734554"/>
-        <c:axId val="2094734552"/>
-        <c:axId val="2094734556"/>
-      </c:barChart>
-      <c:catAx>
-        <c:axId val="2094734554"/>
-        <c:scaling>
-          <c:orientation val="minMax"/>
-        </c:scaling>
-        <c:delete val="0"/>
-        <c:axPos val="b"/>
-        <c:numFmt formatCode="General" sourceLinked="1"/>
-        <c:majorTickMark val="out"/>
-        <c:minorTickMark val="none"/>
-        <c:tickLblPos val="low"/>
-        <c:spPr>
-          <a:ln w="12700" cap="flat">
-            <a:solidFill>
-              <a:srgbClr val="888888"/>
-            </a:solidFill>
-            <a:prstDash val="solid"/>
-            <a:round/>
-          </a:ln>
-        </c:spPr>
-        <c:txPr>
-          <a:bodyPr/>
-          <a:lstStyle/>
-          <a:p>
-            <a:pPr>
-              <a:defRPr sz="1100" b="0" i="0" u="none" strike="noStrike">
-                <a:solidFill>
-                  <a:srgbClr val="1B1F2A"/>
-                </a:solidFill>
-                <a:latin typeface="Apple SD Gothic Neo"/>
-              </a:defRPr>
-            </a:pPr>
-            <a:endParaRPr lang="en-US"/>
-          </a:p>
-        </c:txPr>
-        <c:crossAx val="2094734552"/>
-        <c:crosses val="autoZero"/>
-        <c:auto val="1"/>
-        <c:lblAlgn val="ctr"/>
-        <c:noMultiLvlLbl val="1"/>
-      </c:catAx>
-      <c:valAx>
-        <c:axId val="2094734552"/>
-        <c:scaling>
-          <c:orientation val="minMax"/>
-        </c:scaling>
-        <c:delete val="0"/>
-        <c:axPos val="l"/>
-        <c:majorGridlines>
-          <c:spPr>
-            <a:ln w="6350" cap="flat">
-              <a:solidFill>
-                <a:srgbClr val="D5DDE0"/>
-              </a:solidFill>
-              <a:prstDash val="solid"/>
-              <a:round/>
-            </a:ln>
-          </c:spPr>
-        </c:majorGridlines>
-        <c:numFmt formatCode="General" sourceLinked="0"/>
-        <c:majorTickMark val="out"/>
-        <c:minorTickMark val="none"/>
-        <c:tickLblPos val="nextTo"/>
-        <c:spPr>
-          <a:ln w="12700" cap="flat">
-            <a:solidFill>
-              <a:srgbClr val="888888"/>
-            </a:solidFill>
-            <a:prstDash val="solid"/>
-            <a:round/>
-          </a:ln>
-        </c:spPr>
-        <c:txPr>
-          <a:bodyPr/>
-          <a:lstStyle/>
-          <a:p>
-            <a:pPr>
-              <a:defRPr sz="1100" b="0" i="0" u="none" strike="noStrike">
-                <a:solidFill>
-                  <a:srgbClr val="5B6B7A"/>
-                </a:solidFill>
-                <a:latin typeface="Apple SD Gothic Neo"/>
-              </a:defRPr>
-            </a:pPr>
-            <a:endParaRPr lang="en-US"/>
-          </a:p>
-        </c:txPr>
-        <c:crossAx val="2094734554"/>
-        <c:crosses val="autoZero"/>
-        <c:crossBetween val="between"/>
-      </c:valAx>
-      <c:spPr>
-        <a:noFill/>
-        <a:ln>
-          <a:noFill/>
-        </a:ln>
-        <a:effectLst/>
-      </c:spPr>
-    </c:plotArea>
-    <c:plotVisOnly val="1"/>
-    <c:dispBlanksAs val="span"/>
-  </c:chart>
-  <c:spPr>
-    <a:noFill/>
-    <a:ln>
-      <a:noFill/>
-    </a:ln>
-    <a:effectLst/>
-  </c:spPr>
-  <c:externalData r:id="rId1">
-    <c:autoUpdate val="0"/>
-  </c:externalData>
-</c:chartSpace>
 </file>
 
 <file path=ppt/notesMasters/notesMaster1.xml><?xml version="1.0" encoding="utf-8"?>
@@ -5316,25 +4722,1141 @@
           </a:p>
         </p:txBody>
       </p:sp>
-      <p:graphicFrame>
-        <p:nvGraphicFramePr>
-          <p:cNvPr id="4" name="Chart 0" descr=""/>
-          <p:cNvGraphicFramePr/>
-          <p:nvPr/>
-        </p:nvGraphicFramePr>
-        <p:xfrm>
-          <a:off x="548640" y="1371600"/>
-          <a:ext cx="6949440" cy="4754880"/>
-        </p:xfrm>
-        <a:graphic xmlns:a="http://schemas.openxmlformats.org/drawingml/2006/main">
-          <a:graphicData uri="http://schemas.openxmlformats.org/drawingml/2006/chart">
-            <c:chart xmlns:c="http://schemas.openxmlformats.org/drawingml/2006/chart" r:id="rId1"/>
-          </a:graphicData>
-        </a:graphic>
-      </p:graphicFrame>
-      <p:sp>
-        <p:nvSpPr>
-          <p:cNvPr id="5" name="read card"/>
+      <p:sp>
+        <p:nvSpPr>
+          <p:cNvPr id="4" name="Text 1"/>
+          <p:cNvSpPr txBox="1"/>
+          <p:nvPr/>
+        </p:nvSpPr>
+        <p:spPr>
+          <a:xfrm>
+            <a:off x="548640" y="1325880"/>
+            <a:ext cx="6949440" cy="365760"/>
+          </a:xfrm>
+          <a:prstGeom prst="rect">
+            <a:avLst/>
+          </a:prstGeom>
+          <a:noFill/>
+          <a:ln/>
+        </p:spPr>
+        <p:txBody>
+          <a:bodyPr wrap="square" lIns="0" tIns="0" rIns="0" bIns="0" rtlCol="0" anchor="ctr"/>
+          <a:lstStyle/>
+          <a:p>
+            <a:pPr indent="0" marL="0">
+              <a:buNone/>
+            </a:pPr>
+            <a:r>
+              <a:rPr lang="en-US" sz="1400" b="1" dirty="0">
+                <a:solidFill>
+                  <a:schemeClr val="tx2"/>
+                </a:solidFill>
+                <a:latin typeface="Apple SD Gothic Neo" pitchFamily="34" charset="0"/>
+                <a:ea typeface="Apple SD Gothic Neo" pitchFamily="34" charset="-122"/>
+                <a:cs typeface="Apple SD Gothic Neo" pitchFamily="34" charset="-120"/>
+              </a:rPr>
+              <a:t>끄면 느려지는 배수 (시간 비, 10초 이상 구간, 1.00 = 영향 없음)</a:t>
+            </a:r>
+            <a:endParaRPr lang="en-US" sz="1400" dirty="0"/>
+          </a:p>
+        </p:txBody>
+      </p:sp>
+      <p:sp>
+        <p:nvSpPr>
+          <p:cNvPr id="5" name="grid 0"/>
+          <p:cNvSpPr/>
+          <p:nvPr/>
+        </p:nvSpPr>
+        <p:spPr>
+          <a:xfrm>
+            <a:off x="2926080" y="1783080"/>
+            <a:ext cx="0" cy="4014216"/>
+          </a:xfrm>
+          <a:prstGeom prst="line">
+            <a:avLst/>
+          </a:prstGeom>
+          <a:noFill/>
+          <a:ln w="15875">
+            <a:solidFill>
+              <a:srgbClr val="5B6B7A"/>
+            </a:solidFill>
+            <a:prstDash val="solid"/>
+          </a:ln>
+        </p:spPr>
+      </p:sp>
+      <p:sp>
+        <p:nvSpPr>
+          <p:cNvPr id="6" name="Text 3"/>
+          <p:cNvSpPr txBox="1"/>
+          <p:nvPr/>
+        </p:nvSpPr>
+        <p:spPr>
+          <a:xfrm>
+            <a:off x="2651760" y="5815584"/>
+            <a:ext cx="548640" cy="274320"/>
+          </a:xfrm>
+          <a:prstGeom prst="rect">
+            <a:avLst/>
+          </a:prstGeom>
+          <a:noFill/>
+          <a:ln/>
+        </p:spPr>
+        <p:txBody>
+          <a:bodyPr wrap="square" lIns="0" tIns="0" rIns="0" bIns="0" rtlCol="0" anchor="ctr"/>
+          <a:lstStyle/>
+          <a:p>
+            <a:pPr algn="ctr" indent="0" marL="0">
+              <a:buNone/>
+            </a:pPr>
+            <a:r>
+              <a:rPr lang="en-US" sz="1100" dirty="0">
+                <a:solidFill>
+                  <a:schemeClr val="accent3"/>
+                </a:solidFill>
+                <a:latin typeface="Apple SD Gothic Neo" pitchFamily="34" charset="0"/>
+                <a:ea typeface="Apple SD Gothic Neo" pitchFamily="34" charset="-122"/>
+                <a:cs typeface="Apple SD Gothic Neo" pitchFamily="34" charset="-120"/>
+              </a:rPr>
+              <a:t>1.00</a:t>
+            </a:r>
+            <a:endParaRPr lang="en-US" sz="1100" dirty="0"/>
+          </a:p>
+        </p:txBody>
+      </p:sp>
+      <p:sp>
+        <p:nvSpPr>
+          <p:cNvPr id="7" name="grid 0.05"/>
+          <p:cNvSpPr/>
+          <p:nvPr/>
+        </p:nvSpPr>
+        <p:spPr>
+          <a:xfrm>
+            <a:off x="3767328" y="1783080"/>
+            <a:ext cx="0" cy="4014216"/>
+          </a:xfrm>
+          <a:prstGeom prst="line">
+            <a:avLst/>
+          </a:prstGeom>
+          <a:noFill/>
+          <a:ln w="6350">
+            <a:solidFill>
+              <a:srgbClr val="D5DDE0"/>
+            </a:solidFill>
+            <a:prstDash val="solid"/>
+          </a:ln>
+        </p:spPr>
+      </p:sp>
+      <p:sp>
+        <p:nvSpPr>
+          <p:cNvPr id="8" name="Text 5"/>
+          <p:cNvSpPr txBox="1"/>
+          <p:nvPr/>
+        </p:nvSpPr>
+        <p:spPr>
+          <a:xfrm>
+            <a:off x="3493008" y="5815584"/>
+            <a:ext cx="548640" cy="274320"/>
+          </a:xfrm>
+          <a:prstGeom prst="rect">
+            <a:avLst/>
+          </a:prstGeom>
+          <a:noFill/>
+          <a:ln/>
+        </p:spPr>
+        <p:txBody>
+          <a:bodyPr wrap="square" lIns="0" tIns="0" rIns="0" bIns="0" rtlCol="0" anchor="ctr"/>
+          <a:lstStyle/>
+          <a:p>
+            <a:pPr algn="ctr" indent="0" marL="0">
+              <a:buNone/>
+            </a:pPr>
+            <a:r>
+              <a:rPr lang="en-US" sz="1100" dirty="0">
+                <a:solidFill>
+                  <a:schemeClr val="accent3"/>
+                </a:solidFill>
+                <a:latin typeface="Apple SD Gothic Neo" pitchFamily="34" charset="0"/>
+                <a:ea typeface="Apple SD Gothic Neo" pitchFamily="34" charset="-122"/>
+                <a:cs typeface="Apple SD Gothic Neo" pitchFamily="34" charset="-120"/>
+              </a:rPr>
+              <a:t>1.05</a:t>
+            </a:r>
+            <a:endParaRPr lang="en-US" sz="1100" dirty="0"/>
+          </a:p>
+        </p:txBody>
+      </p:sp>
+      <p:sp>
+        <p:nvSpPr>
+          <p:cNvPr id="9" name="grid 0.1"/>
+          <p:cNvSpPr/>
+          <p:nvPr/>
+        </p:nvSpPr>
+        <p:spPr>
+          <a:xfrm>
+            <a:off x="4608576" y="1783080"/>
+            <a:ext cx="0" cy="4014216"/>
+          </a:xfrm>
+          <a:prstGeom prst="line">
+            <a:avLst/>
+          </a:prstGeom>
+          <a:noFill/>
+          <a:ln w="6350">
+            <a:solidFill>
+              <a:srgbClr val="D5DDE0"/>
+            </a:solidFill>
+            <a:prstDash val="solid"/>
+          </a:ln>
+        </p:spPr>
+      </p:sp>
+      <p:sp>
+        <p:nvSpPr>
+          <p:cNvPr id="10" name="Text 7"/>
+          <p:cNvSpPr txBox="1"/>
+          <p:nvPr/>
+        </p:nvSpPr>
+        <p:spPr>
+          <a:xfrm>
+            <a:off x="4334256" y="5815584"/>
+            <a:ext cx="548640" cy="274320"/>
+          </a:xfrm>
+          <a:prstGeom prst="rect">
+            <a:avLst/>
+          </a:prstGeom>
+          <a:noFill/>
+          <a:ln/>
+        </p:spPr>
+        <p:txBody>
+          <a:bodyPr wrap="square" lIns="0" tIns="0" rIns="0" bIns="0" rtlCol="0" anchor="ctr"/>
+          <a:lstStyle/>
+          <a:p>
+            <a:pPr algn="ctr" indent="0" marL="0">
+              <a:buNone/>
+            </a:pPr>
+            <a:r>
+              <a:rPr lang="en-US" sz="1100" dirty="0">
+                <a:solidFill>
+                  <a:schemeClr val="accent3"/>
+                </a:solidFill>
+                <a:latin typeface="Apple SD Gothic Neo" pitchFamily="34" charset="0"/>
+                <a:ea typeface="Apple SD Gothic Neo" pitchFamily="34" charset="-122"/>
+                <a:cs typeface="Apple SD Gothic Neo" pitchFamily="34" charset="-120"/>
+              </a:rPr>
+              <a:t>1.10</a:t>
+            </a:r>
+            <a:endParaRPr lang="en-US" sz="1100" dirty="0"/>
+          </a:p>
+        </p:txBody>
+      </p:sp>
+      <p:sp>
+        <p:nvSpPr>
+          <p:cNvPr id="11" name="grid 0.15"/>
+          <p:cNvSpPr/>
+          <p:nvPr/>
+        </p:nvSpPr>
+        <p:spPr>
+          <a:xfrm>
+            <a:off x="5449824" y="1783080"/>
+            <a:ext cx="0" cy="4014216"/>
+          </a:xfrm>
+          <a:prstGeom prst="line">
+            <a:avLst/>
+          </a:prstGeom>
+          <a:noFill/>
+          <a:ln w="6350">
+            <a:solidFill>
+              <a:srgbClr val="D5DDE0"/>
+            </a:solidFill>
+            <a:prstDash val="solid"/>
+          </a:ln>
+        </p:spPr>
+      </p:sp>
+      <p:sp>
+        <p:nvSpPr>
+          <p:cNvPr id="12" name="Text 9"/>
+          <p:cNvSpPr txBox="1"/>
+          <p:nvPr/>
+        </p:nvSpPr>
+        <p:spPr>
+          <a:xfrm>
+            <a:off x="5175504" y="5815584"/>
+            <a:ext cx="548640" cy="274320"/>
+          </a:xfrm>
+          <a:prstGeom prst="rect">
+            <a:avLst/>
+          </a:prstGeom>
+          <a:noFill/>
+          <a:ln/>
+        </p:spPr>
+        <p:txBody>
+          <a:bodyPr wrap="square" lIns="0" tIns="0" rIns="0" bIns="0" rtlCol="0" anchor="ctr"/>
+          <a:lstStyle/>
+          <a:p>
+            <a:pPr algn="ctr" indent="0" marL="0">
+              <a:buNone/>
+            </a:pPr>
+            <a:r>
+              <a:rPr lang="en-US" sz="1100" dirty="0">
+                <a:solidFill>
+                  <a:schemeClr val="accent3"/>
+                </a:solidFill>
+                <a:latin typeface="Apple SD Gothic Neo" pitchFamily="34" charset="0"/>
+                <a:ea typeface="Apple SD Gothic Neo" pitchFamily="34" charset="-122"/>
+                <a:cs typeface="Apple SD Gothic Neo" pitchFamily="34" charset="-120"/>
+              </a:rPr>
+              <a:t>1.15</a:t>
+            </a:r>
+            <a:endParaRPr lang="en-US" sz="1100" dirty="0"/>
+          </a:p>
+        </p:txBody>
+      </p:sp>
+      <p:sp>
+        <p:nvSpPr>
+          <p:cNvPr id="13" name="grid 0.2"/>
+          <p:cNvSpPr/>
+          <p:nvPr/>
+        </p:nvSpPr>
+        <p:spPr>
+          <a:xfrm>
+            <a:off x="6291072" y="1783080"/>
+            <a:ext cx="0" cy="4014216"/>
+          </a:xfrm>
+          <a:prstGeom prst="line">
+            <a:avLst/>
+          </a:prstGeom>
+          <a:noFill/>
+          <a:ln w="6350">
+            <a:solidFill>
+              <a:srgbClr val="D5DDE0"/>
+            </a:solidFill>
+            <a:prstDash val="solid"/>
+          </a:ln>
+        </p:spPr>
+      </p:sp>
+      <p:sp>
+        <p:nvSpPr>
+          <p:cNvPr id="14" name="Text 11"/>
+          <p:cNvSpPr txBox="1"/>
+          <p:nvPr/>
+        </p:nvSpPr>
+        <p:spPr>
+          <a:xfrm>
+            <a:off x="6016752" y="5815584"/>
+            <a:ext cx="548640" cy="274320"/>
+          </a:xfrm>
+          <a:prstGeom prst="rect">
+            <a:avLst/>
+          </a:prstGeom>
+          <a:noFill/>
+          <a:ln/>
+        </p:spPr>
+        <p:txBody>
+          <a:bodyPr wrap="square" lIns="0" tIns="0" rIns="0" bIns="0" rtlCol="0" anchor="ctr"/>
+          <a:lstStyle/>
+          <a:p>
+            <a:pPr algn="ctr" indent="0" marL="0">
+              <a:buNone/>
+            </a:pPr>
+            <a:r>
+              <a:rPr lang="en-US" sz="1100" dirty="0">
+                <a:solidFill>
+                  <a:schemeClr val="accent3"/>
+                </a:solidFill>
+                <a:latin typeface="Apple SD Gothic Neo" pitchFamily="34" charset="0"/>
+                <a:ea typeface="Apple SD Gothic Neo" pitchFamily="34" charset="-122"/>
+                <a:cs typeface="Apple SD Gothic Neo" pitchFamily="34" charset="-120"/>
+              </a:rPr>
+              <a:t>1.20</a:t>
+            </a:r>
+            <a:endParaRPr lang="en-US" sz="1100" dirty="0"/>
+          </a:p>
+        </p:txBody>
+      </p:sp>
+      <p:sp>
+        <p:nvSpPr>
+          <p:cNvPr id="15" name="grid 0.25"/>
+          <p:cNvSpPr/>
+          <p:nvPr/>
+        </p:nvSpPr>
+        <p:spPr>
+          <a:xfrm>
+            <a:off x="7132320" y="1783080"/>
+            <a:ext cx="0" cy="4014216"/>
+          </a:xfrm>
+          <a:prstGeom prst="line">
+            <a:avLst/>
+          </a:prstGeom>
+          <a:noFill/>
+          <a:ln w="6350">
+            <a:solidFill>
+              <a:srgbClr val="D5DDE0"/>
+            </a:solidFill>
+            <a:prstDash val="solid"/>
+          </a:ln>
+        </p:spPr>
+      </p:sp>
+      <p:sp>
+        <p:nvSpPr>
+          <p:cNvPr id="16" name="Text 13"/>
+          <p:cNvSpPr txBox="1"/>
+          <p:nvPr/>
+        </p:nvSpPr>
+        <p:spPr>
+          <a:xfrm>
+            <a:off x="6858000" y="5815584"/>
+            <a:ext cx="548640" cy="274320"/>
+          </a:xfrm>
+          <a:prstGeom prst="rect">
+            <a:avLst/>
+          </a:prstGeom>
+          <a:noFill/>
+          <a:ln/>
+        </p:spPr>
+        <p:txBody>
+          <a:bodyPr wrap="square" lIns="0" tIns="0" rIns="0" bIns="0" rtlCol="0" anchor="ctr"/>
+          <a:lstStyle/>
+          <a:p>
+            <a:pPr algn="ctr" indent="0" marL="0">
+              <a:buNone/>
+            </a:pPr>
+            <a:r>
+              <a:rPr lang="en-US" sz="1100" dirty="0">
+                <a:solidFill>
+                  <a:schemeClr val="accent3"/>
+                </a:solidFill>
+                <a:latin typeface="Apple SD Gothic Neo" pitchFamily="34" charset="0"/>
+                <a:ea typeface="Apple SD Gothic Neo" pitchFamily="34" charset="-122"/>
+                <a:cs typeface="Apple SD Gothic Neo" pitchFamily="34" charset="-120"/>
+              </a:rPr>
+              <a:t>1.25</a:t>
+            </a:r>
+            <a:endParaRPr lang="en-US" sz="1100" dirty="0"/>
+          </a:p>
+        </p:txBody>
+      </p:sp>
+      <p:sp>
+        <p:nvSpPr>
+          <p:cNvPr id="17" name="Text 14"/>
+          <p:cNvSpPr txBox="1"/>
+          <p:nvPr/>
+        </p:nvSpPr>
+        <p:spPr>
+          <a:xfrm>
+            <a:off x="548640" y="1828800"/>
+            <a:ext cx="2240280" cy="566928"/>
+          </a:xfrm>
+          <a:prstGeom prst="rect">
+            <a:avLst/>
+          </a:prstGeom>
+          <a:noFill/>
+          <a:ln/>
+        </p:spPr>
+        <p:txBody>
+          <a:bodyPr wrap="square" lIns="0" tIns="0" rIns="0" bIns="0" rtlCol="0" anchor="ctr"/>
+          <a:lstStyle/>
+          <a:p>
+            <a:pPr algn="r" indent="0" marL="0">
+              <a:buNone/>
+            </a:pPr>
+            <a:r>
+              <a:rPr lang="en-US" sz="1400" dirty="0">
+                <a:solidFill>
+                  <a:schemeClr val="tx1"/>
+                </a:solidFill>
+                <a:latin typeface="Apple SD Gothic Neo" pitchFamily="34" charset="0"/>
+                <a:ea typeface="Apple SD Gothic Neo" pitchFamily="34" charset="-122"/>
+                <a:cs typeface="Apple SD Gothic Neo" pitchFamily="34" charset="-120"/>
+              </a:rPr>
+              <a:t>모델 정리</a:t>
+            </a:r>
+            <a:endParaRPr lang="en-US" sz="1400" dirty="0"/>
+          </a:p>
+        </p:txBody>
+      </p:sp>
+      <p:sp>
+        <p:nvSpPr>
+          <p:cNvPr id="18" name="bar 모델 정리"/>
+          <p:cNvSpPr/>
+          <p:nvPr/>
+        </p:nvSpPr>
+        <p:spPr>
+          <a:xfrm>
+            <a:off x="2926080" y="1956816"/>
+            <a:ext cx="1682496" cy="310896"/>
+          </a:xfrm>
+          <a:prstGeom prst="rect">
+            <a:avLst/>
+          </a:prstGeom>
+          <a:solidFill>
+            <a:schemeClr val="accent1"/>
+          </a:solidFill>
+          <a:ln w="12700">
+            <a:solidFill>
+              <a:schemeClr val="accent1"/>
+            </a:solidFill>
+            <a:prstDash val="solid"/>
+          </a:ln>
+        </p:spPr>
+      </p:sp>
+      <p:sp>
+        <p:nvSpPr>
+          <p:cNvPr id="19" name="Text 16"/>
+          <p:cNvSpPr txBox="1"/>
+          <p:nvPr/>
+        </p:nvSpPr>
+        <p:spPr>
+          <a:xfrm>
+            <a:off x="4700016" y="1828800"/>
+            <a:ext cx="822960" cy="566928"/>
+          </a:xfrm>
+          <a:prstGeom prst="rect">
+            <a:avLst/>
+          </a:prstGeom>
+          <a:noFill/>
+          <a:ln/>
+        </p:spPr>
+        <p:txBody>
+          <a:bodyPr wrap="square" lIns="0" tIns="0" rIns="0" bIns="0" rtlCol="0" anchor="ctr"/>
+          <a:lstStyle/>
+          <a:p>
+            <a:pPr indent="0" marL="0">
+              <a:buNone/>
+            </a:pPr>
+            <a:r>
+              <a:rPr lang="en-US" sz="1300" b="1" dirty="0">
+                <a:solidFill>
+                  <a:schemeClr val="tx2"/>
+                </a:solidFill>
+                <a:latin typeface="Apple SD Gothic Neo" pitchFamily="34" charset="0"/>
+                <a:ea typeface="Apple SD Gothic Neo" pitchFamily="34" charset="-122"/>
+                <a:cs typeface="Apple SD Gothic Neo" pitchFamily="34" charset="-120"/>
+              </a:rPr>
+              <a:t>1.10×</a:t>
+            </a:r>
+            <a:endParaRPr lang="en-US" sz="1300" dirty="0"/>
+          </a:p>
+        </p:txBody>
+      </p:sp>
+      <p:sp>
+        <p:nvSpPr>
+          <p:cNvPr id="20" name="Text 17"/>
+          <p:cNvSpPr txBox="1"/>
+          <p:nvPr/>
+        </p:nvSpPr>
+        <p:spPr>
+          <a:xfrm>
+            <a:off x="548640" y="2395728"/>
+            <a:ext cx="2240280" cy="566928"/>
+          </a:xfrm>
+          <a:prstGeom prst="rect">
+            <a:avLst/>
+          </a:prstGeom>
+          <a:noFill/>
+          <a:ln/>
+        </p:spPr>
+        <p:txBody>
+          <a:bodyPr wrap="square" lIns="0" tIns="0" rIns="0" bIns="0" rtlCol="0" anchor="ctr"/>
+          <a:lstStyle/>
+          <a:p>
+            <a:pPr algn="r" indent="0" marL="0">
+              <a:buNone/>
+            </a:pPr>
+            <a:r>
+              <a:rPr lang="en-US" sz="1400" dirty="0">
+                <a:solidFill>
+                  <a:schemeClr val="tx1"/>
+                </a:solidFill>
+                <a:latin typeface="Apple SD Gothic Neo" pitchFamily="34" charset="0"/>
+                <a:ea typeface="Apple SD Gothic Neo" pitchFamily="34" charset="-122"/>
+                <a:cs typeface="Apple SD Gothic Neo" pitchFamily="34" charset="-120"/>
+              </a:rPr>
+              <a:t>경계 강화</a:t>
+            </a:r>
+            <a:endParaRPr lang="en-US" sz="1400" dirty="0"/>
+          </a:p>
+        </p:txBody>
+      </p:sp>
+      <p:sp>
+        <p:nvSpPr>
+          <p:cNvPr id="21" name="bar 경계 강화"/>
+          <p:cNvSpPr/>
+          <p:nvPr/>
+        </p:nvSpPr>
+        <p:spPr>
+          <a:xfrm>
+            <a:off x="2926080" y="2523744"/>
+            <a:ext cx="1514246" cy="310896"/>
+          </a:xfrm>
+          <a:prstGeom prst="rect">
+            <a:avLst/>
+          </a:prstGeom>
+          <a:solidFill>
+            <a:schemeClr val="accent1"/>
+          </a:solidFill>
+          <a:ln w="12700">
+            <a:solidFill>
+              <a:schemeClr val="accent1"/>
+            </a:solidFill>
+            <a:prstDash val="solid"/>
+          </a:ln>
+        </p:spPr>
+      </p:sp>
+      <p:sp>
+        <p:nvSpPr>
+          <p:cNvPr id="22" name="Text 19"/>
+          <p:cNvSpPr txBox="1"/>
+          <p:nvPr/>
+        </p:nvSpPr>
+        <p:spPr>
+          <a:xfrm>
+            <a:off x="4531766" y="2395728"/>
+            <a:ext cx="822960" cy="566928"/>
+          </a:xfrm>
+          <a:prstGeom prst="rect">
+            <a:avLst/>
+          </a:prstGeom>
+          <a:noFill/>
+          <a:ln/>
+        </p:spPr>
+        <p:txBody>
+          <a:bodyPr wrap="square" lIns="0" tIns="0" rIns="0" bIns="0" rtlCol="0" anchor="ctr"/>
+          <a:lstStyle/>
+          <a:p>
+            <a:pPr indent="0" marL="0">
+              <a:buNone/>
+            </a:pPr>
+            <a:r>
+              <a:rPr lang="en-US" sz="1300" b="1" dirty="0">
+                <a:solidFill>
+                  <a:schemeClr val="tx2"/>
+                </a:solidFill>
+                <a:latin typeface="Apple SD Gothic Neo" pitchFamily="34" charset="0"/>
+                <a:ea typeface="Apple SD Gothic Neo" pitchFamily="34" charset="-122"/>
+                <a:cs typeface="Apple SD Gothic Neo" pitchFamily="34" charset="-120"/>
+              </a:rPr>
+              <a:t>1.09×</a:t>
+            </a:r>
+            <a:endParaRPr lang="en-US" sz="1300" dirty="0"/>
+          </a:p>
+        </p:txBody>
+      </p:sp>
+      <p:sp>
+        <p:nvSpPr>
+          <p:cNvPr id="23" name="Text 20"/>
+          <p:cNvSpPr txBox="1"/>
+          <p:nvPr/>
+        </p:nvSpPr>
+        <p:spPr>
+          <a:xfrm>
+            <a:off x="548640" y="2962656"/>
+            <a:ext cx="2240280" cy="566928"/>
+          </a:xfrm>
+          <a:prstGeom prst="rect">
+            <a:avLst/>
+          </a:prstGeom>
+          <a:noFill/>
+          <a:ln/>
+        </p:spPr>
+        <p:txBody>
+          <a:bodyPr wrap="square" lIns="0" tIns="0" rIns="0" bIns="0" rtlCol="0" anchor="ctr"/>
+          <a:lstStyle/>
+          <a:p>
+            <a:pPr algn="r" indent="0" marL="0">
+              <a:buNone/>
+            </a:pPr>
+            <a:r>
+              <a:rPr lang="en-US" sz="1400" dirty="0">
+                <a:solidFill>
+                  <a:schemeClr val="tx1"/>
+                </a:solidFill>
+                <a:latin typeface="Apple SD Gothic Neo" pitchFamily="34" charset="0"/>
+                <a:ea typeface="Apple SD Gothic Neo" pitchFamily="34" charset="-122"/>
+                <a:cs typeface="Apple SD Gothic Neo" pitchFamily="34" charset="-120"/>
+              </a:rPr>
+              <a:t>계수 강화</a:t>
+            </a:r>
+            <a:endParaRPr lang="en-US" sz="1400" dirty="0"/>
+          </a:p>
+        </p:txBody>
+      </p:sp>
+      <p:sp>
+        <p:nvSpPr>
+          <p:cNvPr id="24" name="bar 계수 강화"/>
+          <p:cNvSpPr/>
+          <p:nvPr/>
+        </p:nvSpPr>
+        <p:spPr>
+          <a:xfrm>
+            <a:off x="2926080" y="3090672"/>
+            <a:ext cx="1009498" cy="310896"/>
+          </a:xfrm>
+          <a:prstGeom prst="rect">
+            <a:avLst/>
+          </a:prstGeom>
+          <a:solidFill>
+            <a:schemeClr val="accent1"/>
+          </a:solidFill>
+          <a:ln w="12700">
+            <a:solidFill>
+              <a:schemeClr val="accent1"/>
+            </a:solidFill>
+            <a:prstDash val="solid"/>
+          </a:ln>
+        </p:spPr>
+      </p:sp>
+      <p:sp>
+        <p:nvSpPr>
+          <p:cNvPr id="25" name="Text 22"/>
+          <p:cNvSpPr txBox="1"/>
+          <p:nvPr/>
+        </p:nvSpPr>
+        <p:spPr>
+          <a:xfrm>
+            <a:off x="4027018" y="2962656"/>
+            <a:ext cx="822960" cy="566928"/>
+          </a:xfrm>
+          <a:prstGeom prst="rect">
+            <a:avLst/>
+          </a:prstGeom>
+          <a:noFill/>
+          <a:ln/>
+        </p:spPr>
+        <p:txBody>
+          <a:bodyPr wrap="square" lIns="0" tIns="0" rIns="0" bIns="0" rtlCol="0" anchor="ctr"/>
+          <a:lstStyle/>
+          <a:p>
+            <a:pPr indent="0" marL="0">
+              <a:buNone/>
+            </a:pPr>
+            <a:r>
+              <a:rPr lang="en-US" sz="1300" b="1" dirty="0">
+                <a:solidFill>
+                  <a:schemeClr val="tx2"/>
+                </a:solidFill>
+                <a:latin typeface="Apple SD Gothic Neo" pitchFamily="34" charset="0"/>
+                <a:ea typeface="Apple SD Gothic Neo" pitchFamily="34" charset="-122"/>
+                <a:cs typeface="Apple SD Gothic Neo" pitchFamily="34" charset="-120"/>
+              </a:rPr>
+              <a:t>1.06×</a:t>
+            </a:r>
+            <a:endParaRPr lang="en-US" sz="1300" dirty="0"/>
+          </a:p>
+        </p:txBody>
+      </p:sp>
+      <p:sp>
+        <p:nvSpPr>
+          <p:cNvPr id="26" name="Text 23"/>
+          <p:cNvSpPr txBox="1"/>
+          <p:nvPr/>
+        </p:nvSpPr>
+        <p:spPr>
+          <a:xfrm>
+            <a:off x="548640" y="3529584"/>
+            <a:ext cx="2240280" cy="566928"/>
+          </a:xfrm>
+          <a:prstGeom prst="rect">
+            <a:avLst/>
+          </a:prstGeom>
+          <a:noFill/>
+          <a:ln/>
+        </p:spPr>
+        <p:txBody>
+          <a:bodyPr wrap="square" lIns="0" tIns="0" rIns="0" bIns="0" rtlCol="0" anchor="ctr"/>
+          <a:lstStyle/>
+          <a:p>
+            <a:pPr algn="r" indent="0" marL="0">
+              <a:buNone/>
+            </a:pPr>
+            <a:r>
+              <a:rPr lang="en-US" sz="1400" dirty="0">
+                <a:solidFill>
+                  <a:schemeClr val="tx1"/>
+                </a:solidFill>
+                <a:latin typeface="Apple SD Gothic Neo" pitchFamily="34" charset="0"/>
+                <a:ea typeface="Apple SD Gothic Neo" pitchFamily="34" charset="-122"/>
+                <a:cs typeface="Apple SD Gothic Neo" pitchFamily="34" charset="-120"/>
+              </a:rPr>
+              <a:t>Chvátal-Gomory</a:t>
+            </a:r>
+            <a:endParaRPr lang="en-US" sz="1400" dirty="0"/>
+          </a:p>
+        </p:txBody>
+      </p:sp>
+      <p:sp>
+        <p:nvSpPr>
+          <p:cNvPr id="27" name="bar Chvátal-Gomory"/>
+          <p:cNvSpPr/>
+          <p:nvPr/>
+        </p:nvSpPr>
+        <p:spPr>
+          <a:xfrm>
+            <a:off x="2926080" y="3657600"/>
+            <a:ext cx="27432" cy="310896"/>
+          </a:xfrm>
+          <a:prstGeom prst="rect">
+            <a:avLst/>
+          </a:prstGeom>
+          <a:solidFill>
+            <a:schemeClr val="accent1"/>
+          </a:solidFill>
+          <a:ln w="12700">
+            <a:solidFill>
+              <a:schemeClr val="accent1"/>
+            </a:solidFill>
+            <a:prstDash val="solid"/>
+          </a:ln>
+        </p:spPr>
+      </p:sp>
+      <p:sp>
+        <p:nvSpPr>
+          <p:cNvPr id="28" name="Text 25"/>
+          <p:cNvSpPr txBox="1"/>
+          <p:nvPr/>
+        </p:nvSpPr>
+        <p:spPr>
+          <a:xfrm>
+            <a:off x="3044952" y="3529584"/>
+            <a:ext cx="822960" cy="566928"/>
+          </a:xfrm>
+          <a:prstGeom prst="rect">
+            <a:avLst/>
+          </a:prstGeom>
+          <a:noFill/>
+          <a:ln/>
+        </p:spPr>
+        <p:txBody>
+          <a:bodyPr wrap="square" lIns="0" tIns="0" rIns="0" bIns="0" rtlCol="0" anchor="ctr"/>
+          <a:lstStyle/>
+          <a:p>
+            <a:pPr indent="0" marL="0">
+              <a:buNone/>
+            </a:pPr>
+            <a:r>
+              <a:rPr lang="en-US" sz="1300" b="1" dirty="0">
+                <a:solidFill>
+                  <a:schemeClr val="tx2"/>
+                </a:solidFill>
+                <a:latin typeface="Apple SD Gothic Neo" pitchFamily="34" charset="0"/>
+                <a:ea typeface="Apple SD Gothic Neo" pitchFamily="34" charset="-122"/>
+                <a:cs typeface="Apple SD Gothic Neo" pitchFamily="34" charset="-120"/>
+              </a:rPr>
+              <a:t>1.00×</a:t>
+            </a:r>
+            <a:endParaRPr lang="en-US" sz="1300" dirty="0"/>
+          </a:p>
+        </p:txBody>
+      </p:sp>
+      <p:sp>
+        <p:nvSpPr>
+          <p:cNvPr id="29" name="Text 26"/>
+          <p:cNvSpPr txBox="1"/>
+          <p:nvPr/>
+        </p:nvSpPr>
+        <p:spPr>
+          <a:xfrm>
+            <a:off x="548640" y="4096512"/>
+            <a:ext cx="2240280" cy="566928"/>
+          </a:xfrm>
+          <a:prstGeom prst="rect">
+            <a:avLst/>
+          </a:prstGeom>
+          <a:noFill/>
+          <a:ln/>
+        </p:spPr>
+        <p:txBody>
+          <a:bodyPr wrap="square" lIns="0" tIns="0" rIns="0" bIns="0" rtlCol="0" anchor="ctr"/>
+          <a:lstStyle/>
+          <a:p>
+            <a:pPr algn="r" indent="0" marL="0">
+              <a:buNone/>
+            </a:pPr>
+            <a:r>
+              <a:rPr lang="en-US" sz="1400" dirty="0">
+                <a:solidFill>
+                  <a:schemeClr val="tx1"/>
+                </a:solidFill>
+                <a:latin typeface="Apple SD Gothic Neo" pitchFamily="34" charset="0"/>
+                <a:ea typeface="Apple SD Gothic Neo" pitchFamily="34" charset="-122"/>
+                <a:cs typeface="Apple SD Gothic Neo" pitchFamily="34" charset="-120"/>
+              </a:rPr>
+              <a:t>이중 고정</a:t>
+            </a:r>
+            <a:endParaRPr lang="en-US" sz="1400" dirty="0"/>
+          </a:p>
+        </p:txBody>
+      </p:sp>
+      <p:sp>
+        <p:nvSpPr>
+          <p:cNvPr id="30" name="bar 이중 고정"/>
+          <p:cNvSpPr/>
+          <p:nvPr/>
+        </p:nvSpPr>
+        <p:spPr>
+          <a:xfrm>
+            <a:off x="2926080" y="4224528"/>
+            <a:ext cx="672998" cy="310896"/>
+          </a:xfrm>
+          <a:prstGeom prst="rect">
+            <a:avLst/>
+          </a:prstGeom>
+          <a:solidFill>
+            <a:schemeClr val="accent1"/>
+          </a:solidFill>
+          <a:ln w="12700">
+            <a:solidFill>
+              <a:schemeClr val="accent1"/>
+            </a:solidFill>
+            <a:prstDash val="solid"/>
+          </a:ln>
+        </p:spPr>
+      </p:sp>
+      <p:sp>
+        <p:nvSpPr>
+          <p:cNvPr id="31" name="Text 28"/>
+          <p:cNvSpPr txBox="1"/>
+          <p:nvPr/>
+        </p:nvSpPr>
+        <p:spPr>
+          <a:xfrm>
+            <a:off x="3690518" y="4096512"/>
+            <a:ext cx="822960" cy="566928"/>
+          </a:xfrm>
+          <a:prstGeom prst="rect">
+            <a:avLst/>
+          </a:prstGeom>
+          <a:noFill/>
+          <a:ln/>
+        </p:spPr>
+        <p:txBody>
+          <a:bodyPr wrap="square" lIns="0" tIns="0" rIns="0" bIns="0" rtlCol="0" anchor="ctr"/>
+          <a:lstStyle/>
+          <a:p>
+            <a:pPr indent="0" marL="0">
+              <a:buNone/>
+            </a:pPr>
+            <a:r>
+              <a:rPr lang="en-US" sz="1300" b="1" dirty="0">
+                <a:solidFill>
+                  <a:schemeClr val="tx2"/>
+                </a:solidFill>
+                <a:latin typeface="Apple SD Gothic Neo" pitchFamily="34" charset="0"/>
+                <a:ea typeface="Apple SD Gothic Neo" pitchFamily="34" charset="-122"/>
+                <a:cs typeface="Apple SD Gothic Neo" pitchFamily="34" charset="-120"/>
+              </a:rPr>
+              <a:t>1.04×</a:t>
+            </a:r>
+            <a:endParaRPr lang="en-US" sz="1300" dirty="0"/>
+          </a:p>
+        </p:txBody>
+      </p:sp>
+      <p:sp>
+        <p:nvSpPr>
+          <p:cNvPr id="32" name="Text 29"/>
+          <p:cNvSpPr txBox="1"/>
+          <p:nvPr/>
+        </p:nvSpPr>
+        <p:spPr>
+          <a:xfrm>
+            <a:off x="548640" y="4663440"/>
+            <a:ext cx="2240280" cy="566928"/>
+          </a:xfrm>
+          <a:prstGeom prst="rect">
+            <a:avLst/>
+          </a:prstGeom>
+          <a:noFill/>
+          <a:ln/>
+        </p:spPr>
+        <p:txBody>
+          <a:bodyPr wrap="square" lIns="0" tIns="0" rIns="0" bIns="0" rtlCol="0" anchor="ctr"/>
+          <a:lstStyle/>
+          <a:p>
+            <a:pPr algn="r" indent="0" marL="0">
+              <a:buNone/>
+            </a:pPr>
+            <a:r>
+              <a:rPr lang="en-US" sz="1400" dirty="0">
+                <a:solidFill>
+                  <a:schemeClr val="tx1"/>
+                </a:solidFill>
+                <a:latin typeface="Apple SD Gothic Neo" pitchFamily="34" charset="0"/>
+                <a:ea typeface="Apple SD Gothic Neo" pitchFamily="34" charset="-122"/>
+                <a:cs typeface="Apple SD Gothic Neo" pitchFamily="34" charset="-120"/>
+              </a:rPr>
+              <a:t>대칭 변수 병합</a:t>
+            </a:r>
+            <a:endParaRPr lang="en-US" sz="1400" dirty="0"/>
+          </a:p>
+        </p:txBody>
+      </p:sp>
+      <p:sp>
+        <p:nvSpPr>
+          <p:cNvPr id="33" name="bar 대칭 변수 병합"/>
+          <p:cNvSpPr/>
+          <p:nvPr/>
+        </p:nvSpPr>
+        <p:spPr>
+          <a:xfrm>
+            <a:off x="2926080" y="4791456"/>
+            <a:ext cx="504749" cy="310896"/>
+          </a:xfrm>
+          <a:prstGeom prst="rect">
+            <a:avLst/>
+          </a:prstGeom>
+          <a:solidFill>
+            <a:schemeClr val="accent1"/>
+          </a:solidFill>
+          <a:ln w="12700">
+            <a:solidFill>
+              <a:schemeClr val="accent1"/>
+            </a:solidFill>
+            <a:prstDash val="solid"/>
+          </a:ln>
+        </p:spPr>
+      </p:sp>
+      <p:sp>
+        <p:nvSpPr>
+          <p:cNvPr id="34" name="Text 31"/>
+          <p:cNvSpPr txBox="1"/>
+          <p:nvPr/>
+        </p:nvSpPr>
+        <p:spPr>
+          <a:xfrm>
+            <a:off x="3522269" y="4663440"/>
+            <a:ext cx="822960" cy="566928"/>
+          </a:xfrm>
+          <a:prstGeom prst="rect">
+            <a:avLst/>
+          </a:prstGeom>
+          <a:noFill/>
+          <a:ln/>
+        </p:spPr>
+        <p:txBody>
+          <a:bodyPr wrap="square" lIns="0" tIns="0" rIns="0" bIns="0" rtlCol="0" anchor="ctr"/>
+          <a:lstStyle/>
+          <a:p>
+            <a:pPr indent="0" marL="0">
+              <a:buNone/>
+            </a:pPr>
+            <a:r>
+              <a:rPr lang="en-US" sz="1300" b="1" dirty="0">
+                <a:solidFill>
+                  <a:schemeClr val="tx2"/>
+                </a:solidFill>
+                <a:latin typeface="Apple SD Gothic Neo" pitchFamily="34" charset="0"/>
+                <a:ea typeface="Apple SD Gothic Neo" pitchFamily="34" charset="-122"/>
+                <a:cs typeface="Apple SD Gothic Neo" pitchFamily="34" charset="-120"/>
+              </a:rPr>
+              <a:t>1.03×</a:t>
+            </a:r>
+            <a:endParaRPr lang="en-US" sz="1300" dirty="0"/>
+          </a:p>
+        </p:txBody>
+      </p:sp>
+      <p:sp>
+        <p:nvSpPr>
+          <p:cNvPr id="35" name="Text 32"/>
+          <p:cNvSpPr txBox="1"/>
+          <p:nvPr/>
+        </p:nvSpPr>
+        <p:spPr>
+          <a:xfrm>
+            <a:off x="548640" y="5230368"/>
+            <a:ext cx="2240280" cy="566928"/>
+          </a:xfrm>
+          <a:prstGeom prst="rect">
+            <a:avLst/>
+          </a:prstGeom>
+          <a:noFill/>
+          <a:ln/>
+        </p:spPr>
+        <p:txBody>
+          <a:bodyPr wrap="square" lIns="0" tIns="0" rIns="0" bIns="0" rtlCol="0" anchor="ctr"/>
+          <a:lstStyle/>
+          <a:p>
+            <a:pPr algn="r" indent="0" marL="0">
+              <a:buNone/>
+            </a:pPr>
+            <a:r>
+              <a:rPr lang="en-US" sz="1400" dirty="0">
+                <a:solidFill>
+                  <a:schemeClr val="tx1"/>
+                </a:solidFill>
+                <a:latin typeface="Apple SD Gothic Neo" pitchFamily="34" charset="0"/>
+                <a:ea typeface="Apple SD Gothic Neo" pitchFamily="34" charset="-122"/>
+                <a:cs typeface="Apple SD Gothic Neo" pitchFamily="34" charset="-120"/>
+              </a:rPr>
+              <a:t>Orbital fixing</a:t>
+            </a:r>
+            <a:endParaRPr lang="en-US" sz="1400" dirty="0"/>
+          </a:p>
+        </p:txBody>
+      </p:sp>
+      <p:sp>
+        <p:nvSpPr>
+          <p:cNvPr id="36" name="bar Orbital fixing"/>
+          <p:cNvSpPr/>
+          <p:nvPr/>
+        </p:nvSpPr>
+        <p:spPr>
+          <a:xfrm>
+            <a:off x="2926080" y="5358384"/>
+            <a:ext cx="3364992" cy="310896"/>
+          </a:xfrm>
+          <a:prstGeom prst="rect">
+            <a:avLst/>
+          </a:prstGeom>
+          <a:solidFill>
+            <a:schemeClr val="accent2"/>
+          </a:solidFill>
+          <a:ln w="12700">
+            <a:solidFill>
+              <a:schemeClr val="accent2"/>
+            </a:solidFill>
+            <a:prstDash val="solid"/>
+          </a:ln>
+        </p:spPr>
+      </p:sp>
+      <p:sp>
+        <p:nvSpPr>
+          <p:cNvPr id="37" name="Text 34"/>
+          <p:cNvSpPr txBox="1"/>
+          <p:nvPr/>
+        </p:nvSpPr>
+        <p:spPr>
+          <a:xfrm>
+            <a:off x="6382512" y="5230368"/>
+            <a:ext cx="822960" cy="566928"/>
+          </a:xfrm>
+          <a:prstGeom prst="rect">
+            <a:avLst/>
+          </a:prstGeom>
+          <a:noFill/>
+          <a:ln/>
+        </p:spPr>
+        <p:txBody>
+          <a:bodyPr wrap="square" lIns="0" tIns="0" rIns="0" bIns="0" rtlCol="0" anchor="ctr"/>
+          <a:lstStyle/>
+          <a:p>
+            <a:pPr indent="0" marL="0">
+              <a:buNone/>
+            </a:pPr>
+            <a:r>
+              <a:rPr lang="en-US" sz="1300" b="1" dirty="0">
+                <a:solidFill>
+                  <a:schemeClr val="tx2"/>
+                </a:solidFill>
+                <a:latin typeface="Apple SD Gothic Neo" pitchFamily="34" charset="0"/>
+                <a:ea typeface="Apple SD Gothic Neo" pitchFamily="34" charset="-122"/>
+                <a:cs typeface="Apple SD Gothic Neo" pitchFamily="34" charset="-120"/>
+              </a:rPr>
+              <a:t>1.20×</a:t>
+            </a:r>
+            <a:endParaRPr lang="en-US" sz="1300" dirty="0"/>
+          </a:p>
+        </p:txBody>
+      </p:sp>
+      <p:sp>
+        <p:nvSpPr>
+          <p:cNvPr id="38" name="read card"/>
           <p:cNvSpPr/>
           <p:nvPr/>
         </p:nvSpPr>
@@ -5361,7 +5883,7 @@
       </p:sp>
       <p:sp>
         <p:nvSpPr>
-          <p:cNvPr id="6" name="Text 2"/>
+          <p:cNvPr id="39" name="Text 36"/>
           <p:cNvSpPr txBox="1"/>
           <p:nvPr/>
         </p:nvSpPr>
@@ -5400,7 +5922,7 @@
       </p:sp>
       <p:sp>
         <p:nvSpPr>
-          <p:cNvPr id="7" name="Text 3"/>
+          <p:cNvPr id="40" name="Text 37"/>
           <p:cNvSpPr txBox="1"/>
           <p:nvPr/>
         </p:nvSpPr>
@@ -5506,7 +6028,7 @@
       </p:sp>
       <p:sp>
         <p:nvSpPr>
-          <p:cNvPr id="8" name="Text 4"/>
+          <p:cNvPr id="41" name="Text 38"/>
           <p:cNvSpPr txBox="1"/>
           <p:nvPr/>
         </p:nvSpPr>
@@ -8278,25 +8800,895 @@
           </a:p>
         </p:txBody>
       </p:sp>
-      <p:graphicFrame>
-        <p:nvGraphicFramePr>
-          <p:cNvPr id="4" name="Chart 0" descr=""/>
-          <p:cNvGraphicFramePr/>
-          <p:nvPr/>
-        </p:nvGraphicFramePr>
-        <p:xfrm>
-          <a:off x="548640" y="1371600"/>
-          <a:ext cx="6949440" cy="4754880"/>
-        </p:xfrm>
-        <a:graphic xmlns:a="http://schemas.openxmlformats.org/drawingml/2006/main">
-          <a:graphicData uri="http://schemas.openxmlformats.org/drawingml/2006/chart">
-            <c:chart xmlns:c="http://schemas.openxmlformats.org/drawingml/2006/chart" r:id="rId1"/>
-          </a:graphicData>
-        </a:graphic>
-      </p:graphicFrame>
-      <p:sp>
-        <p:nvSpPr>
-          <p:cNvPr id="5" name="concl card"/>
+      <p:sp>
+        <p:nvSpPr>
+          <p:cNvPr id="4" name="Text 1"/>
+          <p:cNvSpPr txBox="1"/>
+          <p:nvPr/>
+        </p:nvSpPr>
+        <p:spPr>
+          <a:xfrm>
+            <a:off x="548640" y="1325880"/>
+            <a:ext cx="6949440" cy="365760"/>
+          </a:xfrm>
+          <a:prstGeom prst="rect">
+            <a:avLst/>
+          </a:prstGeom>
+          <a:noFill/>
+          <a:ln/>
+        </p:spPr>
+        <p:txBody>
+          <a:bodyPr wrap="square" lIns="0" tIns="0" rIns="0" bIns="0" rtlCol="0" anchor="ctr"/>
+          <a:lstStyle/>
+          <a:p>
+            <a:pPr indent="0" marL="0">
+              <a:buNone/>
+            </a:pPr>
+            <a:r>
+              <a:rPr lang="en-US" sz="1400" b="1" dirty="0">
+                <a:solidFill>
+                  <a:schemeClr val="tx2"/>
+                </a:solidFill>
+                <a:latin typeface="Apple SD Gothic Neo" pitchFamily="34" charset="0"/>
+                <a:ea typeface="Apple SD Gothic Neo" pitchFamily="34" charset="-122"/>
+                <a:cs typeface="Apple SD Gothic Neo" pitchFamily="34" charset="-120"/>
+              </a:rPr>
+              <a:t>기하평균 풀이 시간 (초)</a:t>
+            </a:r>
+            <a:endParaRPr lang="en-US" sz="1400" dirty="0"/>
+          </a:p>
+        </p:txBody>
+      </p:sp>
+      <p:sp>
+        <p:nvSpPr>
+          <p:cNvPr id="5" name="baseline"/>
+          <p:cNvSpPr/>
+          <p:nvPr/>
+        </p:nvSpPr>
+        <p:spPr>
+          <a:xfrm>
+            <a:off x="640080" y="5440680"/>
+            <a:ext cx="6858000" cy="0"/>
+          </a:xfrm>
+          <a:prstGeom prst="line">
+            <a:avLst/>
+          </a:prstGeom>
+          <a:noFill/>
+          <a:ln w="15875">
+            <a:solidFill>
+              <a:srgbClr val="5B6B7A"/>
+            </a:solidFill>
+            <a:prstDash val="solid"/>
+          </a:ln>
+        </p:spPr>
+      </p:sp>
+      <p:sp>
+        <p:nvSpPr>
+          <p:cNvPr id="6" name="bar random"/>
+          <p:cNvSpPr/>
+          <p:nvPr/>
+        </p:nvSpPr>
+        <p:spPr>
+          <a:xfrm>
+            <a:off x="822960" y="2315883"/>
+            <a:ext cx="566928" cy="3124797"/>
+          </a:xfrm>
+          <a:prstGeom prst="rect">
+            <a:avLst/>
+          </a:prstGeom>
+          <a:solidFill>
+            <a:schemeClr val="accent1"/>
+          </a:solidFill>
+          <a:ln w="12700">
+            <a:solidFill>
+              <a:schemeClr val="accent1"/>
+            </a:solidFill>
+            <a:prstDash val="solid"/>
+          </a:ln>
+        </p:spPr>
+      </p:sp>
+      <p:sp>
+        <p:nvSpPr>
+          <p:cNvPr id="7" name="Text 4"/>
+          <p:cNvSpPr txBox="1"/>
+          <p:nvPr/>
+        </p:nvSpPr>
+        <p:spPr>
+          <a:xfrm>
+            <a:off x="640080" y="2023275"/>
+            <a:ext cx="932688" cy="274320"/>
+          </a:xfrm>
+          <a:prstGeom prst="rect">
+            <a:avLst/>
+          </a:prstGeom>
+          <a:noFill/>
+          <a:ln/>
+        </p:spPr>
+        <p:txBody>
+          <a:bodyPr wrap="square" lIns="0" tIns="0" rIns="0" bIns="0" rtlCol="0" anchor="ctr"/>
+          <a:lstStyle/>
+          <a:p>
+            <a:pPr algn="ctr" indent="0" marL="0">
+              <a:buNone/>
+            </a:pPr>
+            <a:r>
+              <a:rPr lang="en-US" sz="1200" b="1" dirty="0">
+                <a:solidFill>
+                  <a:schemeClr val="tx2"/>
+                </a:solidFill>
+                <a:latin typeface="Apple SD Gothic Neo" pitchFamily="34" charset="0"/>
+                <a:ea typeface="Apple SD Gothic Neo" pitchFamily="34" charset="-122"/>
+                <a:cs typeface="Apple SD Gothic Neo" pitchFamily="34" charset="-120"/>
+              </a:rPr>
+              <a:t>924</a:t>
+            </a:r>
+            <a:endParaRPr lang="en-US" sz="1200" dirty="0"/>
+          </a:p>
+        </p:txBody>
+      </p:sp>
+      <p:sp>
+        <p:nvSpPr>
+          <p:cNvPr id="8" name="Text 5"/>
+          <p:cNvSpPr txBox="1"/>
+          <p:nvPr/>
+        </p:nvSpPr>
+        <p:spPr>
+          <a:xfrm>
+            <a:off x="667512" y="5495544"/>
+            <a:ext cx="877824" cy="502920"/>
+          </a:xfrm>
+          <a:prstGeom prst="rect">
+            <a:avLst/>
+          </a:prstGeom>
+          <a:noFill/>
+          <a:ln/>
+        </p:spPr>
+        <p:txBody>
+          <a:bodyPr wrap="square" lIns="0" tIns="0" rIns="0" bIns="0" rtlCol="0" anchor="t"/>
+          <a:lstStyle/>
+          <a:p>
+            <a:pPr algn="ctr" indent="0" marL="0">
+              <a:buNone/>
+            </a:pPr>
+            <a:r>
+              <a:rPr lang="en-US" sz="1100" dirty="0">
+                <a:solidFill>
+                  <a:schemeClr val="tx1"/>
+                </a:solidFill>
+                <a:latin typeface="Apple SD Gothic Neo" pitchFamily="34" charset="0"/>
+                <a:ea typeface="Apple SD Gothic Neo" pitchFamily="34" charset="-122"/>
+                <a:cs typeface="Apple SD Gothic Neo" pitchFamily="34" charset="-120"/>
+              </a:rPr>
+              <a:t>random</a:t>
+            </a:r>
+            <a:endParaRPr lang="en-US" sz="1100" dirty="0"/>
+          </a:p>
+        </p:txBody>
+      </p:sp>
+      <p:sp>
+        <p:nvSpPr>
+          <p:cNvPr id="9" name="bar pseudocost"/>
+          <p:cNvSpPr/>
+          <p:nvPr/>
+        </p:nvSpPr>
+        <p:spPr>
+          <a:xfrm>
+            <a:off x="1645920" y="4481858"/>
+            <a:ext cx="566928" cy="958822"/>
+          </a:xfrm>
+          <a:prstGeom prst="rect">
+            <a:avLst/>
+          </a:prstGeom>
+          <a:solidFill>
+            <a:schemeClr val="accent1"/>
+          </a:solidFill>
+          <a:ln w="12700">
+            <a:solidFill>
+              <a:schemeClr val="accent1"/>
+            </a:solidFill>
+            <a:prstDash val="solid"/>
+          </a:ln>
+        </p:spPr>
+      </p:sp>
+      <p:sp>
+        <p:nvSpPr>
+          <p:cNvPr id="10" name="Text 7"/>
+          <p:cNvSpPr txBox="1"/>
+          <p:nvPr/>
+        </p:nvSpPr>
+        <p:spPr>
+          <a:xfrm>
+            <a:off x="1463040" y="4189250"/>
+            <a:ext cx="932688" cy="274320"/>
+          </a:xfrm>
+          <a:prstGeom prst="rect">
+            <a:avLst/>
+          </a:prstGeom>
+          <a:noFill/>
+          <a:ln/>
+        </p:spPr>
+        <p:txBody>
+          <a:bodyPr wrap="square" lIns="0" tIns="0" rIns="0" bIns="0" rtlCol="0" anchor="ctr"/>
+          <a:lstStyle/>
+          <a:p>
+            <a:pPr algn="ctr" indent="0" marL="0">
+              <a:buNone/>
+            </a:pPr>
+            <a:r>
+              <a:rPr lang="en-US" sz="1200" b="1" dirty="0">
+                <a:solidFill>
+                  <a:schemeClr val="tx2"/>
+                </a:solidFill>
+                <a:latin typeface="Apple SD Gothic Neo" pitchFamily="34" charset="0"/>
+                <a:ea typeface="Apple SD Gothic Neo" pitchFamily="34" charset="-122"/>
+                <a:cs typeface="Apple SD Gothic Neo" pitchFamily="34" charset="-120"/>
+              </a:rPr>
+              <a:t>283</a:t>
+            </a:r>
+            <a:endParaRPr lang="en-US" sz="1200" dirty="0"/>
+          </a:p>
+        </p:txBody>
+      </p:sp>
+      <p:sp>
+        <p:nvSpPr>
+          <p:cNvPr id="11" name="Text 8"/>
+          <p:cNvSpPr txBox="1"/>
+          <p:nvPr/>
+        </p:nvSpPr>
+        <p:spPr>
+          <a:xfrm>
+            <a:off x="1490472" y="5495544"/>
+            <a:ext cx="877824" cy="502920"/>
+          </a:xfrm>
+          <a:prstGeom prst="rect">
+            <a:avLst/>
+          </a:prstGeom>
+          <a:noFill/>
+          <a:ln/>
+        </p:spPr>
+        <p:txBody>
+          <a:bodyPr wrap="square" lIns="0" tIns="0" rIns="0" bIns="0" rtlCol="0" anchor="t"/>
+          <a:lstStyle/>
+          <a:p>
+            <a:pPr algn="ctr" indent="0" marL="0">
+              <a:buNone/>
+            </a:pPr>
+            <a:r>
+              <a:rPr lang="en-US" sz="1100" dirty="0">
+                <a:solidFill>
+                  <a:schemeClr val="tx1"/>
+                </a:solidFill>
+                <a:latin typeface="Apple SD Gothic Neo" pitchFamily="34" charset="0"/>
+                <a:ea typeface="Apple SD Gothic Neo" pitchFamily="34" charset="-122"/>
+                <a:cs typeface="Apple SD Gothic Neo" pitchFamily="34" charset="-120"/>
+              </a:rPr>
+              <a:t>pseudocost</a:t>
+            </a:r>
+            <a:endParaRPr lang="en-US" sz="1100" dirty="0"/>
+          </a:p>
+        </p:txBody>
+      </p:sp>
+      <p:sp>
+        <p:nvSpPr>
+          <p:cNvPr id="12" name="bar full strong"/>
+          <p:cNvSpPr/>
+          <p:nvPr/>
+        </p:nvSpPr>
+        <p:spPr>
+          <a:xfrm>
+            <a:off x="2468880" y="3734154"/>
+            <a:ext cx="566928" cy="1706526"/>
+          </a:xfrm>
+          <a:prstGeom prst="rect">
+            <a:avLst/>
+          </a:prstGeom>
+          <a:solidFill>
+            <a:schemeClr val="accent1"/>
+          </a:solidFill>
+          <a:ln w="12700">
+            <a:solidFill>
+              <a:schemeClr val="accent1"/>
+            </a:solidFill>
+            <a:prstDash val="solid"/>
+          </a:ln>
+        </p:spPr>
+      </p:sp>
+      <p:sp>
+        <p:nvSpPr>
+          <p:cNvPr id="13" name="Text 10"/>
+          <p:cNvSpPr txBox="1"/>
+          <p:nvPr/>
+        </p:nvSpPr>
+        <p:spPr>
+          <a:xfrm>
+            <a:off x="2286000" y="3441546"/>
+            <a:ext cx="932688" cy="274320"/>
+          </a:xfrm>
+          <a:prstGeom prst="rect">
+            <a:avLst/>
+          </a:prstGeom>
+          <a:noFill/>
+          <a:ln/>
+        </p:spPr>
+        <p:txBody>
+          <a:bodyPr wrap="square" lIns="0" tIns="0" rIns="0" bIns="0" rtlCol="0" anchor="ctr"/>
+          <a:lstStyle/>
+          <a:p>
+            <a:pPr algn="ctr" indent="0" marL="0">
+              <a:buNone/>
+            </a:pPr>
+            <a:r>
+              <a:rPr lang="en-US" sz="1200" b="1" dirty="0">
+                <a:solidFill>
+                  <a:schemeClr val="tx2"/>
+                </a:solidFill>
+                <a:latin typeface="Apple SD Gothic Neo" pitchFamily="34" charset="0"/>
+                <a:ea typeface="Apple SD Gothic Neo" pitchFamily="34" charset="-122"/>
+                <a:cs typeface="Apple SD Gothic Neo" pitchFamily="34" charset="-120"/>
+              </a:rPr>
+              <a:t>504</a:t>
+            </a:r>
+            <a:endParaRPr lang="en-US" sz="1200" dirty="0"/>
+          </a:p>
+        </p:txBody>
+      </p:sp>
+      <p:sp>
+        <p:nvSpPr>
+          <p:cNvPr id="14" name="Text 11"/>
+          <p:cNvSpPr txBox="1"/>
+          <p:nvPr/>
+        </p:nvSpPr>
+        <p:spPr>
+          <a:xfrm>
+            <a:off x="2313432" y="5495544"/>
+            <a:ext cx="877824" cy="502920"/>
+          </a:xfrm>
+          <a:prstGeom prst="rect">
+            <a:avLst/>
+          </a:prstGeom>
+          <a:noFill/>
+          <a:ln/>
+        </p:spPr>
+        <p:txBody>
+          <a:bodyPr wrap="square" lIns="0" tIns="0" rIns="0" bIns="0" rtlCol="0" anchor="t"/>
+          <a:lstStyle/>
+          <a:p>
+            <a:pPr algn="ctr" indent="0" marL="0">
+              <a:buNone/>
+            </a:pPr>
+            <a:r>
+              <a:rPr lang="en-US" sz="1100" dirty="0">
+                <a:solidFill>
+                  <a:schemeClr val="tx1"/>
+                </a:solidFill>
+                <a:latin typeface="Apple SD Gothic Neo" pitchFamily="34" charset="0"/>
+                <a:ea typeface="Apple SD Gothic Neo" pitchFamily="34" charset="-122"/>
+                <a:cs typeface="Apple SD Gothic Neo" pitchFamily="34" charset="-120"/>
+              </a:rPr>
+              <a:t>full strong</a:t>
+            </a:r>
+            <a:endParaRPr lang="en-US" sz="1100" dirty="0"/>
+          </a:p>
+        </p:txBody>
+      </p:sp>
+      <p:sp>
+        <p:nvSpPr>
+          <p:cNvPr id="15" name="bar strong/ps(10)"/>
+          <p:cNvSpPr/>
+          <p:nvPr/>
+        </p:nvSpPr>
+        <p:spPr>
+          <a:xfrm>
+            <a:off x="3291840" y="4663879"/>
+            <a:ext cx="566928" cy="776801"/>
+          </a:xfrm>
+          <a:prstGeom prst="rect">
+            <a:avLst/>
+          </a:prstGeom>
+          <a:solidFill>
+            <a:schemeClr val="accent1"/>
+          </a:solidFill>
+          <a:ln w="12700">
+            <a:solidFill>
+              <a:schemeClr val="accent1"/>
+            </a:solidFill>
+            <a:prstDash val="solid"/>
+          </a:ln>
+        </p:spPr>
+      </p:sp>
+      <p:sp>
+        <p:nvSpPr>
+          <p:cNvPr id="16" name="Text 13"/>
+          <p:cNvSpPr txBox="1"/>
+          <p:nvPr/>
+        </p:nvSpPr>
+        <p:spPr>
+          <a:xfrm>
+            <a:off x="3108960" y="4371271"/>
+            <a:ext cx="932688" cy="274320"/>
+          </a:xfrm>
+          <a:prstGeom prst="rect">
+            <a:avLst/>
+          </a:prstGeom>
+          <a:noFill/>
+          <a:ln/>
+        </p:spPr>
+        <p:txBody>
+          <a:bodyPr wrap="square" lIns="0" tIns="0" rIns="0" bIns="0" rtlCol="0" anchor="ctr"/>
+          <a:lstStyle/>
+          <a:p>
+            <a:pPr algn="ctr" indent="0" marL="0">
+              <a:buNone/>
+            </a:pPr>
+            <a:r>
+              <a:rPr lang="en-US" sz="1200" b="1" dirty="0">
+                <a:solidFill>
+                  <a:schemeClr val="tx2"/>
+                </a:solidFill>
+                <a:latin typeface="Apple SD Gothic Neo" pitchFamily="34" charset="0"/>
+                <a:ea typeface="Apple SD Gothic Neo" pitchFamily="34" charset="-122"/>
+                <a:cs typeface="Apple SD Gothic Neo" pitchFamily="34" charset="-120"/>
+              </a:rPr>
+              <a:t>230</a:t>
+            </a:r>
+            <a:endParaRPr lang="en-US" sz="1200" dirty="0"/>
+          </a:p>
+        </p:txBody>
+      </p:sp>
+      <p:sp>
+        <p:nvSpPr>
+          <p:cNvPr id="17" name="Text 14"/>
+          <p:cNvSpPr txBox="1"/>
+          <p:nvPr/>
+        </p:nvSpPr>
+        <p:spPr>
+          <a:xfrm>
+            <a:off x="3136392" y="5495544"/>
+            <a:ext cx="877824" cy="502920"/>
+          </a:xfrm>
+          <a:prstGeom prst="rect">
+            <a:avLst/>
+          </a:prstGeom>
+          <a:noFill/>
+          <a:ln/>
+        </p:spPr>
+        <p:txBody>
+          <a:bodyPr wrap="square" lIns="0" tIns="0" rIns="0" bIns="0" rtlCol="0" anchor="t"/>
+          <a:lstStyle/>
+          <a:p>
+            <a:pPr algn="ctr" indent="0" marL="0">
+              <a:buNone/>
+            </a:pPr>
+            <a:r>
+              <a:rPr lang="en-US" sz="1100" dirty="0">
+                <a:solidFill>
+                  <a:schemeClr val="tx1"/>
+                </a:solidFill>
+                <a:latin typeface="Apple SD Gothic Neo" pitchFamily="34" charset="0"/>
+                <a:ea typeface="Apple SD Gothic Neo" pitchFamily="34" charset="-122"/>
+                <a:cs typeface="Apple SD Gothic Neo" pitchFamily="34" charset="-120"/>
+              </a:rPr>
+              <a:t>strong/ps(10)</a:t>
+            </a:r>
+            <a:endParaRPr lang="en-US" sz="1100" dirty="0"/>
+          </a:p>
+        </p:txBody>
+      </p:sp>
+      <p:sp>
+        <p:nvSpPr>
+          <p:cNvPr id="18" name="bar reliab.(1)"/>
+          <p:cNvSpPr/>
+          <p:nvPr/>
+        </p:nvSpPr>
+        <p:spPr>
+          <a:xfrm>
+            <a:off x="4114800" y="4708538"/>
+            <a:ext cx="566928" cy="732142"/>
+          </a:xfrm>
+          <a:prstGeom prst="rect">
+            <a:avLst/>
+          </a:prstGeom>
+          <a:solidFill>
+            <a:schemeClr val="accent1"/>
+          </a:solidFill>
+          <a:ln w="12700">
+            <a:solidFill>
+              <a:schemeClr val="accent1"/>
+            </a:solidFill>
+            <a:prstDash val="solid"/>
+          </a:ln>
+        </p:spPr>
+      </p:sp>
+      <p:sp>
+        <p:nvSpPr>
+          <p:cNvPr id="19" name="Text 16"/>
+          <p:cNvSpPr txBox="1"/>
+          <p:nvPr/>
+        </p:nvSpPr>
+        <p:spPr>
+          <a:xfrm>
+            <a:off x="3931920" y="4415930"/>
+            <a:ext cx="932688" cy="274320"/>
+          </a:xfrm>
+          <a:prstGeom prst="rect">
+            <a:avLst/>
+          </a:prstGeom>
+          <a:noFill/>
+          <a:ln/>
+        </p:spPr>
+        <p:txBody>
+          <a:bodyPr wrap="square" lIns="0" tIns="0" rIns="0" bIns="0" rtlCol="0" anchor="ctr"/>
+          <a:lstStyle/>
+          <a:p>
+            <a:pPr algn="ctr" indent="0" marL="0">
+              <a:buNone/>
+            </a:pPr>
+            <a:r>
+              <a:rPr lang="en-US" sz="1200" b="1" dirty="0">
+                <a:solidFill>
+                  <a:schemeClr val="tx2"/>
+                </a:solidFill>
+                <a:latin typeface="Apple SD Gothic Neo" pitchFamily="34" charset="0"/>
+                <a:ea typeface="Apple SD Gothic Neo" pitchFamily="34" charset="-122"/>
+                <a:cs typeface="Apple SD Gothic Neo" pitchFamily="34" charset="-120"/>
+              </a:rPr>
+              <a:t>216</a:t>
+            </a:r>
+            <a:endParaRPr lang="en-US" sz="1200" dirty="0"/>
+          </a:p>
+        </p:txBody>
+      </p:sp>
+      <p:sp>
+        <p:nvSpPr>
+          <p:cNvPr id="20" name="Text 17"/>
+          <p:cNvSpPr txBox="1"/>
+          <p:nvPr/>
+        </p:nvSpPr>
+        <p:spPr>
+          <a:xfrm>
+            <a:off x="3959352" y="5495544"/>
+            <a:ext cx="877824" cy="502920"/>
+          </a:xfrm>
+          <a:prstGeom prst="rect">
+            <a:avLst/>
+          </a:prstGeom>
+          <a:noFill/>
+          <a:ln/>
+        </p:spPr>
+        <p:txBody>
+          <a:bodyPr wrap="square" lIns="0" tIns="0" rIns="0" bIns="0" rtlCol="0" anchor="t"/>
+          <a:lstStyle/>
+          <a:p>
+            <a:pPr algn="ctr" indent="0" marL="0">
+              <a:buNone/>
+            </a:pPr>
+            <a:r>
+              <a:rPr lang="en-US" sz="1100" dirty="0">
+                <a:solidFill>
+                  <a:schemeClr val="tx1"/>
+                </a:solidFill>
+                <a:latin typeface="Apple SD Gothic Neo" pitchFamily="34" charset="0"/>
+                <a:ea typeface="Apple SD Gothic Neo" pitchFamily="34" charset="-122"/>
+                <a:cs typeface="Apple SD Gothic Neo" pitchFamily="34" charset="-120"/>
+              </a:rPr>
+              <a:t>reliab.(1)</a:t>
+            </a:r>
+            <a:endParaRPr lang="en-US" sz="1100" dirty="0"/>
+          </a:p>
+        </p:txBody>
+      </p:sp>
+      <p:sp>
+        <p:nvSpPr>
+          <p:cNvPr id="21" name="bar reliab.(4)"/>
+          <p:cNvSpPr/>
+          <p:nvPr/>
+        </p:nvSpPr>
+        <p:spPr>
+          <a:xfrm>
+            <a:off x="4937760" y="4837780"/>
+            <a:ext cx="566928" cy="602900"/>
+          </a:xfrm>
+          <a:prstGeom prst="rect">
+            <a:avLst/>
+          </a:prstGeom>
+          <a:solidFill>
+            <a:schemeClr val="accent1"/>
+          </a:solidFill>
+          <a:ln w="12700">
+            <a:solidFill>
+              <a:schemeClr val="accent1"/>
+            </a:solidFill>
+            <a:prstDash val="solid"/>
+          </a:ln>
+        </p:spPr>
+      </p:sp>
+      <p:sp>
+        <p:nvSpPr>
+          <p:cNvPr id="22" name="Text 19"/>
+          <p:cNvSpPr txBox="1"/>
+          <p:nvPr/>
+        </p:nvSpPr>
+        <p:spPr>
+          <a:xfrm>
+            <a:off x="4754880" y="4545172"/>
+            <a:ext cx="932688" cy="274320"/>
+          </a:xfrm>
+          <a:prstGeom prst="rect">
+            <a:avLst/>
+          </a:prstGeom>
+          <a:noFill/>
+          <a:ln/>
+        </p:spPr>
+        <p:txBody>
+          <a:bodyPr wrap="square" lIns="0" tIns="0" rIns="0" bIns="0" rtlCol="0" anchor="ctr"/>
+          <a:lstStyle/>
+          <a:p>
+            <a:pPr algn="ctr" indent="0" marL="0">
+              <a:buNone/>
+            </a:pPr>
+            <a:r>
+              <a:rPr lang="en-US" sz="1200" b="1" dirty="0">
+                <a:solidFill>
+                  <a:schemeClr val="tx2"/>
+                </a:solidFill>
+                <a:latin typeface="Apple SD Gothic Neo" pitchFamily="34" charset="0"/>
+                <a:ea typeface="Apple SD Gothic Neo" pitchFamily="34" charset="-122"/>
+                <a:cs typeface="Apple SD Gothic Neo" pitchFamily="34" charset="-120"/>
+              </a:rPr>
+              <a:t>178</a:t>
+            </a:r>
+            <a:endParaRPr lang="en-US" sz="1200" dirty="0"/>
+          </a:p>
+        </p:txBody>
+      </p:sp>
+      <p:sp>
+        <p:nvSpPr>
+          <p:cNvPr id="23" name="Text 20"/>
+          <p:cNvSpPr txBox="1"/>
+          <p:nvPr/>
+        </p:nvSpPr>
+        <p:spPr>
+          <a:xfrm>
+            <a:off x="4782312" y="5495544"/>
+            <a:ext cx="877824" cy="502920"/>
+          </a:xfrm>
+          <a:prstGeom prst="rect">
+            <a:avLst/>
+          </a:prstGeom>
+          <a:noFill/>
+          <a:ln/>
+        </p:spPr>
+        <p:txBody>
+          <a:bodyPr wrap="square" lIns="0" tIns="0" rIns="0" bIns="0" rtlCol="0" anchor="t"/>
+          <a:lstStyle/>
+          <a:p>
+            <a:pPr algn="ctr" indent="0" marL="0">
+              <a:buNone/>
+            </a:pPr>
+            <a:r>
+              <a:rPr lang="en-US" sz="1100" dirty="0">
+                <a:solidFill>
+                  <a:schemeClr val="tx1"/>
+                </a:solidFill>
+                <a:latin typeface="Apple SD Gothic Neo" pitchFamily="34" charset="0"/>
+                <a:ea typeface="Apple SD Gothic Neo" pitchFamily="34" charset="-122"/>
+                <a:cs typeface="Apple SD Gothic Neo" pitchFamily="34" charset="-120"/>
+              </a:rPr>
+              <a:t>reliab.(4)</a:t>
+            </a:r>
+            <a:endParaRPr lang="en-US" sz="1100" dirty="0"/>
+          </a:p>
+        </p:txBody>
+      </p:sp>
+      <p:sp>
+        <p:nvSpPr>
+          <p:cNvPr id="24" name="bar reliab.(8)"/>
+          <p:cNvSpPr/>
+          <p:nvPr/>
+        </p:nvSpPr>
+        <p:spPr>
+          <a:xfrm>
+            <a:off x="5760720" y="4863831"/>
+            <a:ext cx="566928" cy="576849"/>
+          </a:xfrm>
+          <a:prstGeom prst="rect">
+            <a:avLst/>
+          </a:prstGeom>
+          <a:solidFill>
+            <a:schemeClr val="accent2"/>
+          </a:solidFill>
+          <a:ln w="12700">
+            <a:solidFill>
+              <a:schemeClr val="accent2"/>
+            </a:solidFill>
+            <a:prstDash val="solid"/>
+          </a:ln>
+        </p:spPr>
+      </p:sp>
+      <p:sp>
+        <p:nvSpPr>
+          <p:cNvPr id="25" name="Text 22"/>
+          <p:cNvSpPr txBox="1"/>
+          <p:nvPr/>
+        </p:nvSpPr>
+        <p:spPr>
+          <a:xfrm>
+            <a:off x="5577840" y="4571223"/>
+            <a:ext cx="932688" cy="274320"/>
+          </a:xfrm>
+          <a:prstGeom prst="rect">
+            <a:avLst/>
+          </a:prstGeom>
+          <a:noFill/>
+          <a:ln/>
+        </p:spPr>
+        <p:txBody>
+          <a:bodyPr wrap="square" lIns="0" tIns="0" rIns="0" bIns="0" rtlCol="0" anchor="ctr"/>
+          <a:lstStyle/>
+          <a:p>
+            <a:pPr algn="ctr" indent="0" marL="0">
+              <a:buNone/>
+            </a:pPr>
+            <a:r>
+              <a:rPr lang="en-US" sz="1200" b="1" dirty="0">
+                <a:solidFill>
+                  <a:schemeClr val="tx2"/>
+                </a:solidFill>
+                <a:latin typeface="Apple SD Gothic Neo" pitchFamily="34" charset="0"/>
+                <a:ea typeface="Apple SD Gothic Neo" pitchFamily="34" charset="-122"/>
+                <a:cs typeface="Apple SD Gothic Neo" pitchFamily="34" charset="-120"/>
+              </a:rPr>
+              <a:t>171</a:t>
+            </a:r>
+            <a:endParaRPr lang="en-US" sz="1200" dirty="0"/>
+          </a:p>
+        </p:txBody>
+      </p:sp>
+      <p:sp>
+        <p:nvSpPr>
+          <p:cNvPr id="26" name="Text 23"/>
+          <p:cNvSpPr txBox="1"/>
+          <p:nvPr/>
+        </p:nvSpPr>
+        <p:spPr>
+          <a:xfrm>
+            <a:off x="5605272" y="5495544"/>
+            <a:ext cx="877824" cy="502920"/>
+          </a:xfrm>
+          <a:prstGeom prst="rect">
+            <a:avLst/>
+          </a:prstGeom>
+          <a:noFill/>
+          <a:ln/>
+        </p:spPr>
+        <p:txBody>
+          <a:bodyPr wrap="square" lIns="0" tIns="0" rIns="0" bIns="0" rtlCol="0" anchor="t"/>
+          <a:lstStyle/>
+          <a:p>
+            <a:pPr algn="ctr" indent="0" marL="0">
+              <a:buNone/>
+            </a:pPr>
+            <a:r>
+              <a:rPr lang="en-US" sz="1100" dirty="0">
+                <a:solidFill>
+                  <a:schemeClr val="tx1"/>
+                </a:solidFill>
+                <a:latin typeface="Apple SD Gothic Neo" pitchFamily="34" charset="0"/>
+                <a:ea typeface="Apple SD Gothic Neo" pitchFamily="34" charset="-122"/>
+                <a:cs typeface="Apple SD Gothic Neo" pitchFamily="34" charset="-120"/>
+              </a:rPr>
+              <a:t>reliab.(8)</a:t>
+            </a:r>
+            <a:endParaRPr lang="en-US" sz="1100" dirty="0"/>
+          </a:p>
+        </p:txBody>
+      </p:sp>
+      <p:sp>
+        <p:nvSpPr>
+          <p:cNvPr id="27" name="bar reliab.(16)"/>
+          <p:cNvSpPr/>
+          <p:nvPr/>
+        </p:nvSpPr>
+        <p:spPr>
+          <a:xfrm>
+            <a:off x="6583680" y="4835073"/>
+            <a:ext cx="566928" cy="605607"/>
+          </a:xfrm>
+          <a:prstGeom prst="rect">
+            <a:avLst/>
+          </a:prstGeom>
+          <a:solidFill>
+            <a:schemeClr val="accent1"/>
+          </a:solidFill>
+          <a:ln w="12700">
+            <a:solidFill>
+              <a:schemeClr val="accent1"/>
+            </a:solidFill>
+            <a:prstDash val="solid"/>
+          </a:ln>
+        </p:spPr>
+      </p:sp>
+      <p:sp>
+        <p:nvSpPr>
+          <p:cNvPr id="28" name="Text 25"/>
+          <p:cNvSpPr txBox="1"/>
+          <p:nvPr/>
+        </p:nvSpPr>
+        <p:spPr>
+          <a:xfrm>
+            <a:off x="6400800" y="4542465"/>
+            <a:ext cx="932688" cy="274320"/>
+          </a:xfrm>
+          <a:prstGeom prst="rect">
+            <a:avLst/>
+          </a:prstGeom>
+          <a:noFill/>
+          <a:ln/>
+        </p:spPr>
+        <p:txBody>
+          <a:bodyPr wrap="square" lIns="0" tIns="0" rIns="0" bIns="0" rtlCol="0" anchor="ctr"/>
+          <a:lstStyle/>
+          <a:p>
+            <a:pPr algn="ctr" indent="0" marL="0">
+              <a:buNone/>
+            </a:pPr>
+            <a:r>
+              <a:rPr lang="en-US" sz="1200" b="1" dirty="0">
+                <a:solidFill>
+                  <a:schemeClr val="tx2"/>
+                </a:solidFill>
+                <a:latin typeface="Apple SD Gothic Neo" pitchFamily="34" charset="0"/>
+                <a:ea typeface="Apple SD Gothic Neo" pitchFamily="34" charset="-122"/>
+                <a:cs typeface="Apple SD Gothic Neo" pitchFamily="34" charset="-120"/>
+              </a:rPr>
+              <a:t>179</a:t>
+            </a:r>
+            <a:endParaRPr lang="en-US" sz="1200" dirty="0"/>
+          </a:p>
+        </p:txBody>
+      </p:sp>
+      <p:sp>
+        <p:nvSpPr>
+          <p:cNvPr id="29" name="Text 26"/>
+          <p:cNvSpPr txBox="1"/>
+          <p:nvPr/>
+        </p:nvSpPr>
+        <p:spPr>
+          <a:xfrm>
+            <a:off x="6428232" y="5495544"/>
+            <a:ext cx="877824" cy="502920"/>
+          </a:xfrm>
+          <a:prstGeom prst="rect">
+            <a:avLst/>
+          </a:prstGeom>
+          <a:noFill/>
+          <a:ln/>
+        </p:spPr>
+        <p:txBody>
+          <a:bodyPr wrap="square" lIns="0" tIns="0" rIns="0" bIns="0" rtlCol="0" anchor="t"/>
+          <a:lstStyle/>
+          <a:p>
+            <a:pPr algn="ctr" indent="0" marL="0">
+              <a:buNone/>
+            </a:pPr>
+            <a:r>
+              <a:rPr lang="en-US" sz="1100" dirty="0">
+                <a:solidFill>
+                  <a:schemeClr val="tx1"/>
+                </a:solidFill>
+                <a:latin typeface="Apple SD Gothic Neo" pitchFamily="34" charset="0"/>
+                <a:ea typeface="Apple SD Gothic Neo" pitchFamily="34" charset="-122"/>
+                <a:cs typeface="Apple SD Gothic Neo" pitchFamily="34" charset="-120"/>
+              </a:rPr>
+              <a:t>reliab.(16)</a:t>
+            </a:r>
+            <a:endParaRPr lang="en-US" sz="1100" dirty="0"/>
+          </a:p>
+        </p:txBody>
+      </p:sp>
+      <p:sp>
+        <p:nvSpPr>
+          <p:cNvPr id="30" name="concl card"/>
           <p:cNvSpPr/>
           <p:nvPr/>
         </p:nvSpPr>
@@ -8323,7 +9715,7 @@
       </p:sp>
       <p:sp>
         <p:nvSpPr>
-          <p:cNvPr id="6" name="Text 2"/>
+          <p:cNvPr id="31" name="Text 28"/>
           <p:cNvSpPr txBox="1"/>
           <p:nvPr/>
         </p:nvSpPr>
@@ -8362,7 +9754,7 @@
       </p:sp>
       <p:sp>
         <p:nvSpPr>
-          <p:cNvPr id="7" name="Text 3"/>
+          <p:cNvPr id="32" name="Text 29"/>
           <p:cNvSpPr txBox="1"/>
           <p:nvPr/>
         </p:nvSpPr>
@@ -8468,7 +9860,7 @@
       </p:sp>
       <p:sp>
         <p:nvSpPr>
-          <p:cNvPr id="8" name="Text 4"/>
+          <p:cNvPr id="33" name="Text 30"/>
           <p:cNvSpPr txBox="1"/>
           <p:nvPr/>
         </p:nvSpPr>

</xml_diff>

<commit_message>
content: rewrite per-topic MILP decks as detailed study guides and add pptx builder
- add tutor-style decks (presolve, branching, conflict, symmetry, decomposition)
  with worked examples, common pitfalls and check questions
- add Psi, conflict and symmetry-detection slides to the expanded deck
- branching post: note that eta_rel 4-8 is empirical, summarize Hendel (2015)
- add tools/pptx builder (lib, template, preview script, deck scripts)

Co-Authored-By: Claude Sonnet 5.5 <noreply@anthropic.com>
Claude-Session: https://claude.ai/code/session_01LPVKYyoH68YJk5yyhnP17M
</commit_message>
<xml_diff>
--- a/public/papers/milp-acceleration-v2.pptx
+++ b/public/papers/milp-acceleration-v2.pptx
@@ -20,10 +20,13 @@
     <p:sldId id="268" r:id="rId14"/>
     <p:sldId id="269" r:id="rId15"/>
     <p:sldId id="270" r:id="rId16"/>
+    <p:sldId id="282" r:id="rId33"/>
     <p:sldId id="271" r:id="rId17"/>
+    <p:sldId id="283" r:id="rId34"/>
     <p:sldId id="272" r:id="rId18"/>
     <p:sldId id="273" r:id="rId19"/>
     <p:sldId id="274" r:id="rId20"/>
+    <p:sldId id="284" r:id="rId35"/>
     <p:sldId id="275" r:id="rId21"/>
     <p:sldId id="276" r:id="rId22"/>
     <p:sldId id="277" r:id="rId23"/>
@@ -8746,6 +8749,574 @@
 </file>
 
 <file path=ppt/slides/slide16.xml><?xml version="1.0" encoding="utf-8"?>
+<p:sld xmlns:a="http://schemas.openxmlformats.org/drawingml/2006/main" xmlns:p="http://schemas.openxmlformats.org/presentationml/2006/main" xmlns:r="http://schemas.openxmlformats.org/officeDocument/2006/relationships">
+  <p:cSld>
+    <p:spTree>
+      <p:nvGrpSpPr>
+        <p:cNvPr id="1" name=""/>
+        <p:cNvGrpSpPr/>
+        <p:nvPr/>
+      </p:nvGrpSpPr>
+      <p:grpSpPr/>
+      <p:sp>
+        <p:nvSpPr>
+          <p:cNvPr id="2" name="Text 0"/>
+          <p:cNvSpPr/>
+          <p:nvPr>
+            <p:ph idx="100" type="title" hasCustomPrompt="1"/>
+          </p:nvPr>
+        </p:nvSpPr>
+        <p:spPr>
+          <a:xfrm>
+            <a:off x="548640" y="320040"/>
+            <a:ext cx="11064240" cy="822960"/>
+          </a:xfrm>
+          <a:prstGeom prst="rect">
+            <a:avLst/>
+          </a:prstGeom>
+          <a:noFill/>
+          <a:ln/>
+        </p:spPr>
+        <p:txBody>
+          <a:bodyPr wrap="square" rtlCol="0" anchor="ctr"/>
+          <a:lstStyle/>
+          <a:p>
+            <a:pPr indent="0" marL="0">
+              <a:buNone/>
+            </a:pPr>
+            <a:r>
+              <a:rPr lang="en-US" sz="3000" b="1" dirty="0">
+                <a:solidFill>
+                  <a:schemeClr val="tx2"/>
+                </a:solidFill>
+              </a:rPr>
+              <a:t>Pseudocost Ψ 는 무엇인가</a:t>
+            </a:r>
+            <a:endParaRPr lang="en-US" sz="3000" dirty="0"/>
+          </a:p>
+        </p:txBody>
+      </p:sp>
+      <p:sp>
+        <p:nvSpPr>
+          <p:cNvPr id="4" name="formula card"/>
+          <p:cNvSpPr/>
+          <p:nvPr/>
+        </p:nvSpPr>
+        <p:spPr>
+          <a:xfrm>
+            <a:off x="548640" y="1371600"/>
+            <a:ext cx="6675120" cy="4846320"/>
+          </a:xfrm>
+          <a:prstGeom prst="roundRect">
+            <a:avLst>
+              <a:gd name="adj" fmla="val 2264"/>
+            </a:avLst>
+          </a:prstGeom>
+          <a:solidFill>
+            <a:schemeClr val="bg2"/>
+          </a:solidFill>
+          <a:ln w="12700">
+            <a:solidFill>
+              <a:schemeClr val="bg2"/>
+            </a:solidFill>
+            <a:prstDash val="solid"/>
+          </a:ln>
+        </p:spPr>
+      </p:sp>
+      <p:sp>
+        <p:nvSpPr>
+          <p:cNvPr id="5" name="Text 2"/>
+          <p:cNvSpPr txBox="1"/>
+          <p:nvPr/>
+        </p:nvSpPr>
+        <p:spPr>
+          <a:xfrm>
+            <a:off x="822960" y="1508760"/>
+            <a:ext cx="6126480" cy="320040"/>
+          </a:xfrm>
+          <a:prstGeom prst="rect">
+            <a:avLst/>
+          </a:prstGeom>
+          <a:noFill/>
+          <a:ln/>
+        </p:spPr>
+        <p:txBody>
+          <a:bodyPr wrap="square" lIns="0" tIns="0" rIns="0" bIns="0" rtlCol="0" anchor="ctr"/>
+          <a:lstStyle/>
+          <a:p>
+            <a:pPr indent="0" marL="0">
+              <a:buNone/>
+            </a:pPr>
+            <a:r>
+              <a:rPr lang="en-US" sz="1400" b="1" dirty="0">
+                <a:solidFill>
+                  <a:schemeClr val="accent1"/>
+                </a:solidFill>
+                <a:latin typeface="Apple SD Gothic Neo" pitchFamily="34" charset="0"/>
+                <a:ea typeface="Apple SD Gothic Neo" pitchFamily="34" charset="-122"/>
+                <a:cs typeface="Apple SD Gothic Neo" pitchFamily="34" charset="-120"/>
+              </a:rPr>
+              <a:t>변수 i 의 위쪽 분지 기록 (아래쪽은 같은 방식)</a:t>
+            </a:r>
+            <a:endParaRPr lang="en-US" sz="1400" dirty="0"/>
+          </a:p>
+        </p:txBody>
+      </p:sp>
+      <p:sp>
+        <p:nvSpPr>
+          <p:cNvPr id="12" name="param card"/>
+          <p:cNvSpPr/>
+          <p:nvPr/>
+        </p:nvSpPr>
+        <p:spPr>
+          <a:xfrm>
+            <a:off x="7589520" y="1371600"/>
+            <a:ext cx="4023360" cy="4846320"/>
+          </a:xfrm>
+          <a:prstGeom prst="roundRect">
+            <a:avLst>
+              <a:gd name="adj" fmla="val 2727"/>
+            </a:avLst>
+          </a:prstGeom>
+          <a:solidFill>
+            <a:schemeClr val="bg2"/>
+          </a:solidFill>
+          <a:ln w="12700">
+            <a:solidFill>
+              <a:schemeClr val="bg2"/>
+            </a:solidFill>
+            <a:prstDash val="solid"/>
+          </a:ln>
+        </p:spPr>
+      </p:sp>
+      <p:sp>
+        <p:nvSpPr>
+          <p:cNvPr id="13" name="Text 7"/>
+          <p:cNvSpPr txBox="1"/>
+          <p:nvPr/>
+        </p:nvSpPr>
+        <p:spPr>
+          <a:xfrm>
+            <a:off x="7818120" y="1536192"/>
+            <a:ext cx="3566160" cy="365760"/>
+          </a:xfrm>
+          <a:prstGeom prst="rect">
+            <a:avLst/>
+          </a:prstGeom>
+          <a:noFill/>
+          <a:ln/>
+        </p:spPr>
+        <p:txBody>
+          <a:bodyPr wrap="square" lIns="0" tIns="0" rIns="0" bIns="0" rtlCol="0" anchor="ctr"/>
+          <a:lstStyle/>
+          <a:p>
+            <a:pPr indent="0" marL="0">
+              <a:buNone/>
+            </a:pPr>
+            <a:r>
+              <a:rPr lang="en-US" sz="1600" b="1" dirty="0">
+                <a:solidFill>
+                  <a:schemeClr val="accent1"/>
+                </a:solidFill>
+                <a:latin typeface="Apple SD Gothic Neo" pitchFamily="34" charset="0"/>
+                <a:ea typeface="Apple SD Gothic Neo" pitchFamily="34" charset="-122"/>
+                <a:cs typeface="Apple SD Gothic Neo" pitchFamily="34" charset="-120"/>
+              </a:rPr>
+              <a:t>숫자 예시</a:t>
+            </a:r>
+            <a:endParaRPr lang="en-US" sz="1600" dirty="0"/>
+          </a:p>
+        </p:txBody>
+      </p:sp>
+      <p:sp>
+        <p:nvSpPr>
+          <p:cNvPr id="14" name="Text 8"/>
+          <p:cNvSpPr txBox="1"/>
+          <p:nvPr/>
+        </p:nvSpPr>
+        <p:spPr>
+          <a:xfrm>
+            <a:off x="7818120" y="2011680"/>
+            <a:ext cx="3566160" cy="4069080"/>
+          </a:xfrm>
+          <a:prstGeom prst="rect">
+            <a:avLst/>
+          </a:prstGeom>
+          <a:noFill/>
+          <a:ln/>
+        </p:spPr>
+        <p:txBody>
+          <a:bodyPr wrap="square" lIns="0" tIns="0" rIns="0" bIns="0" rtlCol="0" anchor="t"/>
+          <a:lstStyle/>
+          <a:p>
+            <a:pPr marL="342900" indent="-342900">
+              <a:spcAft>
+                <a:spcPts val="600"/>
+              </a:spcAft>
+              <a:buSzPct val="100000"/>
+              <a:buChar char="•"/>
+            </a:pPr>
+            <a:r>
+              <a:rPr lang="en-US" sz="1400" dirty="0">
+                <a:solidFill>
+                  <a:schemeClr val="tx1"/>
+                </a:solidFill>
+                <a:latin typeface="Apple SD Gothic Neo" pitchFamily="34" charset="0"/>
+                <a:ea typeface="Apple SD Gothic Neo" pitchFamily="34" charset="-122"/>
+                <a:cs typeface="Apple SD Gothic Neo" pitchFamily="34" charset="-120"/>
+              </a:rPr>
+              <a:t>관측 (f⁺, Δ⁺) = (0.6, 1.2), (0.5, 0.75), (0.4, 1.0)</a:t>
+            </a:r>
+            <a:endParaRPr lang="en-US" sz="1400" dirty="0"/>
+          </a:p>
+          <a:p>
+            <a:pPr marL="342900" indent="-342900">
+              <a:spcAft>
+                <a:spcPts val="600"/>
+              </a:spcAft>
+              <a:buSzPct val="100000"/>
+              <a:buChar char="•"/>
+            </a:pPr>
+            <a:r>
+              <a:rPr lang="en-US" sz="1400" dirty="0">
+                <a:solidFill>
+                  <a:schemeClr val="tx1"/>
+                </a:solidFill>
+                <a:latin typeface="Apple SD Gothic Neo" pitchFamily="34" charset="0"/>
+                <a:ea typeface="Apple SD Gothic Neo" pitchFamily="34" charset="-122"/>
+                <a:cs typeface="Apple SD Gothic Neo" pitchFamily="34" charset="-120"/>
+              </a:rPr>
+              <a:t>ς⁺ = 2.0, 1.5, 2.5 → σ⁺ = 6.0, η⁺ = 3</a:t>
+            </a:r>
+            <a:endParaRPr lang="en-US" sz="1400" dirty="0"/>
+          </a:p>
+          <a:p>
+            <a:pPr marL="342900" indent="-342900">
+              <a:spcAft>
+                <a:spcPts val="600"/>
+              </a:spcAft>
+              <a:buSzPct val="100000"/>
+              <a:buChar char="•"/>
+            </a:pPr>
+            <a:r>
+              <a:rPr lang="en-US" sz="1400" dirty="0">
+                <a:solidFill>
+                  <a:schemeClr val="tx1"/>
+                </a:solidFill>
+                <a:latin typeface="Apple SD Gothic Neo" pitchFamily="34" charset="0"/>
+                <a:ea typeface="Apple SD Gothic Neo" pitchFamily="34" charset="-122"/>
+                <a:cs typeface="Apple SD Gothic Neo" pitchFamily="34" charset="-120"/>
+              </a:rPr>
+              <a:t>Ψ⁺ = 6.0 / 3 = 2.0</a:t>
+            </a:r>
+            <a:endParaRPr lang="en-US" sz="1400" dirty="0"/>
+          </a:p>
+          <a:p>
+            <a:pPr marL="342900" indent="-342900">
+              <a:spcAft>
+                <a:spcPts val="600"/>
+              </a:spcAft>
+              <a:buSzPct val="100000"/>
+              <a:buChar char="•"/>
+            </a:pPr>
+            <a:r>
+              <a:rPr lang="en-US" sz="1400" dirty="0">
+                <a:solidFill>
+                  <a:schemeClr val="tx1"/>
+                </a:solidFill>
+                <a:latin typeface="Apple SD Gothic Neo" pitchFamily="34" charset="0"/>
+                <a:ea typeface="Apple SD Gothic Neo" pitchFamily="34" charset="-122"/>
+                <a:cs typeface="Apple SD Gothic Neo" pitchFamily="34" charset="-120"/>
+              </a:rPr>
+              <a:t>다음 노드에서 f⁺ = 0.3 이면 예상 증가량 = 0.3 × 2.0 = 0.6</a:t>
+            </a:r>
+            <a:endParaRPr lang="en-US" sz="1400" dirty="0"/>
+          </a:p>
+          <a:p>
+            <a:pPr marL="342900" indent="-342900">
+              <a:spcAft>
+                <a:spcPts val="600"/>
+              </a:spcAft>
+              <a:buSzPct val="100000"/>
+              <a:buChar char="•"/>
+            </a:pPr>
+            <a:r>
+              <a:rPr lang="en-US" sz="1400" dirty="0">
+                <a:solidFill>
+                  <a:schemeClr val="tx1"/>
+                </a:solidFill>
+                <a:latin typeface="Apple SD Gothic Neo" pitchFamily="34" charset="0"/>
+                <a:ea typeface="Apple SD Gothic Neo" pitchFamily="34" charset="-122"/>
+                <a:cs typeface="Apple SD Gothic Neo" pitchFamily="34" charset="-120"/>
+              </a:rPr>
+              <a:t>η_rel = 4 라면 min(η⁻, η⁺) ≤ 3 &lt; 4 이므로 이 Ψ 는 믿기 어렵다 → strong branching</a:t>
+            </a:r>
+            <a:endParaRPr lang="en-US" sz="1400" dirty="0"/>
+          </a:p>
+        </p:txBody>
+      </p:sp>
+      <p:sp>
+        <p:nvSpPr>
+          <p:cNvPr id="15" name="Text 9"/>
+          <p:cNvSpPr txBox="1"/>
+          <p:nvPr/>
+        </p:nvSpPr>
+        <p:spPr>
+          <a:xfrm>
+            <a:off x="548640" y="6355080"/>
+            <a:ext cx="10607040" cy="274320"/>
+          </a:xfrm>
+          <a:prstGeom prst="rect">
+            <a:avLst/>
+          </a:prstGeom>
+          <a:noFill/>
+          <a:ln/>
+        </p:spPr>
+        <p:txBody>
+          <a:bodyPr wrap="square" lIns="0" tIns="0" rIns="0" bIns="0" rtlCol="0" anchor="ctr"/>
+          <a:lstStyle/>
+          <a:p>
+            <a:pPr indent="0" marL="0">
+              <a:buNone/>
+            </a:pPr>
+            <a:r>
+              <a:rPr lang="en-US" sz="1000" dirty="0">
+                <a:solidFill>
+                  <a:schemeClr val="accent3"/>
+                </a:solidFill>
+                <a:latin typeface="Apple SD Gothic Neo" pitchFamily="34" charset="0"/>
+                <a:ea typeface="Apple SD Gothic Neo" pitchFamily="34" charset="-122"/>
+                <a:cs typeface="Apple SD Gothic Neo" pitchFamily="34" charset="-120"/>
+              </a:rPr>
+              <a:t>Achterberg, Koch, Martin (2005), 2.2절. 숫자 예시는 정의에 맞춰 만든 가상의 값</a:t>
+            </a:r>
+            <a:endParaRPr lang="en-US" sz="1000" dirty="0"/>
+          </a:p>
+        </p:txBody>
+      </p:sp>
+      <p:sp>
+        <p:nvSpPr>
+          <p:cNvPr id="25" name="Slide Number Placeholder 0"/>
+          <p:cNvSpPr>
+            <a:spLocks noGrp="1"/>
+          </p:cNvSpPr>
+          <p:nvPr>
+            <p:ph type="sldNum" sz="quarter" idx="4294967295"/>
+          </p:nvPr>
+        </p:nvSpPr>
+        <p:spPr>
+          <a:xfrm>
+            <a:off x="11338560" y="6400800"/>
+            <a:ext cx="548640" cy="274320"/>
+          </a:xfrm>
+          <a:prstGeom prst="rect">
+            <a:avLst/>
+          </a:prstGeom>
+          <a:extLst>
+            <a:ext uri="{C572A759-6A51-4108-AA02-DFA0A04FC94B}">
+              <ma14:wrappingTextBoxFlag xmlns:ma14="http://schemas.microsoft.com/office/mac/drawingml/2011/main" val="0"/>
+            </a:ext>
+          </a:extLst>
+        </p:spPr>
+        <p:txBody>
+          <a:bodyPr/>
+          <a:lstStyle>
+            <a:lvl1pPr>
+              <a:defRPr sz="1000">
+                <a:solidFill>
+                  <a:schemeClr val="accent3"/>
+                </a:solidFill>
+              </a:defRPr>
+            </a:lvl1pPr>
+          </a:lstStyle>
+          <a:p>
+            <a:pPr algn="r"/>
+            <a:fld id="{F7021451-1387-4CA6-816F-3879F97B5CBC}" type="slidenum">
+              <a:rPr b="0" lang="en-US"/>
+              <a:t>15</a:t>
+            </a:fld>
+            <a:endParaRPr lang="en-US"/>
+          </a:p>
+        </p:txBody>
+      </p:sp>
+      <p:sp>
+        <p:nvSpPr>
+          <p:cNvPr id="40" name="Text 10"/>
+          <p:cNvSpPr txBox="1"/>
+          <p:nvPr/>
+        </p:nvSpPr>
+        <p:spPr>
+          <a:xfrm>
+            <a:off x="822960" y="2011680"/>
+            <a:ext cx="6126480" cy="4069080"/>
+          </a:xfrm>
+          <a:prstGeom prst="rect">
+            <a:avLst/>
+          </a:prstGeom>
+          <a:noFill/>
+          <a:ln/>
+        </p:spPr>
+        <p:txBody>
+          <a:bodyPr wrap="square" lIns="0" tIns="0" rIns="0" bIns="0" rtlCol="0" anchor="t"/>
+          <a:lstStyle/>
+          <a:p>
+            <a:pPr marL="342900" indent="-342900">
+              <a:spcAft>
+                <a:spcPts val="600"/>
+              </a:spcAft>
+              <a:buSzPct val="100000"/>
+              <a:buChar char="•"/>
+            </a:pPr>
+            <a:r>
+              <a:rPr lang="en-US" sz="1400" dirty="0">
+                <a:solidFill>
+                  <a:schemeClr val="tx1"/>
+                </a:solidFill>
+                <a:latin typeface="Apple SD Gothic Neo" pitchFamily="34" charset="0"/>
+                <a:ea typeface="Apple SD Gothic Neo" pitchFamily="34" charset="-122"/>
+                <a:cs typeface="Apple SD Gothic Neo" pitchFamily="34" charset="-120"/>
+              </a:rPr>
+              <a:t>f⁺ : 위로 분지할 때 xᵢ 가 움직이는 거리 (⌈x̂ᵢ⌉ − x̂ᵢ)</a:t>
+            </a:r>
+            <a:endParaRPr lang="en-US" sz="1400" dirty="0"/>
+          </a:p>
+          <a:p>
+            <a:pPr marL="342900" indent="-342900">
+              <a:spcAft>
+                <a:spcPts val="600"/>
+              </a:spcAft>
+              <a:buSzPct val="100000"/>
+              <a:buChar char="•"/>
+            </a:pPr>
+            <a:r>
+              <a:rPr lang="en-US" sz="1400" dirty="0">
+                <a:solidFill>
+                  <a:schemeClr val="tx1"/>
+                </a:solidFill>
+                <a:latin typeface="Apple SD Gothic Neo" pitchFamily="34" charset="0"/>
+                <a:ea typeface="Apple SD Gothic Neo" pitchFamily="34" charset="-122"/>
+                <a:cs typeface="Apple SD Gothic Neo" pitchFamily="34" charset="-120"/>
+              </a:rPr>
+              <a:t>Δ⁺ : 그때 실제로 측정한 자식 LP 하한의 증가량</a:t>
+            </a:r>
+            <a:endParaRPr lang="en-US" sz="1400" dirty="0"/>
+          </a:p>
+          <a:p>
+            <a:pPr marL="342900" indent="-342900">
+              <a:spcAft>
+                <a:spcPts val="600"/>
+              </a:spcAft>
+              <a:buSzPct val="100000"/>
+              <a:buChar char="•"/>
+            </a:pPr>
+            <a:r>
+              <a:rPr lang="en-US" sz="1400" dirty="0">
+                <a:solidFill>
+                  <a:schemeClr val="tx1"/>
+                </a:solidFill>
+                <a:latin typeface="Apple SD Gothic Neo" pitchFamily="34" charset="0"/>
+                <a:ea typeface="Apple SD Gothic Neo" pitchFamily="34" charset="-122"/>
+                <a:cs typeface="Apple SD Gothic Neo" pitchFamily="34" charset="-120"/>
+              </a:rPr>
+              <a:t>ς⁺ = Δ⁺ / f⁺ : 단위 변화당 이득, 한 번의 관측값</a:t>
+            </a:r>
+            <a:endParaRPr lang="en-US" sz="1400" dirty="0"/>
+          </a:p>
+          <a:p>
+            <a:pPr marL="342900" indent="-342900">
+              <a:spcAft>
+                <a:spcPts val="600"/>
+              </a:spcAft>
+              <a:buSzPct val="100000"/>
+              <a:buChar char="•"/>
+            </a:pPr>
+            <a:r>
+              <a:rPr lang="en-US" sz="1400" dirty="0">
+                <a:solidFill>
+                  <a:schemeClr val="tx1"/>
+                </a:solidFill>
+                <a:latin typeface="Apple SD Gothic Neo" pitchFamily="34" charset="0"/>
+                <a:ea typeface="Apple SD Gothic Neo" pitchFamily="34" charset="-122"/>
+                <a:cs typeface="Apple SD Gothic Neo" pitchFamily="34" charset="-120"/>
+              </a:rPr>
+              <a:t>σ⁺ : 지금까지 쌓인 ς⁺ 의 합</a:t>
+            </a:r>
+            <a:endParaRPr lang="en-US" sz="1400" dirty="0"/>
+          </a:p>
+          <a:p>
+            <a:pPr marL="342900" indent="-342900">
+              <a:spcAft>
+                <a:spcPts val="600"/>
+              </a:spcAft>
+              <a:buSzPct val="100000"/>
+              <a:buChar char="•"/>
+            </a:pPr>
+            <a:r>
+              <a:rPr lang="en-US" sz="1400" dirty="0">
+                <a:solidFill>
+                  <a:schemeClr val="tx1"/>
+                </a:solidFill>
+                <a:latin typeface="Apple SD Gothic Neo" pitchFamily="34" charset="0"/>
+                <a:ea typeface="Apple SD Gothic Neo" pitchFamily="34" charset="-122"/>
+                <a:cs typeface="Apple SD Gothic Neo" pitchFamily="34" charset="-120"/>
+              </a:rPr>
+              <a:t>η⁺ : 그 관측 횟수</a:t>
+            </a:r>
+            <a:endParaRPr lang="en-US" sz="1400" dirty="0"/>
+          </a:p>
+          <a:p>
+            <a:pPr marL="342900" indent="-342900">
+              <a:spcAft>
+                <a:spcPts val="600"/>
+              </a:spcAft>
+              <a:buSzPct val="100000"/>
+              <a:buChar char="•"/>
+            </a:pPr>
+            <a:r>
+              <a:rPr lang="en-US" sz="1400" dirty="0">
+                <a:solidFill>
+                  <a:schemeClr val="tx1"/>
+                </a:solidFill>
+                <a:latin typeface="Apple SD Gothic Neo" pitchFamily="34" charset="0"/>
+                <a:ea typeface="Apple SD Gothic Neo" pitchFamily="34" charset="-122"/>
+                <a:cs typeface="Apple SD Gothic Neo" pitchFamily="34" charset="-120"/>
+              </a:rPr>
+              <a:t>Ψ⁺ = σ⁺ / η⁺ : ς⁺ 의 평균, 곧 pseudocost</a:t>
+            </a:r>
+            <a:endParaRPr lang="en-US" sz="1400" dirty="0"/>
+          </a:p>
+          <a:p>
+            <a:pPr marL="342900" indent="-342900">
+              <a:spcAft>
+                <a:spcPts val="600"/>
+              </a:spcAft>
+              <a:buSzPct val="100000"/>
+              <a:buChar char="•"/>
+            </a:pPr>
+            <a:r>
+              <a:rPr lang="en-US" sz="1400" dirty="0">
+                <a:solidFill>
+                  <a:schemeClr val="tx1"/>
+                </a:solidFill>
+                <a:latin typeface="Apple SD Gothic Neo" pitchFamily="34" charset="0"/>
+                <a:ea typeface="Apple SD Gothic Neo" pitchFamily="34" charset="-122"/>
+                <a:cs typeface="Apple SD Gothic Neo" pitchFamily="34" charset="-120"/>
+              </a:rPr>
+              <a:t>분지 전에는 자식 LP를 풀지 않으므로 Δ⁺ 를 f⁺·Ψ⁺ 로 추정해 점수에 쓴다</a:t>
+            </a:r>
+            <a:endParaRPr lang="en-US" sz="1400" dirty="0"/>
+          </a:p>
+        </p:txBody>
+      </p:sp>
+    </p:spTree>
+  </p:cSld>
+  <p:clrMapOvr>
+    <a:masterClrMapping/>
+  </p:clrMapOvr>
+</p:sld>
+</file>
+
+<file path=ppt/slides/slide17.xml><?xml version="1.0" encoding="utf-8"?>
 <p:sld xmlns:a="http://schemas.openxmlformats.org/drawingml/2006/main" xmlns:r="http://schemas.openxmlformats.org/officeDocument/2006/relationships" xmlns:p="http://schemas.openxmlformats.org/presentationml/2006/main">
   <p:cSld name="Slide 16">
     <p:spTree>
@@ -9950,7 +10521,491 @@
 </p:sld>
 </file>
 
-<file path=ppt/slides/slide17.xml><?xml version="1.0" encoding="utf-8"?>
+<file path=ppt/slides/slide18.xml><?xml version="1.0" encoding="utf-8"?>
+<p:sld xmlns:a="http://schemas.openxmlformats.org/drawingml/2006/main" xmlns:p="http://schemas.openxmlformats.org/presentationml/2006/main" xmlns:r="http://schemas.openxmlformats.org/officeDocument/2006/relationships">
+  <p:cSld>
+    <p:spTree>
+      <p:nvGrpSpPr>
+        <p:cNvPr id="1" name=""/>
+        <p:cNvGrpSpPr/>
+        <p:nvPr/>
+      </p:nvGrpSpPr>
+      <p:grpSpPr/>
+      <p:sp>
+        <p:nvSpPr>
+          <p:cNvPr id="2" name="Text 0"/>
+          <p:cNvSpPr/>
+          <p:nvPr>
+            <p:ph idx="100" type="title" hasCustomPrompt="1"/>
+          </p:nvPr>
+        </p:nvSpPr>
+        <p:spPr>
+          <a:xfrm>
+            <a:off x="548640" y="320040"/>
+            <a:ext cx="11064240" cy="822960"/>
+          </a:xfrm>
+          <a:prstGeom prst="rect">
+            <a:avLst/>
+          </a:prstGeom>
+          <a:noFill/>
+          <a:ln/>
+        </p:spPr>
+        <p:txBody>
+          <a:bodyPr wrap="square" rtlCol="0" anchor="ctr"/>
+          <a:lstStyle/>
+          <a:p>
+            <a:pPr indent="0" marL="0">
+              <a:buNone/>
+            </a:pPr>
+            <a:r>
+              <a:rPr lang="en-US" sz="3000" b="1" dirty="0">
+                <a:solidFill>
+                  <a:schemeClr val="tx2"/>
+                </a:solidFill>
+              </a:rPr>
+              <a:t>Conflict analysis를 쉽게 보면</a:t>
+            </a:r>
+            <a:endParaRPr lang="en-US" sz="3000" dirty="0"/>
+          </a:p>
+        </p:txBody>
+      </p:sp>
+      <p:sp>
+        <p:nvSpPr>
+          <p:cNvPr id="4" name="formula card"/>
+          <p:cNvSpPr/>
+          <p:nvPr/>
+        </p:nvSpPr>
+        <p:spPr>
+          <a:xfrm>
+            <a:off x="548640" y="1371600"/>
+            <a:ext cx="6675120" cy="4846320"/>
+          </a:xfrm>
+          <a:prstGeom prst="roundRect">
+            <a:avLst>
+              <a:gd name="adj" fmla="val 2264"/>
+            </a:avLst>
+          </a:prstGeom>
+          <a:solidFill>
+            <a:schemeClr val="bg2"/>
+          </a:solidFill>
+          <a:ln w="12700">
+            <a:solidFill>
+              <a:schemeClr val="bg2"/>
+            </a:solidFill>
+            <a:prstDash val="solid"/>
+          </a:ln>
+        </p:spPr>
+      </p:sp>
+      <p:sp>
+        <p:nvSpPr>
+          <p:cNvPr id="5" name="Text 2"/>
+          <p:cNvSpPr txBox="1"/>
+          <p:nvPr/>
+        </p:nvSpPr>
+        <p:spPr>
+          <a:xfrm>
+            <a:off x="822960" y="1508760"/>
+            <a:ext cx="6126480" cy="320040"/>
+          </a:xfrm>
+          <a:prstGeom prst="rect">
+            <a:avLst/>
+          </a:prstGeom>
+          <a:noFill/>
+          <a:ln/>
+        </p:spPr>
+        <p:txBody>
+          <a:bodyPr wrap="square" lIns="0" tIns="0" rIns="0" bIns="0" rtlCol="0" anchor="ctr"/>
+          <a:lstStyle/>
+          <a:p>
+            <a:pPr indent="0" marL="0">
+              <a:buNone/>
+            </a:pPr>
+            <a:r>
+              <a:rPr lang="en-US" sz="1400" b="1" dirty="0">
+                <a:solidFill>
+                  <a:schemeClr val="accent1"/>
+                </a:solidFill>
+                <a:latin typeface="Apple SD Gothic Neo" pitchFamily="34" charset="0"/>
+                <a:ea typeface="Apple SD Gothic Neo" pitchFamily="34" charset="-122"/>
+                <a:cs typeface="Apple SD Gothic Neo" pitchFamily="34" charset="-120"/>
+              </a:rPr>
+              <a:t>막다른 길의 이유를 적어 두고, 같은 이유로는 다시 안 간다</a:t>
+            </a:r>
+            <a:endParaRPr lang="en-US" sz="1400" dirty="0"/>
+          </a:p>
+        </p:txBody>
+      </p:sp>
+      <p:sp>
+        <p:nvSpPr>
+          <p:cNvPr id="12" name="param card"/>
+          <p:cNvSpPr/>
+          <p:nvPr/>
+        </p:nvSpPr>
+        <p:spPr>
+          <a:xfrm>
+            <a:off x="7589520" y="1371600"/>
+            <a:ext cx="4023360" cy="4846320"/>
+          </a:xfrm>
+          <a:prstGeom prst="roundRect">
+            <a:avLst>
+              <a:gd name="adj" fmla="val 2727"/>
+            </a:avLst>
+          </a:prstGeom>
+          <a:solidFill>
+            <a:schemeClr val="bg2"/>
+          </a:solidFill>
+          <a:ln w="12700">
+            <a:solidFill>
+              <a:schemeClr val="bg2"/>
+            </a:solidFill>
+            <a:prstDash val="solid"/>
+          </a:ln>
+        </p:spPr>
+      </p:sp>
+      <p:sp>
+        <p:nvSpPr>
+          <p:cNvPr id="13" name="Text 7"/>
+          <p:cNvSpPr txBox="1"/>
+          <p:nvPr/>
+        </p:nvSpPr>
+        <p:spPr>
+          <a:xfrm>
+            <a:off x="7818120" y="1536192"/>
+            <a:ext cx="3566160" cy="365760"/>
+          </a:xfrm>
+          <a:prstGeom prst="rect">
+            <a:avLst/>
+          </a:prstGeom>
+          <a:noFill/>
+          <a:ln/>
+        </p:spPr>
+        <p:txBody>
+          <a:bodyPr wrap="square" lIns="0" tIns="0" rIns="0" bIns="0" rtlCol="0" anchor="ctr"/>
+          <a:lstStyle/>
+          <a:p>
+            <a:pPr indent="0" marL="0">
+              <a:buNone/>
+            </a:pPr>
+            <a:r>
+              <a:rPr lang="en-US" sz="1600" b="1" dirty="0">
+                <a:solidFill>
+                  <a:schemeClr val="accent1"/>
+                </a:solidFill>
+                <a:latin typeface="Apple SD Gothic Neo" pitchFamily="34" charset="0"/>
+                <a:ea typeface="Apple SD Gothic Neo" pitchFamily="34" charset="-122"/>
+                <a:cs typeface="Apple SD Gothic Neo" pitchFamily="34" charset="-120"/>
+              </a:rPr>
+              <a:t>실험 결과를 쉽게 말하면</a:t>
+            </a:r>
+            <a:endParaRPr lang="en-US" sz="1600" dirty="0"/>
+          </a:p>
+        </p:txBody>
+      </p:sp>
+      <p:sp>
+        <p:nvSpPr>
+          <p:cNvPr id="14" name="Text 8"/>
+          <p:cNvSpPr txBox="1"/>
+          <p:nvPr/>
+        </p:nvSpPr>
+        <p:spPr>
+          <a:xfrm>
+            <a:off x="7818120" y="2011680"/>
+            <a:ext cx="3566160" cy="4069080"/>
+          </a:xfrm>
+          <a:prstGeom prst="rect">
+            <a:avLst/>
+          </a:prstGeom>
+          <a:noFill/>
+          <a:ln/>
+        </p:spPr>
+        <p:txBody>
+          <a:bodyPr wrap="square" lIns="0" tIns="0" rIns="0" bIns="0" rtlCol="0" anchor="t"/>
+          <a:lstStyle/>
+          <a:p>
+            <a:pPr marL="342900" indent="-342900">
+              <a:spcAft>
+                <a:spcPts val="600"/>
+              </a:spcAft>
+              <a:buSzPct val="100000"/>
+              <a:buChar char="•"/>
+            </a:pPr>
+            <a:r>
+              <a:rPr lang="en-US" sz="1400" dirty="0">
+                <a:solidFill>
+                  <a:schemeClr val="tx1"/>
+                </a:solidFill>
+                <a:latin typeface="Apple SD Gothic Neo" pitchFamily="34" charset="0"/>
+                <a:ea typeface="Apple SD Gothic Neo" pitchFamily="34" charset="-122"/>
+                <a:cs typeface="Apple SD Gothic Neo" pitchFamily="34" charset="-120"/>
+              </a:rPr>
+              <a:t>풀 수 있는 문제: 노드 수는 약 절반, 시간은 약 15% 증가 (메모를 쓰고 확인하는 비용)</a:t>
+            </a:r>
+            <a:endParaRPr lang="en-US" sz="1400" dirty="0"/>
+          </a:p>
+          <a:p>
+            <a:pPr marL="342900" indent="-342900">
+              <a:spcAft>
+                <a:spcPts val="600"/>
+              </a:spcAft>
+              <a:buSzPct val="100000"/>
+              <a:buChar char="•"/>
+            </a:pPr>
+            <a:r>
+              <a:rPr lang="en-US" sz="1400" dirty="0">
+                <a:solidFill>
+                  <a:schemeClr val="tx1"/>
+                </a:solidFill>
+                <a:latin typeface="Apple SD Gothic Neo" pitchFamily="34" charset="0"/>
+                <a:ea typeface="Apple SD Gothic Neo" pitchFamily="34" charset="-122"/>
+                <a:cs typeface="Apple SD Gothic Neo" pitchFamily="34" charset="-120"/>
+              </a:rPr>
+              <a:t>답이 없는 문제 (칩 검증): 노드 수와 시간 모두 크게 감소</a:t>
+            </a:r>
+            <a:endParaRPr lang="en-US" sz="1400" dirty="0"/>
+          </a:p>
+          <a:p>
+            <a:pPr marL="342900" indent="-342900">
+              <a:spcAft>
+                <a:spcPts val="600"/>
+              </a:spcAft>
+              <a:buSzPct val="100000"/>
+              <a:buChar char="•"/>
+            </a:pPr>
+            <a:r>
+              <a:rPr lang="en-US" sz="1400" dirty="0">
+                <a:solidFill>
+                  <a:schemeClr val="tx1"/>
+                </a:solidFill>
+                <a:latin typeface="Apple SD Gothic Neo" pitchFamily="34" charset="0"/>
+                <a:ea typeface="Apple SD Gothic Neo" pitchFamily="34" charset="-122"/>
+                <a:cs typeface="Apple SD Gothic Neo" pitchFamily="34" charset="-120"/>
+              </a:rPr>
+              <a:t>막다른 길이 많은 문제에서 특히 효과가 크다</a:t>
+            </a:r>
+            <a:endParaRPr lang="en-US" sz="1400" dirty="0"/>
+          </a:p>
+        </p:txBody>
+      </p:sp>
+      <p:sp>
+        <p:nvSpPr>
+          <p:cNvPr id="15" name="Text 9"/>
+          <p:cNvSpPr txBox="1"/>
+          <p:nvPr/>
+        </p:nvSpPr>
+        <p:spPr>
+          <a:xfrm>
+            <a:off x="548640" y="6355080"/>
+            <a:ext cx="10607040" cy="274320"/>
+          </a:xfrm>
+          <a:prstGeom prst="rect">
+            <a:avLst/>
+          </a:prstGeom>
+          <a:noFill/>
+          <a:ln/>
+        </p:spPr>
+        <p:txBody>
+          <a:bodyPr wrap="square" lIns="0" tIns="0" rIns="0" bIns="0" rtlCol="0" anchor="ctr"/>
+          <a:lstStyle/>
+          <a:p>
+            <a:pPr indent="0" marL="0">
+              <a:buNone/>
+            </a:pPr>
+            <a:r>
+              <a:rPr lang="en-US" sz="1000" dirty="0">
+                <a:solidFill>
+                  <a:schemeClr val="accent3"/>
+                </a:solidFill>
+                <a:latin typeface="Apple SD Gothic Neo" pitchFamily="34" charset="0"/>
+                <a:ea typeface="Apple SD Gothic Neo" pitchFamily="34" charset="-122"/>
+                <a:cs typeface="Apple SD Gothic Neo" pitchFamily="34" charset="-120"/>
+              </a:rPr>
+              <a:t>Achterberg (2007), 1장·3장·4장. 예시의 A, B, C 는 설명을 위한 가상의 변수</a:t>
+            </a:r>
+            <a:endParaRPr lang="en-US" sz="1000" dirty="0"/>
+          </a:p>
+        </p:txBody>
+      </p:sp>
+      <p:sp>
+        <p:nvSpPr>
+          <p:cNvPr id="25" name="Slide Number Placeholder 0"/>
+          <p:cNvSpPr>
+            <a:spLocks noGrp="1"/>
+          </p:cNvSpPr>
+          <p:nvPr>
+            <p:ph type="sldNum" sz="quarter" idx="4294967295"/>
+          </p:nvPr>
+        </p:nvSpPr>
+        <p:spPr>
+          <a:xfrm>
+            <a:off x="11338560" y="6400800"/>
+            <a:ext cx="548640" cy="274320"/>
+          </a:xfrm>
+          <a:prstGeom prst="rect">
+            <a:avLst/>
+          </a:prstGeom>
+          <a:extLst>
+            <a:ext uri="{C572A759-6A51-4108-AA02-DFA0A04FC94B}">
+              <ma14:wrappingTextBoxFlag xmlns:ma14="http://schemas.microsoft.com/office/mac/drawingml/2011/main" val="0"/>
+            </a:ext>
+          </a:extLst>
+        </p:spPr>
+        <p:txBody>
+          <a:bodyPr/>
+          <a:lstStyle>
+            <a:lvl1pPr>
+              <a:defRPr sz="1000">
+                <a:solidFill>
+                  <a:schemeClr val="accent3"/>
+                </a:solidFill>
+              </a:defRPr>
+            </a:lvl1pPr>
+          </a:lstStyle>
+          <a:p>
+            <a:pPr algn="r"/>
+            <a:fld id="{F7021451-1387-4CA6-816F-3879F97B5CBC}" type="slidenum">
+              <a:rPr b="0" lang="en-US"/>
+              <a:t>15</a:t>
+            </a:fld>
+            <a:endParaRPr lang="en-US"/>
+          </a:p>
+        </p:txBody>
+      </p:sp>
+      <p:sp>
+        <p:nvSpPr>
+          <p:cNvPr id="40" name="Text 10"/>
+          <p:cNvSpPr txBox="1"/>
+          <p:nvPr/>
+        </p:nvSpPr>
+        <p:spPr>
+          <a:xfrm>
+            <a:off x="822960" y="2011680"/>
+            <a:ext cx="6126480" cy="4069080"/>
+          </a:xfrm>
+          <a:prstGeom prst="rect">
+            <a:avLst/>
+          </a:prstGeom>
+          <a:noFill/>
+          <a:ln/>
+        </p:spPr>
+        <p:txBody>
+          <a:bodyPr wrap="square" lIns="0" tIns="0" rIns="0" bIns="0" rtlCol="0" anchor="t"/>
+          <a:lstStyle/>
+          <a:p>
+            <a:pPr marL="342900" indent="-342900">
+              <a:spcAft>
+                <a:spcPts val="600"/>
+              </a:spcAft>
+              <a:buSzPct val="100000"/>
+              <a:buChar char="•"/>
+            </a:pPr>
+            <a:r>
+              <a:rPr lang="en-US" sz="1400" dirty="0">
+                <a:solidFill>
+                  <a:schemeClr val="tx1"/>
+                </a:solidFill>
+                <a:latin typeface="Apple SD Gothic Neo" pitchFamily="34" charset="0"/>
+                <a:ea typeface="Apple SD Gothic Neo" pitchFamily="34" charset="-122"/>
+                <a:cs typeface="Apple SD Gothic Neo" pitchFamily="34" charset="-120"/>
+              </a:rPr>
+              <a:t>상황: A=1, B=0, C=1 로 정했더니 LP가 비실현 (막다른 길)</a:t>
+            </a:r>
+            <a:endParaRPr lang="en-US" sz="1400" dirty="0"/>
+          </a:p>
+          <a:p>
+            <a:pPr marL="342900" indent="-342900">
+              <a:spcAft>
+                <a:spcPts val="600"/>
+              </a:spcAft>
+              <a:buSzPct val="100000"/>
+              <a:buChar char="•"/>
+            </a:pPr>
+            <a:r>
+              <a:rPr lang="en-US" sz="1400" dirty="0">
+                <a:solidFill>
+                  <a:schemeClr val="tx1"/>
+                </a:solidFill>
+                <a:latin typeface="Apple SD Gothic Neo" pitchFamily="34" charset="0"/>
+                <a:ea typeface="Apple SD Gothic Neo" pitchFamily="34" charset="-122"/>
+                <a:cs typeface="Apple SD Gothic Neo" pitchFamily="34" charset="-120"/>
+              </a:rPr>
+              <a:t>원래는 이 가지를 버리고 끝. 다른 가지에서 같은 이유로 또 막힌다</a:t>
+            </a:r>
+            <a:endParaRPr lang="en-US" sz="1400" dirty="0"/>
+          </a:p>
+          <a:p>
+            <a:pPr marL="342900" indent="-342900">
+              <a:spcAft>
+                <a:spcPts val="600"/>
+              </a:spcAft>
+              <a:buSzPct val="100000"/>
+              <a:buChar char="•"/>
+            </a:pPr>
+            <a:r>
+              <a:rPr lang="en-US" sz="1400" dirty="0">
+                <a:solidFill>
+                  <a:schemeClr val="tx1"/>
+                </a:solidFill>
+                <a:latin typeface="Apple SD Gothic Neo" pitchFamily="34" charset="0"/>
+                <a:ea typeface="Apple SD Gothic Neo" pitchFamily="34" charset="-122"/>
+                <a:cs typeface="Apple SD Gothic Neo" pitchFamily="34" charset="-120"/>
+              </a:rPr>
+              <a:t>① 원인 찾기: 쌍대 광선에서 실제로 쓰인 경계만 원인 (A=1, B=0. C 는 무관)</a:t>
+            </a:r>
+            <a:endParaRPr lang="en-US" sz="1400" dirty="0"/>
+          </a:p>
+          <a:p>
+            <a:pPr marL="342900" indent="-342900">
+              <a:spcAft>
+                <a:spcPts val="600"/>
+              </a:spcAft>
+              <a:buSzPct val="100000"/>
+              <a:buChar char="•"/>
+            </a:pPr>
+            <a:r>
+              <a:rPr lang="en-US" sz="1400" dirty="0">
+                <a:solidFill>
+                  <a:schemeClr val="tx1"/>
+                </a:solidFill>
+                <a:latin typeface="Apple SD Gothic Neo" pitchFamily="34" charset="0"/>
+                <a:ea typeface="Apple SD Gothic Neo" pitchFamily="34" charset="-122"/>
+                <a:cs typeface="Apple SD Gothic Neo" pitchFamily="34" charset="-120"/>
+              </a:rPr>
+              <a:t>② 규칙으로 적기: A=1 이면서 B=0 은 불가 → (1−A) + B ≥ 1</a:t>
+            </a:r>
+            <a:endParaRPr lang="en-US" sz="1400" dirty="0"/>
+          </a:p>
+          <a:p>
+            <a:pPr marL="342900" indent="-342900">
+              <a:spcAft>
+                <a:spcPts val="600"/>
+              </a:spcAft>
+              <a:buSzPct val="100000"/>
+              <a:buChar char="•"/>
+            </a:pPr>
+            <a:r>
+              <a:rPr lang="en-US" sz="1400" dirty="0">
+                <a:solidFill>
+                  <a:schemeClr val="tx1"/>
+                </a:solidFill>
+                <a:latin typeface="Apple SD Gothic Neo" pitchFamily="34" charset="0"/>
+                <a:ea typeface="Apple SD Gothic Neo" pitchFamily="34" charset="-122"/>
+                <a:cs typeface="Apple SD Gothic Neo" pitchFamily="34" charset="-120"/>
+              </a:rPr>
+              <a:t>③ 이후 그 조합이 나오면 C 와 상관없이 바로 가지치기</a:t>
+            </a:r>
+            <a:endParaRPr lang="en-US" sz="1400" dirty="0"/>
+          </a:p>
+        </p:txBody>
+      </p:sp>
+    </p:spTree>
+  </p:cSld>
+  <p:clrMapOvr>
+    <a:masterClrMapping/>
+  </p:clrMapOvr>
+</p:sld>
+</file>
+
+<file path=ppt/slides/slide19.xml><?xml version="1.0" encoding="utf-8"?>
 <p:sld xmlns:a="http://schemas.openxmlformats.org/drawingml/2006/main" xmlns:r="http://schemas.openxmlformats.org/officeDocument/2006/relationships" xmlns:p="http://schemas.openxmlformats.org/presentationml/2006/main">
   <p:cSld name="Slide 17">
     <p:spTree>
@@ -10469,1394 +11524,6 @@
             <a:fld id="{F7021451-1387-4CA6-816F-3879F97B5CBC}" type="slidenum">
               <a:rPr b="0" lang="en-US"/>
               <a:t>17</a:t>
-            </a:fld>
-            <a:endParaRPr lang="en-US"/>
-          </a:p>
-        </p:txBody>
-      </p:sp>
-    </p:spTree>
-  </p:cSld>
-  <p:clrMapOvr>
-    <a:masterClrMapping/>
-  </p:clrMapOvr>
-</p:sld>
-</file>
-
-<file path=ppt/slides/slide18.xml><?xml version="1.0" encoding="utf-8"?>
-<p:sld xmlns:a="http://schemas.openxmlformats.org/drawingml/2006/main" xmlns:r="http://schemas.openxmlformats.org/officeDocument/2006/relationships" xmlns:p="http://schemas.openxmlformats.org/presentationml/2006/main">
-  <p:cSld name="Slide 18">
-    <p:spTree>
-      <p:nvGrpSpPr>
-        <p:cNvPr id="1" name=""/>
-        <p:cNvGrpSpPr/>
-        <p:nvPr/>
-      </p:nvGrpSpPr>
-      <p:grpSpPr>
-        <a:xfrm>
-          <a:off x="0" y="0"/>
-          <a:ext cx="0" cy="0"/>
-          <a:chOff x="0" y="0"/>
-          <a:chExt cx="0" cy="0"/>
-        </a:xfrm>
-      </p:grpSpPr>
-      <p:sp>
-        <p:nvSpPr>
-          <p:cNvPr id="2" name="Text 0"/>
-          <p:cNvSpPr/>
-          <p:nvPr>
-            <p:ph idx="100" type="title" hasCustomPrompt="1"/>
-          </p:nvPr>
-        </p:nvSpPr>
-        <p:spPr>
-          <a:xfrm>
-            <a:off x="548640" y="320040"/>
-            <a:ext cx="11064240" cy="822960"/>
-          </a:xfrm>
-          <a:prstGeom prst="rect">
-            <a:avLst/>
-          </a:prstGeom>
-          <a:noFill/>
-          <a:ln/>
-        </p:spPr>
-        <p:txBody>
-          <a:bodyPr wrap="square" rtlCol="0" anchor="ctr"/>
-          <a:lstStyle/>
-          <a:p>
-            <a:pPr indent="0" marL="0">
-              <a:buNone/>
-            </a:pPr>
-            <a:r>
-              <a:rPr lang="en-US" sz="3000" b="1" dirty="0">
-                <a:solidFill>
-                  <a:schemeClr val="tx2"/>
-                </a:solidFill>
-              </a:rPr>
-              <a:t>Conflict: 학습 제약과 효과</a:t>
-            </a:r>
-            <a:endParaRPr lang="en-US" sz="3000" dirty="0"/>
-          </a:p>
-        </p:txBody>
-      </p:sp>
-      <p:sp>
-        <p:nvSpPr>
-          <p:cNvPr id="4" name="formula card"/>
-          <p:cNvSpPr/>
-          <p:nvPr/>
-        </p:nvSpPr>
-        <p:spPr>
-          <a:xfrm>
-            <a:off x="548640" y="1371600"/>
-            <a:ext cx="6035040" cy="3108960"/>
-          </a:xfrm>
-          <a:prstGeom prst="roundRect">
-            <a:avLst>
-              <a:gd name="adj" fmla="val 3529"/>
-            </a:avLst>
-          </a:prstGeom>
-          <a:solidFill>
-            <a:schemeClr val="bg2"/>
-          </a:solidFill>
-          <a:ln w="12700">
-            <a:solidFill>
-              <a:schemeClr val="bg2"/>
-            </a:solidFill>
-            <a:prstDash val="solid"/>
-          </a:ln>
-        </p:spPr>
-      </p:sp>
-      <p:sp>
-        <p:nvSpPr>
-          <p:cNvPr id="5" name="Text 2"/>
-          <p:cNvSpPr txBox="1"/>
-          <p:nvPr/>
-        </p:nvSpPr>
-        <p:spPr>
-          <a:xfrm>
-            <a:off x="822960" y="1508760"/>
-            <a:ext cx="5486400" cy="320040"/>
-          </a:xfrm>
-          <a:prstGeom prst="rect">
-            <a:avLst/>
-          </a:prstGeom>
-          <a:noFill/>
-          <a:ln/>
-        </p:spPr>
-        <p:txBody>
-          <a:bodyPr wrap="square" lIns="0" tIns="0" rIns="0" bIns="0" rtlCol="0" anchor="ctr"/>
-          <a:lstStyle/>
-          <a:p>
-            <a:pPr indent="0" marL="0">
-              <a:buNone/>
-            </a:pPr>
-            <a:r>
-              <a:rPr lang="en-US" sz="1400" b="1" dirty="0">
-                <a:solidFill>
-                  <a:schemeClr val="accent1"/>
-                </a:solidFill>
-                <a:latin typeface="Apple SD Gothic Neo" pitchFamily="34" charset="0"/>
-                <a:ea typeface="Apple SD Gothic Neo" pitchFamily="34" charset="-122"/>
-                <a:cs typeface="Apple SD Gothic Neo" pitchFamily="34" charset="-120"/>
-              </a:rPr>
-              <a:t>원인 집합 → 제약</a:t>
-            </a:r>
-            <a:endParaRPr lang="en-US" sz="1400" dirty="0"/>
-          </a:p>
-        </p:txBody>
-      </p:sp>
-      <p:pic>
-        <p:nvPicPr>
-          <p:cNvPr id="6" name="eq c3" descr="c3">    </p:cNvPr>
-          <p:cNvPicPr>
-            <a:picLocks noChangeAspect="1"/>
-          </p:cNvPicPr>
-          <p:nvPr/>
-        </p:nvPicPr>
-        <p:blipFill>
-          <a:blip r:embed="rId1"/>
-          <a:stretch>
-            <a:fillRect/>
-          </a:stretch>
-        </p:blipFill>
-        <p:spPr>
-          <a:xfrm>
-            <a:off x="2277999" y="1901952"/>
-            <a:ext cx="2576322" cy="363474"/>
-          </a:xfrm>
-          <a:prstGeom prst="rect">
-            <a:avLst/>
-          </a:prstGeom>
-        </p:spPr>
-      </p:pic>
-      <p:sp>
-        <p:nvSpPr>
-          <p:cNvPr id="7" name="Text 3"/>
-          <p:cNvSpPr txBox="1"/>
-          <p:nvPr/>
-        </p:nvSpPr>
-        <p:spPr>
-          <a:xfrm>
-            <a:off x="777240" y="2704338"/>
-            <a:ext cx="5577840" cy="402336"/>
-          </a:xfrm>
-          <a:prstGeom prst="rect">
-            <a:avLst/>
-          </a:prstGeom>
-          <a:noFill/>
-          <a:ln/>
-        </p:spPr>
-        <p:txBody>
-          <a:bodyPr wrap="square" lIns="0" tIns="0" rIns="0" bIns="0" rtlCol="0" anchor="t"/>
-          <a:lstStyle/>
-          <a:p>
-            <a:pPr algn="ctr" indent="0" marL="0">
-              <a:buNone/>
-            </a:pPr>
-            <a:r>
-              <a:rPr lang="en-US" sz="1200" dirty="0">
-                <a:solidFill>
-                  <a:schemeClr val="accent3"/>
-                </a:solidFill>
-                <a:latin typeface="Apple SD Gothic Neo" pitchFamily="34" charset="0"/>
-                <a:ea typeface="Apple SD Gothic Neo" pitchFamily="34" charset="-122"/>
-                <a:cs typeface="Apple SD Gothic Neo" pitchFamily="34" charset="-120"/>
-              </a:rPr>
-              <a:t>z 가 정수라 바로 선형화할 수 없다</a:t>
-            </a:r>
-            <a:endParaRPr lang="en-US" sz="1200" dirty="0"/>
-          </a:p>
-        </p:txBody>
-      </p:sp>
-      <p:pic>
-        <p:nvPicPr>
-          <p:cNvPr id="8" name="eq c4" descr="c4">    </p:cNvPr>
-          <p:cNvPicPr>
-            <a:picLocks noChangeAspect="1"/>
-          </p:cNvPicPr>
-          <p:nvPr/>
-        </p:nvPicPr>
-        <p:blipFill>
-          <a:blip r:embed="rId2"/>
-          <a:stretch>
-            <a:fillRect/>
-          </a:stretch>
-        </p:blipFill>
-        <p:spPr>
-          <a:xfrm>
-            <a:off x="1729359" y="3159252"/>
-            <a:ext cx="3673602" cy="363474"/>
-          </a:xfrm>
-          <a:prstGeom prst="rect">
-            <a:avLst/>
-          </a:prstGeom>
-        </p:spPr>
-      </p:pic>
-      <p:sp>
-        <p:nvSpPr>
-          <p:cNvPr id="9" name="Text 4"/>
-          <p:cNvSpPr txBox="1"/>
-          <p:nvPr/>
-        </p:nvSpPr>
-        <p:spPr>
-          <a:xfrm>
-            <a:off x="777240" y="3961638"/>
-            <a:ext cx="5577840" cy="402336"/>
-          </a:xfrm>
-          <a:prstGeom prst="rect">
-            <a:avLst/>
-          </a:prstGeom>
-          <a:noFill/>
-          <a:ln/>
-        </p:spPr>
-        <p:txBody>
-          <a:bodyPr wrap="square" lIns="0" tIns="0" rIns="0" bIns="0" rtlCol="0" anchor="t"/>
-          <a:lstStyle/>
-          <a:p>
-            <a:pPr algn="ctr" indent="0" marL="0">
-              <a:buNone/>
-            </a:pPr>
-            <a:r>
-              <a:rPr lang="en-US" sz="1200" dirty="0">
-                <a:solidFill>
-                  <a:schemeClr val="accent3"/>
-                </a:solidFill>
-                <a:latin typeface="Apple SD Gothic Neo" pitchFamily="34" charset="0"/>
-                <a:ea typeface="Apple SD Gothic Neo" pitchFamily="34" charset="-122"/>
-                <a:cs typeface="Apple SD Gothic Neo" pitchFamily="34" charset="-120"/>
-              </a:rPr>
-              <a:t>논문이 택한 방법: x 변수만 남긴 cut B 로 선형화</a:t>
-            </a:r>
-            <a:endParaRPr lang="en-US" sz="1200" dirty="0"/>
-          </a:p>
-        </p:txBody>
-      </p:sp>
-      <p:sp>
-        <p:nvSpPr>
-          <p:cNvPr id="10" name="formula card"/>
-          <p:cNvSpPr/>
-          <p:nvPr/>
-        </p:nvSpPr>
-        <p:spPr>
-          <a:xfrm>
-            <a:off x="548640" y="4663440"/>
-            <a:ext cx="6035040" cy="1554480"/>
-          </a:xfrm>
-          <a:prstGeom prst="roundRect">
-            <a:avLst>
-              <a:gd name="adj" fmla="val 7059"/>
-            </a:avLst>
-          </a:prstGeom>
-          <a:solidFill>
-            <a:schemeClr val="bg2"/>
-          </a:solidFill>
-          <a:ln w="12700">
-            <a:solidFill>
-              <a:schemeClr val="bg2"/>
-            </a:solidFill>
-            <a:prstDash val="solid"/>
-          </a:ln>
-        </p:spPr>
-      </p:sp>
-      <p:sp>
-        <p:nvSpPr>
-          <p:cNvPr id="11" name="Text 6"/>
-          <p:cNvSpPr txBox="1"/>
-          <p:nvPr/>
-        </p:nvSpPr>
-        <p:spPr>
-          <a:xfrm>
-            <a:off x="822960" y="4800600"/>
-            <a:ext cx="5486400" cy="320040"/>
-          </a:xfrm>
-          <a:prstGeom prst="rect">
-            <a:avLst/>
-          </a:prstGeom>
-          <a:noFill/>
-          <a:ln/>
-        </p:spPr>
-        <p:txBody>
-          <a:bodyPr wrap="square" lIns="0" tIns="0" rIns="0" bIns="0" rtlCol="0" anchor="ctr"/>
-          <a:lstStyle/>
-          <a:p>
-            <a:pPr indent="0" marL="0">
-              <a:buNone/>
-            </a:pPr>
-            <a:r>
-              <a:rPr lang="en-US" sz="1400" b="1" dirty="0">
-                <a:solidFill>
-                  <a:schemeClr val="accent1"/>
-                </a:solidFill>
-                <a:latin typeface="Apple SD Gothic Neo" pitchFamily="34" charset="0"/>
-                <a:ea typeface="Apple SD Gothic Neo" pitchFamily="34" charset="-122"/>
-                <a:cs typeface="Apple SD Gothic Neo" pitchFamily="34" charset="-120"/>
-              </a:rPr>
-              <a:t>이진 변수만 있을 때의 일반형 (식 1)</a:t>
-            </a:r>
-            <a:endParaRPr lang="en-US" sz="1400" dirty="0"/>
-          </a:p>
-        </p:txBody>
-      </p:sp>
-      <p:pic>
-        <p:nvPicPr>
-          <p:cNvPr id="12" name="eq c5" descr="c5">    </p:cNvPr>
-          <p:cNvPicPr>
-            <a:picLocks noChangeAspect="1"/>
-          </p:cNvPicPr>
-          <p:nvPr/>
-        </p:nvPicPr>
-        <p:blipFill>
-          <a:blip r:embed="rId3"/>
-          <a:stretch>
-            <a:fillRect/>
-          </a:stretch>
-        </p:blipFill>
-        <p:spPr>
-          <a:xfrm>
-            <a:off x="1813941" y="5271516"/>
-            <a:ext cx="3504438" cy="749808"/>
-          </a:xfrm>
-          <a:prstGeom prst="rect">
-            <a:avLst/>
-          </a:prstGeom>
-        </p:spPr>
-      </p:pic>
-      <p:sp>
-        <p:nvSpPr>
-          <p:cNvPr id="13" name="Text 7"/>
-          <p:cNvSpPr txBox="1"/>
-          <p:nvPr/>
-        </p:nvSpPr>
-        <p:spPr>
-          <a:xfrm>
-            <a:off x="6949440" y="1463040"/>
-            <a:ext cx="2286000" cy="822960"/>
-          </a:xfrm>
-          <a:prstGeom prst="rect">
-            <a:avLst/>
-          </a:prstGeom>
-          <a:noFill/>
-          <a:ln/>
-        </p:spPr>
-        <p:txBody>
-          <a:bodyPr wrap="square" lIns="0" tIns="0" rIns="0" bIns="0" rtlCol="0" anchor="ctr"/>
-          <a:lstStyle/>
-          <a:p>
-            <a:pPr indent="0" marL="0">
-              <a:buNone/>
-            </a:pPr>
-            <a:r>
-              <a:rPr lang="en-US" sz="4400" b="1" dirty="0">
-                <a:solidFill>
-                  <a:schemeClr val="accent4"/>
-                </a:solidFill>
-                <a:latin typeface="Apple SD Gothic Neo" pitchFamily="34" charset="0"/>
-                <a:ea typeface="Apple SD Gothic Neo" pitchFamily="34" charset="-122"/>
-                <a:cs typeface="Apple SD Gothic Neo" pitchFamily="34" charset="-120"/>
-              </a:rPr>
-              <a:t>약 50%</a:t>
-            </a:r>
-            <a:endParaRPr lang="en-US" sz="4400" dirty="0"/>
-          </a:p>
-        </p:txBody>
-      </p:sp>
-      <p:sp>
-        <p:nvSpPr>
-          <p:cNvPr id="14" name="Text 8"/>
-          <p:cNvSpPr txBox="1"/>
-          <p:nvPr/>
-        </p:nvSpPr>
-        <p:spPr>
-          <a:xfrm>
-            <a:off x="6949440" y="2331720"/>
-            <a:ext cx="2286000" cy="822960"/>
-          </a:xfrm>
-          <a:prstGeom prst="rect">
-            <a:avLst/>
-          </a:prstGeom>
-          <a:noFill/>
-          <a:ln/>
-        </p:spPr>
-        <p:txBody>
-          <a:bodyPr wrap="square" lIns="0" tIns="0" rIns="0" bIns="0" rtlCol="0" anchor="t"/>
-          <a:lstStyle/>
-          <a:p>
-            <a:pPr indent="0" marL="0">
-              <a:buNone/>
-            </a:pPr>
-            <a:r>
-              <a:rPr lang="en-US" sz="1400" dirty="0">
-                <a:solidFill>
-                  <a:schemeClr val="tx1"/>
-                </a:solidFill>
-                <a:latin typeface="Apple SD Gothic Neo" pitchFamily="34" charset="0"/>
-                <a:ea typeface="Apple SD Gothic Neo" pitchFamily="34" charset="-122"/>
-                <a:cs typeface="Apple SD Gothic Neo" pitchFamily="34" charset="-120"/>
-              </a:rPr>
-              <a:t>노드 수 감소 (feasible 인스턴스, 기하평균)</a:t>
-            </a:r>
-            <a:endParaRPr lang="en-US" sz="1400" dirty="0"/>
-          </a:p>
-        </p:txBody>
-      </p:sp>
-      <p:sp>
-        <p:nvSpPr>
-          <p:cNvPr id="15" name="Text 9"/>
-          <p:cNvSpPr txBox="1"/>
-          <p:nvPr/>
-        </p:nvSpPr>
-        <p:spPr>
-          <a:xfrm>
-            <a:off x="9418320" y="1463040"/>
-            <a:ext cx="2194560" cy="822960"/>
-          </a:xfrm>
-          <a:prstGeom prst="rect">
-            <a:avLst/>
-          </a:prstGeom>
-          <a:noFill/>
-          <a:ln/>
-        </p:spPr>
-        <p:txBody>
-          <a:bodyPr wrap="square" lIns="0" tIns="0" rIns="0" bIns="0" rtlCol="0" anchor="ctr"/>
-          <a:lstStyle/>
-          <a:p>
-            <a:pPr indent="0" marL="0">
-              <a:buNone/>
-            </a:pPr>
-            <a:r>
-              <a:rPr lang="en-US" sz="4400" b="1" dirty="0">
-                <a:solidFill>
-                  <a:schemeClr val="accent5"/>
-                </a:solidFill>
-                <a:latin typeface="Apple SD Gothic Neo" pitchFamily="34" charset="0"/>
-                <a:ea typeface="Apple SD Gothic Neo" pitchFamily="34" charset="-122"/>
-                <a:cs typeface="Apple SD Gothic Neo" pitchFamily="34" charset="-120"/>
-              </a:rPr>
-              <a:t>약 +15%</a:t>
-            </a:r>
-            <a:endParaRPr lang="en-US" sz="4400" dirty="0"/>
-          </a:p>
-        </p:txBody>
-      </p:sp>
-      <p:sp>
-        <p:nvSpPr>
-          <p:cNvPr id="16" name="Text 10"/>
-          <p:cNvSpPr txBox="1"/>
-          <p:nvPr/>
-        </p:nvSpPr>
-        <p:spPr>
-          <a:xfrm>
-            <a:off x="9418320" y="2331720"/>
-            <a:ext cx="2194560" cy="822960"/>
-          </a:xfrm>
-          <a:prstGeom prst="rect">
-            <a:avLst/>
-          </a:prstGeom>
-          <a:noFill/>
-          <a:ln/>
-        </p:spPr>
-        <p:txBody>
-          <a:bodyPr wrap="square" lIns="0" tIns="0" rIns="0" bIns="0" rtlCol="0" anchor="t"/>
-          <a:lstStyle/>
-          <a:p>
-            <a:pPr indent="0" marL="0">
-              <a:buNone/>
-            </a:pPr>
-            <a:r>
-              <a:rPr lang="en-US" sz="1400" dirty="0">
-                <a:solidFill>
-                  <a:schemeClr val="tx1"/>
-                </a:solidFill>
-                <a:latin typeface="Apple SD Gothic Neo" pitchFamily="34" charset="0"/>
-                <a:ea typeface="Apple SD Gothic Neo" pitchFamily="34" charset="-122"/>
-                <a:cs typeface="Apple SD Gothic Neo" pitchFamily="34" charset="-120"/>
-              </a:rPr>
-              <a:t>시간은 오히려 증가</a:t>
-            </a:r>
-            <a:endParaRPr lang="en-US" sz="1400" dirty="0"/>
-          </a:p>
-        </p:txBody>
-      </p:sp>
-      <p:sp>
-        <p:nvSpPr>
-          <p:cNvPr id="17" name="alu card"/>
-          <p:cNvSpPr/>
-          <p:nvPr/>
-        </p:nvSpPr>
-        <p:spPr>
-          <a:xfrm>
-            <a:off x="6949440" y="3383280"/>
-            <a:ext cx="4663440" cy="2834640"/>
-          </a:xfrm>
-          <a:prstGeom prst="roundRect">
-            <a:avLst>
-              <a:gd name="adj" fmla="val 3871"/>
-            </a:avLst>
-          </a:prstGeom>
-          <a:solidFill>
-            <a:schemeClr val="bg2"/>
-          </a:solidFill>
-          <a:ln w="12700">
-            <a:solidFill>
-              <a:schemeClr val="bg2"/>
-            </a:solidFill>
-            <a:prstDash val="solid"/>
-          </a:ln>
-        </p:spPr>
-      </p:sp>
-      <p:sp>
-        <p:nvSpPr>
-          <p:cNvPr id="18" name="Text 12"/>
-          <p:cNvSpPr txBox="1"/>
-          <p:nvPr/>
-        </p:nvSpPr>
-        <p:spPr>
-          <a:xfrm>
-            <a:off x="7178040" y="3547872"/>
-            <a:ext cx="4206240" cy="365760"/>
-          </a:xfrm>
-          <a:prstGeom prst="rect">
-            <a:avLst/>
-          </a:prstGeom>
-          <a:noFill/>
-          <a:ln/>
-        </p:spPr>
-        <p:txBody>
-          <a:bodyPr wrap="square" lIns="0" tIns="0" rIns="0" bIns="0" rtlCol="0" anchor="ctr"/>
-          <a:lstStyle/>
-          <a:p>
-            <a:pPr indent="0" marL="0">
-              <a:buNone/>
-            </a:pPr>
-            <a:r>
-              <a:rPr lang="en-US" sz="1600" b="1" dirty="0">
-                <a:solidFill>
-                  <a:schemeClr val="accent1"/>
-                </a:solidFill>
-                <a:latin typeface="Apple SD Gothic Neo" pitchFamily="34" charset="0"/>
-                <a:ea typeface="Apple SD Gothic Neo" pitchFamily="34" charset="-122"/>
-                <a:cs typeface="Apple SD Gothic Neo" pitchFamily="34" charset="-120"/>
-              </a:rPr>
-              <a:t>infeasible 인스턴스는 다르다</a:t>
-            </a:r>
-            <a:endParaRPr lang="en-US" sz="1600" dirty="0"/>
-          </a:p>
-        </p:txBody>
-      </p:sp>
-      <p:sp>
-        <p:nvSpPr>
-          <p:cNvPr id="19" name="Text 13"/>
-          <p:cNvSpPr txBox="1"/>
-          <p:nvPr/>
-        </p:nvSpPr>
-        <p:spPr>
-          <a:xfrm>
-            <a:off x="7178040" y="4023360"/>
-            <a:ext cx="4206240" cy="2057400"/>
-          </a:xfrm>
-          <a:prstGeom prst="rect">
-            <a:avLst/>
-          </a:prstGeom>
-          <a:noFill/>
-          <a:ln/>
-        </p:spPr>
-        <p:txBody>
-          <a:bodyPr wrap="square" lIns="0" tIns="0" rIns="0" bIns="0" rtlCol="0" anchor="t"/>
-          <a:lstStyle/>
-          <a:p>
-            <a:pPr marL="342900" indent="-342900">
-              <a:spcAft>
-                <a:spcPts val="600"/>
-              </a:spcAft>
-              <a:buSzPct val="100000"/>
-              <a:buChar char="•"/>
-            </a:pPr>
-            <a:r>
-              <a:rPr lang="en-US" sz="1400" dirty="0">
-                <a:solidFill>
-                  <a:schemeClr val="tx1"/>
-                </a:solidFill>
-                <a:latin typeface="Apple SD Gothic Neo" pitchFamily="34" charset="0"/>
-                <a:ea typeface="Apple SD Gothic Neo" pitchFamily="34" charset="-122"/>
-                <a:cs typeface="Apple SD Gothic Neo" pitchFamily="34" charset="-120"/>
-              </a:rPr>
-              <a:t>ALU 검증 인스턴스에서 노드·시간 모두 크게 개선</a:t>
-            </a:r>
-            <a:endParaRPr lang="en-US" sz="1400" dirty="0"/>
-          </a:p>
-          <a:p>
-            <a:pPr marL="342900" indent="-342900">
-              <a:spcAft>
-                <a:spcPts val="600"/>
-              </a:spcAft>
-              <a:buSzPct val="100000"/>
-              <a:buChar char="•"/>
-            </a:pPr>
-            <a:r>
-              <a:rPr lang="en-US" sz="1400" dirty="0">
-                <a:solidFill>
-                  <a:schemeClr val="tx1"/>
-                </a:solidFill>
-                <a:latin typeface="Apple SD Gothic Neo" pitchFamily="34" charset="0"/>
-                <a:ea typeface="Apple SD Gothic Neo" pitchFamily="34" charset="-122"/>
-                <a:cs typeface="Apple SD Gothic Neo" pitchFamily="34" charset="-120"/>
-              </a:rPr>
-              <a:t>property 1 은 10비트도 쉽게, 기본 설정은 100만 노드 이상</a:t>
-            </a:r>
-            <a:endParaRPr lang="en-US" sz="1400" dirty="0"/>
-          </a:p>
-          <a:p>
-            <a:pPr marL="342900" indent="-342900">
-              <a:spcAft>
-                <a:spcPts val="600"/>
-              </a:spcAft>
-              <a:buSzPct val="100000"/>
-              <a:buChar char="•"/>
-            </a:pPr>
-            <a:r>
-              <a:rPr lang="en-US" sz="1400" dirty="0">
-                <a:solidFill>
-                  <a:schemeClr val="tx1"/>
-                </a:solidFill>
-                <a:latin typeface="Apple SD Gothic Neo" pitchFamily="34" charset="0"/>
-                <a:ea typeface="Apple SD Gothic Neo" pitchFamily="34" charset="-122"/>
-                <a:cs typeface="Apple SD Gothic Neo" pitchFamily="34" charset="-120"/>
-              </a:rPr>
-              <a:t>학습된 절이 매우 짧아서 트리를 크게 자르기 때문</a:t>
-            </a:r>
-            <a:endParaRPr lang="en-US" sz="1400" dirty="0"/>
-          </a:p>
-        </p:txBody>
-      </p:sp>
-      <p:sp>
-        <p:nvSpPr>
-          <p:cNvPr id="20" name="Text 14"/>
-          <p:cNvSpPr txBox="1"/>
-          <p:nvPr/>
-        </p:nvSpPr>
-        <p:spPr>
-          <a:xfrm>
-            <a:off x="548640" y="6355080"/>
-            <a:ext cx="10607040" cy="274320"/>
-          </a:xfrm>
-          <a:prstGeom prst="rect">
-            <a:avLst/>
-          </a:prstGeom>
-          <a:noFill/>
-          <a:ln/>
-        </p:spPr>
-        <p:txBody>
-          <a:bodyPr wrap="square" lIns="0" tIns="0" rIns="0" bIns="0" rtlCol="0" anchor="ctr"/>
-          <a:lstStyle/>
-          <a:p>
-            <a:pPr indent="0" marL="0">
-              <a:buNone/>
-            </a:pPr>
-            <a:r>
-              <a:rPr lang="en-US" sz="1000" dirty="0">
-                <a:solidFill>
-                  <a:schemeClr val="accent3"/>
-                </a:solidFill>
-                <a:latin typeface="Apple SD Gothic Neo" pitchFamily="34" charset="0"/>
-                <a:ea typeface="Apple SD Gothic Neo" pitchFamily="34" charset="-122"/>
-                <a:cs typeface="Apple SD Gothic Neo" pitchFamily="34" charset="-120"/>
-              </a:rPr>
-              <a:t>Achterberg (2007; ZIB 05-19), 3.4절·Example 3.7, 4장 Table 1·3</a:t>
-            </a:r>
-            <a:endParaRPr lang="en-US" sz="1000" dirty="0"/>
-          </a:p>
-        </p:txBody>
-      </p:sp>
-      <p:sp>
-        <p:nvSpPr>
-          <p:cNvPr id="25" name="Slide Number Placeholder 0"/>
-          <p:cNvSpPr>
-            <a:spLocks noGrp="1"/>
-          </p:cNvSpPr>
-          <p:nvPr>
-            <p:ph type="sldNum" sz="quarter" idx="4294967295"/>
-          </p:nvPr>
-        </p:nvSpPr>
-        <p:spPr>
-          <a:xfrm>
-            <a:off x="11338560" y="6400800"/>
-            <a:ext cx="548640" cy="274320"/>
-          </a:xfrm>
-          <a:prstGeom prst="rect">
-            <a:avLst/>
-          </a:prstGeom>
-          <a:extLst>
-            <a:ext uri="{C572A759-6A51-4108-AA02-DFA0A04FC94B}">
-              <ma14:wrappingTextBoxFlag xmlns:ma14="http://schemas.microsoft.com/office/mac/drawingml/2011/main" val="0"/>
-            </a:ext>
-          </a:extLst>
-        </p:spPr>
-        <p:txBody>
-          <a:bodyPr/>
-          <a:lstStyle>
-            <a:lvl1pPr>
-              <a:defRPr sz="1000">
-                <a:solidFill>
-                  <a:schemeClr val="accent3"/>
-                </a:solidFill>
-              </a:defRPr>
-            </a:lvl1pPr>
-          </a:lstStyle>
-          <a:p>
-            <a:pPr algn="r"/>
-            <a:fld id="{F7021451-1387-4CA6-816F-3879F97B5CBC}" type="slidenum">
-              <a:rPr b="0" lang="en-US"/>
-              <a:t>18</a:t>
-            </a:fld>
-            <a:endParaRPr lang="en-US"/>
-          </a:p>
-        </p:txBody>
-      </p:sp>
-    </p:spTree>
-  </p:cSld>
-  <p:clrMapOvr>
-    <a:masterClrMapping/>
-  </p:clrMapOvr>
-</p:sld>
-</file>
-
-<file path=ppt/slides/slide19.xml><?xml version="1.0" encoding="utf-8"?>
-<p:sld xmlns:a="http://schemas.openxmlformats.org/drawingml/2006/main" xmlns:r="http://schemas.openxmlformats.org/officeDocument/2006/relationships" xmlns:p="http://schemas.openxmlformats.org/presentationml/2006/main">
-  <p:cSld name="Slide 19">
-    <p:spTree>
-      <p:nvGrpSpPr>
-        <p:cNvPr id="1" name=""/>
-        <p:cNvGrpSpPr/>
-        <p:nvPr/>
-      </p:nvGrpSpPr>
-      <p:grpSpPr>
-        <a:xfrm>
-          <a:off x="0" y="0"/>
-          <a:ext cx="0" cy="0"/>
-          <a:chOff x="0" y="0"/>
-          <a:chExt cx="0" cy="0"/>
-        </a:xfrm>
-      </p:grpSpPr>
-      <p:sp>
-        <p:nvSpPr>
-          <p:cNvPr id="2" name="Text 0"/>
-          <p:cNvSpPr/>
-          <p:nvPr>
-            <p:ph idx="100" type="title" hasCustomPrompt="1"/>
-          </p:nvPr>
-        </p:nvSpPr>
-        <p:spPr>
-          <a:xfrm>
-            <a:off x="548640" y="320040"/>
-            <a:ext cx="11064240" cy="822960"/>
-          </a:xfrm>
-          <a:prstGeom prst="rect">
-            <a:avLst/>
-          </a:prstGeom>
-          <a:noFill/>
-          <a:ln/>
-        </p:spPr>
-        <p:txBody>
-          <a:bodyPr wrap="square" rtlCol="0" anchor="ctr"/>
-          <a:lstStyle/>
-          <a:p>
-            <a:pPr indent="0" marL="0">
-              <a:buNone/>
-            </a:pPr>
-            <a:r>
-              <a:rPr lang="en-US" sz="3000" b="1" dirty="0">
-                <a:solidFill>
-                  <a:schemeClr val="tx2"/>
-                </a:solidFill>
-              </a:rPr>
-              <a:t>대칭성: 논문의 Example 9와 Orbital fixing</a:t>
-            </a:r>
-            <a:endParaRPr lang="en-US" sz="3000" dirty="0"/>
-          </a:p>
-        </p:txBody>
-      </p:sp>
-      <p:sp>
-        <p:nvSpPr>
-          <p:cNvPr id="4" name="formula card"/>
-          <p:cNvSpPr/>
-          <p:nvPr/>
-        </p:nvSpPr>
-        <p:spPr>
-          <a:xfrm>
-            <a:off x="548640" y="1371600"/>
-            <a:ext cx="6309360" cy="4846320"/>
-          </a:xfrm>
-          <a:prstGeom prst="roundRect">
-            <a:avLst>
-              <a:gd name="adj" fmla="val 2264"/>
-            </a:avLst>
-          </a:prstGeom>
-          <a:solidFill>
-            <a:schemeClr val="bg2"/>
-          </a:solidFill>
-          <a:ln w="12700">
-            <a:solidFill>
-              <a:schemeClr val="bg2"/>
-            </a:solidFill>
-            <a:prstDash val="solid"/>
-          </a:ln>
-        </p:spPr>
-      </p:sp>
-      <p:sp>
-        <p:nvSpPr>
-          <p:cNvPr id="5" name="Text 2"/>
-          <p:cNvSpPr txBox="1"/>
-          <p:nvPr/>
-        </p:nvSpPr>
-        <p:spPr>
-          <a:xfrm>
-            <a:off x="822960" y="1508760"/>
-            <a:ext cx="5760720" cy="320040"/>
-          </a:xfrm>
-          <a:prstGeom prst="rect">
-            <a:avLst/>
-          </a:prstGeom>
-          <a:noFill/>
-          <a:ln/>
-        </p:spPr>
-        <p:txBody>
-          <a:bodyPr wrap="square" lIns="0" tIns="0" rIns="0" bIns="0" rtlCol="0" anchor="ctr"/>
-          <a:lstStyle/>
-          <a:p>
-            <a:pPr indent="0" marL="0">
-              <a:buNone/>
-            </a:pPr>
-            <a:r>
-              <a:rPr lang="en-US" sz="1400" b="1" dirty="0">
-                <a:solidFill>
-                  <a:schemeClr val="accent1"/>
-                </a:solidFill>
-                <a:latin typeface="Apple SD Gothic Neo" pitchFamily="34" charset="0"/>
-                <a:ea typeface="Apple SD Gothic Neo" pitchFamily="34" charset="-122"/>
-                <a:cs typeface="Apple SD Gothic Neo" pitchFamily="34" charset="-120"/>
-              </a:rPr>
-              <a:t>Example 9: 대칭 변수를 하나로 합친다</a:t>
-            </a:r>
-            <a:endParaRPr lang="en-US" sz="1400" dirty="0"/>
-          </a:p>
-        </p:txBody>
-      </p:sp>
-      <p:pic>
-        <p:nvPicPr>
-          <p:cNvPr id="6" name="eq ex9a" descr="ex9a">    </p:cNvPr>
-          <p:cNvPicPr>
-            <a:picLocks noChangeAspect="1"/>
-          </p:cNvPicPr>
-          <p:nvPr/>
-        </p:nvPicPr>
-        <p:blipFill>
-          <a:blip r:embed="rId1"/>
-          <a:stretch>
-            <a:fillRect/>
-          </a:stretch>
-        </p:blipFill>
-        <p:spPr>
-          <a:xfrm>
-            <a:off x="777240" y="2126556"/>
-            <a:ext cx="5852160" cy="346321"/>
-          </a:xfrm>
-          <a:prstGeom prst="rect">
-            <a:avLst/>
-          </a:prstGeom>
-        </p:spPr>
-      </p:pic>
-      <p:pic>
-        <p:nvPicPr>
-          <p:cNvPr id="7" name="eq ex9b" descr="ex9b">    </p:cNvPr>
-          <p:cNvPicPr>
-            <a:picLocks noChangeAspect="1"/>
-          </p:cNvPicPr>
-          <p:nvPr/>
-        </p:nvPicPr>
-        <p:blipFill>
-          <a:blip r:embed="rId2"/>
-          <a:stretch>
-            <a:fillRect/>
-          </a:stretch>
-        </p:blipFill>
-        <p:spPr>
-          <a:xfrm>
-            <a:off x="1728216" y="2970657"/>
-            <a:ext cx="3950208" cy="358902"/>
-          </a:xfrm>
-          <a:prstGeom prst="rect">
-            <a:avLst/>
-          </a:prstGeom>
-        </p:spPr>
-      </p:pic>
-      <p:pic>
-        <p:nvPicPr>
-          <p:cNvPr id="8" name="eq ex9c" descr="ex9c">    </p:cNvPr>
-          <p:cNvPicPr>
-            <a:picLocks noChangeAspect="1"/>
-          </p:cNvPicPr>
-          <p:nvPr/>
-        </p:nvPicPr>
-        <p:blipFill>
-          <a:blip r:embed="rId3"/>
-          <a:stretch>
-            <a:fillRect/>
-          </a:stretch>
-        </p:blipFill>
-        <p:spPr>
-          <a:xfrm>
-            <a:off x="1728216" y="3821049"/>
-            <a:ext cx="3950208" cy="358902"/>
-          </a:xfrm>
-          <a:prstGeom prst="rect">
-            <a:avLst/>
-          </a:prstGeom>
-        </p:spPr>
-      </p:pic>
-      <p:pic>
-        <p:nvPicPr>
-          <p:cNvPr id="9" name="eq ex9d" descr="ex9d">    </p:cNvPr>
-          <p:cNvPicPr>
-            <a:picLocks noChangeAspect="1"/>
-          </p:cNvPicPr>
-          <p:nvPr/>
-        </p:nvPicPr>
-        <p:blipFill>
-          <a:blip r:embed="rId4"/>
-          <a:stretch>
-            <a:fillRect/>
-          </a:stretch>
-        </p:blipFill>
-        <p:spPr>
-          <a:xfrm>
-            <a:off x="777240" y="4453128"/>
-            <a:ext cx="5852160" cy="359264"/>
-          </a:xfrm>
-          <a:prstGeom prst="rect">
-            <a:avLst/>
-          </a:prstGeom>
-        </p:spPr>
-      </p:pic>
-      <p:sp>
-        <p:nvSpPr>
-          <p:cNvPr id="10" name="Text 3"/>
-          <p:cNvSpPr txBox="1"/>
-          <p:nvPr/>
-        </p:nvSpPr>
-        <p:spPr>
-          <a:xfrm>
-            <a:off x="777240" y="4986955"/>
-            <a:ext cx="5852160" cy="272125"/>
-          </a:xfrm>
-          <a:prstGeom prst="rect">
-            <a:avLst/>
-          </a:prstGeom>
-          <a:noFill/>
-          <a:ln/>
-        </p:spPr>
-        <p:txBody>
-          <a:bodyPr wrap="square" lIns="0" tIns="0" rIns="0" bIns="0" rtlCol="0" anchor="t"/>
-          <a:lstStyle/>
-          <a:p>
-            <a:pPr algn="ctr" indent="0" marL="0">
-              <a:buNone/>
-            </a:pPr>
-            <a:r>
-              <a:rPr lang="en-US" sz="1200" dirty="0">
-                <a:solidFill>
-                  <a:schemeClr val="accent3"/>
-                </a:solidFill>
-                <a:latin typeface="Apple SD Gothic Neo" pitchFamily="34" charset="0"/>
-                <a:ea typeface="Apple SD Gothic Neo" pitchFamily="34" charset="-122"/>
-                <a:cs typeface="Apple SD Gothic Neo" pitchFamily="34" charset="-120"/>
-              </a:rPr>
-              <a:t>x₁↔x₂, x₃↔x₄ 를 바꾸고 행을 바꾸면 원래 식</a:t>
-            </a:r>
-            <a:endParaRPr lang="en-US" sz="1200" dirty="0"/>
-          </a:p>
-        </p:txBody>
-      </p:sp>
-      <p:pic>
-        <p:nvPicPr>
-          <p:cNvPr id="11" name="eq ex9e" descr="ex9e">    </p:cNvPr>
-          <p:cNvPicPr>
-            <a:picLocks noChangeAspect="1"/>
-          </p:cNvPicPr>
-          <p:nvPr/>
-        </p:nvPicPr>
-        <p:blipFill>
-          <a:blip r:embed="rId5"/>
-          <a:stretch>
-            <a:fillRect/>
-          </a:stretch>
-        </p:blipFill>
-        <p:spPr>
-          <a:xfrm>
-            <a:off x="1480185" y="5303520"/>
-            <a:ext cx="4446270" cy="358902"/>
-          </a:xfrm>
-          <a:prstGeom prst="rect">
-            <a:avLst/>
-          </a:prstGeom>
-        </p:spPr>
-      </p:pic>
-      <p:sp>
-        <p:nvSpPr>
-          <p:cNvPr id="12" name="Text 4"/>
-          <p:cNvSpPr txBox="1"/>
-          <p:nvPr/>
-        </p:nvSpPr>
-        <p:spPr>
-          <a:xfrm>
-            <a:off x="777240" y="5837347"/>
-            <a:ext cx="5852160" cy="272125"/>
-          </a:xfrm>
-          <a:prstGeom prst="rect">
-            <a:avLst/>
-          </a:prstGeom>
-          <a:noFill/>
-          <a:ln/>
-        </p:spPr>
-        <p:txBody>
-          <a:bodyPr wrap="square" lIns="0" tIns="0" rIns="0" bIns="0" rtlCol="0" anchor="t"/>
-          <a:lstStyle/>
-          <a:p>
-            <a:pPr algn="ctr" indent="0" marL="0">
-              <a:buNone/>
-            </a:pPr>
-            <a:r>
-              <a:rPr lang="en-US" sz="1200" dirty="0">
-                <a:solidFill>
-                  <a:schemeClr val="accent3"/>
-                </a:solidFill>
-                <a:latin typeface="Apple SD Gothic Neo" pitchFamily="34" charset="0"/>
-                <a:ea typeface="Apple SD Gothic Neo" pitchFamily="34" charset="-122"/>
-                <a:cs typeface="Apple SD Gothic Neo" pitchFamily="34" charset="-120"/>
-              </a:rPr>
-              <a:t>합친 뒤 두 제약이 같아져 하나가 삭제된다</a:t>
-            </a:r>
-            <a:endParaRPr lang="en-US" sz="1200" dirty="0"/>
-          </a:p>
-        </p:txBody>
-      </p:sp>
-      <p:sp>
-        <p:nvSpPr>
-          <p:cNvPr id="13" name="formula card"/>
-          <p:cNvSpPr/>
-          <p:nvPr/>
-        </p:nvSpPr>
-        <p:spPr>
-          <a:xfrm>
-            <a:off x="7132320" y="1371600"/>
-            <a:ext cx="4480560" cy="1828800"/>
-          </a:xfrm>
-          <a:prstGeom prst="roundRect">
-            <a:avLst>
-              <a:gd name="adj" fmla="val 6000"/>
-            </a:avLst>
-          </a:prstGeom>
-          <a:solidFill>
-            <a:schemeClr val="bg2"/>
-          </a:solidFill>
-          <a:ln w="12700">
-            <a:solidFill>
-              <a:schemeClr val="bg2"/>
-            </a:solidFill>
-            <a:prstDash val="solid"/>
-          </a:ln>
-        </p:spPr>
-      </p:sp>
-      <p:sp>
-        <p:nvSpPr>
-          <p:cNvPr id="14" name="Text 6"/>
-          <p:cNvSpPr txBox="1"/>
-          <p:nvPr/>
-        </p:nvSpPr>
-        <p:spPr>
-          <a:xfrm>
-            <a:off x="7406640" y="1508760"/>
-            <a:ext cx="3931920" cy="320040"/>
-          </a:xfrm>
-          <a:prstGeom prst="rect">
-            <a:avLst/>
-          </a:prstGeom>
-          <a:noFill/>
-          <a:ln/>
-        </p:spPr>
-        <p:txBody>
-          <a:bodyPr wrap="square" lIns="0" tIns="0" rIns="0" bIns="0" rtlCol="0" anchor="ctr"/>
-          <a:lstStyle/>
-          <a:p>
-            <a:pPr indent="0" marL="0">
-              <a:buNone/>
-            </a:pPr>
-            <a:r>
-              <a:rPr lang="en-US" sz="1400" b="1" dirty="0">
-                <a:solidFill>
-                  <a:schemeClr val="accent1"/>
-                </a:solidFill>
-                <a:latin typeface="Apple SD Gothic Neo" pitchFamily="34" charset="0"/>
-                <a:ea typeface="Apple SD Gothic Neo" pitchFamily="34" charset="-122"/>
-                <a:cs typeface="Apple SD Gothic Neo" pitchFamily="34" charset="-120"/>
-              </a:rPr>
-              <a:t>Orbital fixing (Margot 도입)</a:t>
-            </a:r>
-            <a:endParaRPr lang="en-US" sz="1400" dirty="0"/>
-          </a:p>
-        </p:txBody>
-      </p:sp>
-      <p:pic>
-        <p:nvPicPr>
-          <p:cNvPr id="15" name="eq orb" descr="orb">    </p:cNvPr>
-          <p:cNvPicPr>
-            <a:picLocks noChangeAspect="1"/>
-          </p:cNvPicPr>
-          <p:nvPr/>
-        </p:nvPicPr>
-        <p:blipFill>
-          <a:blip r:embed="rId6"/>
-          <a:stretch>
-            <a:fillRect/>
-          </a:stretch>
-        </p:blipFill>
-        <p:spPr>
-          <a:xfrm>
-            <a:off x="7360920" y="2288582"/>
-            <a:ext cx="4023360" cy="406315"/>
-          </a:xfrm>
-          <a:prstGeom prst="rect">
-            <a:avLst/>
-          </a:prstGeom>
-        </p:spPr>
-      </p:pic>
-      <p:sp>
-        <p:nvSpPr>
-          <p:cNvPr id="16" name="orbres card"/>
-          <p:cNvSpPr/>
-          <p:nvPr/>
-        </p:nvSpPr>
-        <p:spPr>
-          <a:xfrm>
-            <a:off x="7132320" y="3383280"/>
-            <a:ext cx="4480560" cy="2834640"/>
-          </a:xfrm>
-          <a:prstGeom prst="roundRect">
-            <a:avLst>
-              <a:gd name="adj" fmla="val 3871"/>
-            </a:avLst>
-          </a:prstGeom>
-          <a:solidFill>
-            <a:schemeClr val="bg2"/>
-          </a:solidFill>
-          <a:ln w="12700">
-            <a:solidFill>
-              <a:schemeClr val="bg2"/>
-            </a:solidFill>
-            <a:prstDash val="solid"/>
-          </a:ln>
-        </p:spPr>
-      </p:sp>
-      <p:sp>
-        <p:nvSpPr>
-          <p:cNvPr id="17" name="Text 8"/>
-          <p:cNvSpPr txBox="1"/>
-          <p:nvPr/>
-        </p:nvSpPr>
-        <p:spPr>
-          <a:xfrm>
-            <a:off x="7360920" y="3547872"/>
-            <a:ext cx="4023360" cy="365760"/>
-          </a:xfrm>
-          <a:prstGeom prst="rect">
-            <a:avLst/>
-          </a:prstGeom>
-          <a:noFill/>
-          <a:ln/>
-        </p:spPr>
-        <p:txBody>
-          <a:bodyPr wrap="square" lIns="0" tIns="0" rIns="0" bIns="0" rtlCol="0" anchor="ctr"/>
-          <a:lstStyle/>
-          <a:p>
-            <a:pPr indent="0" marL="0">
-              <a:buNone/>
-            </a:pPr>
-            <a:r>
-              <a:rPr lang="en-US" sz="1600" b="1" dirty="0">
-                <a:solidFill>
-                  <a:schemeClr val="accent2"/>
-                </a:solidFill>
-                <a:latin typeface="Apple SD Gothic Neo" pitchFamily="34" charset="0"/>
-                <a:ea typeface="Apple SD Gothic Neo" pitchFamily="34" charset="-122"/>
-                <a:cs typeface="Apple SD Gothic Neo" pitchFamily="34" charset="-120"/>
-              </a:rPr>
-              <a:t>효과 (10초 이상 구간)</a:t>
-            </a:r>
-            <a:endParaRPr lang="en-US" sz="1600" dirty="0"/>
-          </a:p>
-        </p:txBody>
-      </p:sp>
-      <p:sp>
-        <p:nvSpPr>
-          <p:cNvPr id="18" name="Text 9"/>
-          <p:cNvSpPr txBox="1"/>
-          <p:nvPr/>
-        </p:nvSpPr>
-        <p:spPr>
-          <a:xfrm>
-            <a:off x="7360920" y="4023360"/>
-            <a:ext cx="4023360" cy="2057400"/>
-          </a:xfrm>
-          <a:prstGeom prst="rect">
-            <a:avLst/>
-          </a:prstGeom>
-          <a:noFill/>
-          <a:ln/>
-        </p:spPr>
-        <p:txBody>
-          <a:bodyPr wrap="square" lIns="0" tIns="0" rIns="0" bIns="0" rtlCol="0" anchor="t"/>
-          <a:lstStyle/>
-          <a:p>
-            <a:pPr marL="342900" indent="-342900">
-              <a:spcAft>
-                <a:spcPts val="600"/>
-              </a:spcAft>
-              <a:buSzPct val="100000"/>
-              <a:buChar char="•"/>
-            </a:pPr>
-            <a:r>
-              <a:rPr lang="en-US" sz="1400" dirty="0">
-                <a:solidFill>
-                  <a:schemeClr val="tx1"/>
-                </a:solidFill>
-                <a:latin typeface="Apple SD Gothic Neo" pitchFamily="34" charset="0"/>
-                <a:ea typeface="Apple SD Gothic Neo" pitchFamily="34" charset="-122"/>
-                <a:cs typeface="Apple SD Gothic Neo" pitchFamily="34" charset="-120"/>
-              </a:rPr>
-              <a:t>모델의 약 20%에 적용, 그 모델에서 시간 1.77배 차이</a:t>
-            </a:r>
-            <a:endParaRPr lang="en-US" sz="1400" dirty="0"/>
-          </a:p>
-          <a:p>
-            <a:pPr marL="342900" indent="-342900">
-              <a:spcAft>
-                <a:spcPts val="600"/>
-              </a:spcAft>
-              <a:buSzPct val="100000"/>
-              <a:buChar char="•"/>
-            </a:pPr>
-            <a:r>
-              <a:rPr lang="en-US" sz="1400" dirty="0">
-                <a:solidFill>
-                  <a:schemeClr val="tx1"/>
-                </a:solidFill>
-                <a:latin typeface="Apple SD Gothic Neo" pitchFamily="34" charset="0"/>
-                <a:ea typeface="Apple SD Gothic Neo" pitchFamily="34" charset="-122"/>
-                <a:cs typeface="Apple SD Gothic Neo" pitchFamily="34" charset="-120"/>
-              </a:rPr>
-              <a:t>끄면 시간 초과 모델이 37개 늘어난다</a:t>
-            </a:r>
-            <a:endParaRPr lang="en-US" sz="1400" dirty="0"/>
-          </a:p>
-          <a:p>
-            <a:pPr marL="342900" indent="-342900">
-              <a:spcAft>
-                <a:spcPts val="600"/>
-              </a:spcAft>
-              <a:buSzPct val="100000"/>
-              <a:buChar char="•"/>
-            </a:pPr>
-            <a:r>
-              <a:rPr lang="en-US" sz="1400" dirty="0">
-                <a:solidFill>
-                  <a:schemeClr val="tx1"/>
-                </a:solidFill>
-                <a:latin typeface="Apple SD Gothic Neo" pitchFamily="34" charset="0"/>
-                <a:ea typeface="Apple SD Gothic Neo" pitchFamily="34" charset="-122"/>
-                <a:cs typeface="Apple SD Gothic Neo" pitchFamily="34" charset="-120"/>
-              </a:rPr>
-              <a:t>대칭 기법은 일부 모델에만 듣지만 듣는 곳에서 크다</a:t>
-            </a:r>
-            <a:endParaRPr lang="en-US" sz="1400" dirty="0"/>
-          </a:p>
-        </p:txBody>
-      </p:sp>
-      <p:sp>
-        <p:nvSpPr>
-          <p:cNvPr id="19" name="Text 10"/>
-          <p:cNvSpPr txBox="1"/>
-          <p:nvPr/>
-        </p:nvSpPr>
-        <p:spPr>
-          <a:xfrm>
-            <a:off x="548640" y="6355080"/>
-            <a:ext cx="10607040" cy="274320"/>
-          </a:xfrm>
-          <a:prstGeom prst="rect">
-            <a:avLst/>
-          </a:prstGeom>
-          <a:noFill/>
-          <a:ln/>
-        </p:spPr>
-        <p:txBody>
-          <a:bodyPr wrap="square" lIns="0" tIns="0" rIns="0" bIns="0" rtlCol="0" anchor="ctr"/>
-          <a:lstStyle/>
-          <a:p>
-            <a:pPr indent="0" marL="0">
-              <a:buNone/>
-            </a:pPr>
-            <a:r>
-              <a:rPr lang="en-US" sz="1000" dirty="0">
-                <a:solidFill>
-                  <a:schemeClr val="accent3"/>
-                </a:solidFill>
-                <a:latin typeface="Apple SD Gothic Neo" pitchFamily="34" charset="0"/>
-                <a:ea typeface="Apple SD Gothic Neo" pitchFamily="34" charset="-122"/>
-                <a:cs typeface="Apple SD Gothic Neo" pitchFamily="34" charset="-120"/>
-              </a:rPr>
-              <a:t>Achterberg et al. (ZIB 16-44), 7.1절 Example 9·Table 28, 8.2절 Table 36 · Margot(2003)은 2차 인용</a:t>
-            </a:r>
-            <a:endParaRPr lang="en-US" sz="1000" dirty="0"/>
-          </a:p>
-        </p:txBody>
-      </p:sp>
-      <p:sp>
-        <p:nvSpPr>
-          <p:cNvPr id="25" name="Slide Number Placeholder 0"/>
-          <p:cNvSpPr>
-            <a:spLocks noGrp="1"/>
-          </p:cNvSpPr>
-          <p:nvPr>
-            <p:ph type="sldNum" sz="quarter" idx="4294967295"/>
-          </p:nvPr>
-        </p:nvSpPr>
-        <p:spPr>
-          <a:xfrm>
-            <a:off x="11338560" y="6400800"/>
-            <a:ext cx="548640" cy="274320"/>
-          </a:xfrm>
-          <a:prstGeom prst="rect">
-            <a:avLst/>
-          </a:prstGeom>
-          <a:extLst>
-            <a:ext uri="{C572A759-6A51-4108-AA02-DFA0A04FC94B}">
-              <ma14:wrappingTextBoxFlag xmlns:ma14="http://schemas.microsoft.com/office/mac/drawingml/2011/main" val="0"/>
-            </a:ext>
-          </a:extLst>
-        </p:spPr>
-        <p:txBody>
-          <a:bodyPr/>
-          <a:lstStyle>
-            <a:lvl1pPr>
-              <a:defRPr sz="1000">
-                <a:solidFill>
-                  <a:schemeClr val="accent3"/>
-                </a:solidFill>
-              </a:defRPr>
-            </a:lvl1pPr>
-          </a:lstStyle>
-          <a:p>
-            <a:pPr algn="r"/>
-            <a:fld id="{F7021451-1387-4CA6-816F-3879F97B5CBC}" type="slidenum">
-              <a:rPr b="0" lang="en-US"/>
-              <a:t>19</a:t>
             </a:fld>
             <a:endParaRPr lang="en-US"/>
           </a:p>
@@ -12426,6 +12093,1394 @@
 
 <file path=ppt/slides/slide20.xml><?xml version="1.0" encoding="utf-8"?>
 <p:sld xmlns:a="http://schemas.openxmlformats.org/drawingml/2006/main" xmlns:r="http://schemas.openxmlformats.org/officeDocument/2006/relationships" xmlns:p="http://schemas.openxmlformats.org/presentationml/2006/main">
+  <p:cSld name="Slide 18">
+    <p:spTree>
+      <p:nvGrpSpPr>
+        <p:cNvPr id="1" name=""/>
+        <p:cNvGrpSpPr/>
+        <p:nvPr/>
+      </p:nvGrpSpPr>
+      <p:grpSpPr>
+        <a:xfrm>
+          <a:off x="0" y="0"/>
+          <a:ext cx="0" cy="0"/>
+          <a:chOff x="0" y="0"/>
+          <a:chExt cx="0" cy="0"/>
+        </a:xfrm>
+      </p:grpSpPr>
+      <p:sp>
+        <p:nvSpPr>
+          <p:cNvPr id="2" name="Text 0"/>
+          <p:cNvSpPr/>
+          <p:nvPr>
+            <p:ph idx="100" type="title" hasCustomPrompt="1"/>
+          </p:nvPr>
+        </p:nvSpPr>
+        <p:spPr>
+          <a:xfrm>
+            <a:off x="548640" y="320040"/>
+            <a:ext cx="11064240" cy="822960"/>
+          </a:xfrm>
+          <a:prstGeom prst="rect">
+            <a:avLst/>
+          </a:prstGeom>
+          <a:noFill/>
+          <a:ln/>
+        </p:spPr>
+        <p:txBody>
+          <a:bodyPr wrap="square" rtlCol="0" anchor="ctr"/>
+          <a:lstStyle/>
+          <a:p>
+            <a:pPr indent="0" marL="0">
+              <a:buNone/>
+            </a:pPr>
+            <a:r>
+              <a:rPr lang="en-US" sz="3000" b="1" dirty="0">
+                <a:solidFill>
+                  <a:schemeClr val="tx2"/>
+                </a:solidFill>
+              </a:rPr>
+              <a:t>Conflict: 학습 제약과 효과</a:t>
+            </a:r>
+            <a:endParaRPr lang="en-US" sz="3000" dirty="0"/>
+          </a:p>
+        </p:txBody>
+      </p:sp>
+      <p:sp>
+        <p:nvSpPr>
+          <p:cNvPr id="4" name="formula card"/>
+          <p:cNvSpPr/>
+          <p:nvPr/>
+        </p:nvSpPr>
+        <p:spPr>
+          <a:xfrm>
+            <a:off x="548640" y="1371600"/>
+            <a:ext cx="6035040" cy="3108960"/>
+          </a:xfrm>
+          <a:prstGeom prst="roundRect">
+            <a:avLst>
+              <a:gd name="adj" fmla="val 3529"/>
+            </a:avLst>
+          </a:prstGeom>
+          <a:solidFill>
+            <a:schemeClr val="bg2"/>
+          </a:solidFill>
+          <a:ln w="12700">
+            <a:solidFill>
+              <a:schemeClr val="bg2"/>
+            </a:solidFill>
+            <a:prstDash val="solid"/>
+          </a:ln>
+        </p:spPr>
+      </p:sp>
+      <p:sp>
+        <p:nvSpPr>
+          <p:cNvPr id="5" name="Text 2"/>
+          <p:cNvSpPr txBox="1"/>
+          <p:nvPr/>
+        </p:nvSpPr>
+        <p:spPr>
+          <a:xfrm>
+            <a:off x="822960" y="1508760"/>
+            <a:ext cx="5486400" cy="320040"/>
+          </a:xfrm>
+          <a:prstGeom prst="rect">
+            <a:avLst/>
+          </a:prstGeom>
+          <a:noFill/>
+          <a:ln/>
+        </p:spPr>
+        <p:txBody>
+          <a:bodyPr wrap="square" lIns="0" tIns="0" rIns="0" bIns="0" rtlCol="0" anchor="ctr"/>
+          <a:lstStyle/>
+          <a:p>
+            <a:pPr indent="0" marL="0">
+              <a:buNone/>
+            </a:pPr>
+            <a:r>
+              <a:rPr lang="en-US" sz="1400" b="1" dirty="0">
+                <a:solidFill>
+                  <a:schemeClr val="accent1"/>
+                </a:solidFill>
+                <a:latin typeface="Apple SD Gothic Neo" pitchFamily="34" charset="0"/>
+                <a:ea typeface="Apple SD Gothic Neo" pitchFamily="34" charset="-122"/>
+                <a:cs typeface="Apple SD Gothic Neo" pitchFamily="34" charset="-120"/>
+              </a:rPr>
+              <a:t>원인 집합 → 제약</a:t>
+            </a:r>
+            <a:endParaRPr lang="en-US" sz="1400" dirty="0"/>
+          </a:p>
+        </p:txBody>
+      </p:sp>
+      <p:pic>
+        <p:nvPicPr>
+          <p:cNvPr id="6" name="eq c3" descr="c3">    </p:cNvPr>
+          <p:cNvPicPr>
+            <a:picLocks noChangeAspect="1"/>
+          </p:cNvPicPr>
+          <p:nvPr/>
+        </p:nvPicPr>
+        <p:blipFill>
+          <a:blip r:embed="rId1"/>
+          <a:stretch>
+            <a:fillRect/>
+          </a:stretch>
+        </p:blipFill>
+        <p:spPr>
+          <a:xfrm>
+            <a:off x="2277999" y="1901952"/>
+            <a:ext cx="2576322" cy="363474"/>
+          </a:xfrm>
+          <a:prstGeom prst="rect">
+            <a:avLst/>
+          </a:prstGeom>
+        </p:spPr>
+      </p:pic>
+      <p:sp>
+        <p:nvSpPr>
+          <p:cNvPr id="7" name="Text 3"/>
+          <p:cNvSpPr txBox="1"/>
+          <p:nvPr/>
+        </p:nvSpPr>
+        <p:spPr>
+          <a:xfrm>
+            <a:off x="777240" y="2704338"/>
+            <a:ext cx="5577840" cy="402336"/>
+          </a:xfrm>
+          <a:prstGeom prst="rect">
+            <a:avLst/>
+          </a:prstGeom>
+          <a:noFill/>
+          <a:ln/>
+        </p:spPr>
+        <p:txBody>
+          <a:bodyPr wrap="square" lIns="0" tIns="0" rIns="0" bIns="0" rtlCol="0" anchor="t"/>
+          <a:lstStyle/>
+          <a:p>
+            <a:pPr algn="ctr" indent="0" marL="0">
+              <a:buNone/>
+            </a:pPr>
+            <a:r>
+              <a:rPr lang="en-US" sz="1200" dirty="0">
+                <a:solidFill>
+                  <a:schemeClr val="accent3"/>
+                </a:solidFill>
+                <a:latin typeface="Apple SD Gothic Neo" pitchFamily="34" charset="0"/>
+                <a:ea typeface="Apple SD Gothic Neo" pitchFamily="34" charset="-122"/>
+                <a:cs typeface="Apple SD Gothic Neo" pitchFamily="34" charset="-120"/>
+              </a:rPr>
+              <a:t>z 가 정수라 바로 선형화할 수 없다</a:t>
+            </a:r>
+            <a:endParaRPr lang="en-US" sz="1200" dirty="0"/>
+          </a:p>
+        </p:txBody>
+      </p:sp>
+      <p:pic>
+        <p:nvPicPr>
+          <p:cNvPr id="8" name="eq c4" descr="c4">    </p:cNvPr>
+          <p:cNvPicPr>
+            <a:picLocks noChangeAspect="1"/>
+          </p:cNvPicPr>
+          <p:nvPr/>
+        </p:nvPicPr>
+        <p:blipFill>
+          <a:blip r:embed="rId2"/>
+          <a:stretch>
+            <a:fillRect/>
+          </a:stretch>
+        </p:blipFill>
+        <p:spPr>
+          <a:xfrm>
+            <a:off x="1729359" y="3159252"/>
+            <a:ext cx="3673602" cy="363474"/>
+          </a:xfrm>
+          <a:prstGeom prst="rect">
+            <a:avLst/>
+          </a:prstGeom>
+        </p:spPr>
+      </p:pic>
+      <p:sp>
+        <p:nvSpPr>
+          <p:cNvPr id="9" name="Text 4"/>
+          <p:cNvSpPr txBox="1"/>
+          <p:nvPr/>
+        </p:nvSpPr>
+        <p:spPr>
+          <a:xfrm>
+            <a:off x="777240" y="3961638"/>
+            <a:ext cx="5577840" cy="402336"/>
+          </a:xfrm>
+          <a:prstGeom prst="rect">
+            <a:avLst/>
+          </a:prstGeom>
+          <a:noFill/>
+          <a:ln/>
+        </p:spPr>
+        <p:txBody>
+          <a:bodyPr wrap="square" lIns="0" tIns="0" rIns="0" bIns="0" rtlCol="0" anchor="t"/>
+          <a:lstStyle/>
+          <a:p>
+            <a:pPr algn="ctr" indent="0" marL="0">
+              <a:buNone/>
+            </a:pPr>
+            <a:r>
+              <a:rPr lang="en-US" sz="1200" dirty="0">
+                <a:solidFill>
+                  <a:schemeClr val="accent3"/>
+                </a:solidFill>
+                <a:latin typeface="Apple SD Gothic Neo" pitchFamily="34" charset="0"/>
+                <a:ea typeface="Apple SD Gothic Neo" pitchFamily="34" charset="-122"/>
+                <a:cs typeface="Apple SD Gothic Neo" pitchFamily="34" charset="-120"/>
+              </a:rPr>
+              <a:t>논문이 택한 방법: x 변수만 남긴 cut B 로 선형화</a:t>
+            </a:r>
+            <a:endParaRPr lang="en-US" sz="1200" dirty="0"/>
+          </a:p>
+        </p:txBody>
+      </p:sp>
+      <p:sp>
+        <p:nvSpPr>
+          <p:cNvPr id="10" name="formula card"/>
+          <p:cNvSpPr/>
+          <p:nvPr/>
+        </p:nvSpPr>
+        <p:spPr>
+          <a:xfrm>
+            <a:off x="548640" y="4663440"/>
+            <a:ext cx="6035040" cy="1554480"/>
+          </a:xfrm>
+          <a:prstGeom prst="roundRect">
+            <a:avLst>
+              <a:gd name="adj" fmla="val 7059"/>
+            </a:avLst>
+          </a:prstGeom>
+          <a:solidFill>
+            <a:schemeClr val="bg2"/>
+          </a:solidFill>
+          <a:ln w="12700">
+            <a:solidFill>
+              <a:schemeClr val="bg2"/>
+            </a:solidFill>
+            <a:prstDash val="solid"/>
+          </a:ln>
+        </p:spPr>
+      </p:sp>
+      <p:sp>
+        <p:nvSpPr>
+          <p:cNvPr id="11" name="Text 6"/>
+          <p:cNvSpPr txBox="1"/>
+          <p:nvPr/>
+        </p:nvSpPr>
+        <p:spPr>
+          <a:xfrm>
+            <a:off x="822960" y="4800600"/>
+            <a:ext cx="5486400" cy="320040"/>
+          </a:xfrm>
+          <a:prstGeom prst="rect">
+            <a:avLst/>
+          </a:prstGeom>
+          <a:noFill/>
+          <a:ln/>
+        </p:spPr>
+        <p:txBody>
+          <a:bodyPr wrap="square" lIns="0" tIns="0" rIns="0" bIns="0" rtlCol="0" anchor="ctr"/>
+          <a:lstStyle/>
+          <a:p>
+            <a:pPr indent="0" marL="0">
+              <a:buNone/>
+            </a:pPr>
+            <a:r>
+              <a:rPr lang="en-US" sz="1400" b="1" dirty="0">
+                <a:solidFill>
+                  <a:schemeClr val="accent1"/>
+                </a:solidFill>
+                <a:latin typeface="Apple SD Gothic Neo" pitchFamily="34" charset="0"/>
+                <a:ea typeface="Apple SD Gothic Neo" pitchFamily="34" charset="-122"/>
+                <a:cs typeface="Apple SD Gothic Neo" pitchFamily="34" charset="-120"/>
+              </a:rPr>
+              <a:t>이진 변수만 있을 때의 일반형 (식 1)</a:t>
+            </a:r>
+            <a:endParaRPr lang="en-US" sz="1400" dirty="0"/>
+          </a:p>
+        </p:txBody>
+      </p:sp>
+      <p:pic>
+        <p:nvPicPr>
+          <p:cNvPr id="12" name="eq c5" descr="c5">    </p:cNvPr>
+          <p:cNvPicPr>
+            <a:picLocks noChangeAspect="1"/>
+          </p:cNvPicPr>
+          <p:nvPr/>
+        </p:nvPicPr>
+        <p:blipFill>
+          <a:blip r:embed="rId3"/>
+          <a:stretch>
+            <a:fillRect/>
+          </a:stretch>
+        </p:blipFill>
+        <p:spPr>
+          <a:xfrm>
+            <a:off x="1813941" y="5271516"/>
+            <a:ext cx="3504438" cy="749808"/>
+          </a:xfrm>
+          <a:prstGeom prst="rect">
+            <a:avLst/>
+          </a:prstGeom>
+        </p:spPr>
+      </p:pic>
+      <p:sp>
+        <p:nvSpPr>
+          <p:cNvPr id="13" name="Text 7"/>
+          <p:cNvSpPr txBox="1"/>
+          <p:nvPr/>
+        </p:nvSpPr>
+        <p:spPr>
+          <a:xfrm>
+            <a:off x="6949440" y="1463040"/>
+            <a:ext cx="2286000" cy="822960"/>
+          </a:xfrm>
+          <a:prstGeom prst="rect">
+            <a:avLst/>
+          </a:prstGeom>
+          <a:noFill/>
+          <a:ln/>
+        </p:spPr>
+        <p:txBody>
+          <a:bodyPr wrap="square" lIns="0" tIns="0" rIns="0" bIns="0" rtlCol="0" anchor="ctr"/>
+          <a:lstStyle/>
+          <a:p>
+            <a:pPr indent="0" marL="0">
+              <a:buNone/>
+            </a:pPr>
+            <a:r>
+              <a:rPr lang="en-US" sz="4400" b="1" dirty="0">
+                <a:solidFill>
+                  <a:schemeClr val="accent4"/>
+                </a:solidFill>
+                <a:latin typeface="Apple SD Gothic Neo" pitchFamily="34" charset="0"/>
+                <a:ea typeface="Apple SD Gothic Neo" pitchFamily="34" charset="-122"/>
+                <a:cs typeface="Apple SD Gothic Neo" pitchFamily="34" charset="-120"/>
+              </a:rPr>
+              <a:t>약 50%</a:t>
+            </a:r>
+            <a:endParaRPr lang="en-US" sz="4400" dirty="0"/>
+          </a:p>
+        </p:txBody>
+      </p:sp>
+      <p:sp>
+        <p:nvSpPr>
+          <p:cNvPr id="14" name="Text 8"/>
+          <p:cNvSpPr txBox="1"/>
+          <p:nvPr/>
+        </p:nvSpPr>
+        <p:spPr>
+          <a:xfrm>
+            <a:off x="6949440" y="2331720"/>
+            <a:ext cx="2286000" cy="822960"/>
+          </a:xfrm>
+          <a:prstGeom prst="rect">
+            <a:avLst/>
+          </a:prstGeom>
+          <a:noFill/>
+          <a:ln/>
+        </p:spPr>
+        <p:txBody>
+          <a:bodyPr wrap="square" lIns="0" tIns="0" rIns="0" bIns="0" rtlCol="0" anchor="t"/>
+          <a:lstStyle/>
+          <a:p>
+            <a:pPr indent="0" marL="0">
+              <a:buNone/>
+            </a:pPr>
+            <a:r>
+              <a:rPr lang="en-US" sz="1400" dirty="0">
+                <a:solidFill>
+                  <a:schemeClr val="tx1"/>
+                </a:solidFill>
+                <a:latin typeface="Apple SD Gothic Neo" pitchFamily="34" charset="0"/>
+                <a:ea typeface="Apple SD Gothic Neo" pitchFamily="34" charset="-122"/>
+                <a:cs typeface="Apple SD Gothic Neo" pitchFamily="34" charset="-120"/>
+              </a:rPr>
+              <a:t>노드 수 감소 (feasible 인스턴스, 기하평균)</a:t>
+            </a:r>
+            <a:endParaRPr lang="en-US" sz="1400" dirty="0"/>
+          </a:p>
+        </p:txBody>
+      </p:sp>
+      <p:sp>
+        <p:nvSpPr>
+          <p:cNvPr id="15" name="Text 9"/>
+          <p:cNvSpPr txBox="1"/>
+          <p:nvPr/>
+        </p:nvSpPr>
+        <p:spPr>
+          <a:xfrm>
+            <a:off x="9418320" y="1463040"/>
+            <a:ext cx="2194560" cy="822960"/>
+          </a:xfrm>
+          <a:prstGeom prst="rect">
+            <a:avLst/>
+          </a:prstGeom>
+          <a:noFill/>
+          <a:ln/>
+        </p:spPr>
+        <p:txBody>
+          <a:bodyPr wrap="square" lIns="0" tIns="0" rIns="0" bIns="0" rtlCol="0" anchor="ctr"/>
+          <a:lstStyle/>
+          <a:p>
+            <a:pPr indent="0" marL="0">
+              <a:buNone/>
+            </a:pPr>
+            <a:r>
+              <a:rPr lang="en-US" sz="4400" b="1" dirty="0">
+                <a:solidFill>
+                  <a:schemeClr val="accent5"/>
+                </a:solidFill>
+                <a:latin typeface="Apple SD Gothic Neo" pitchFamily="34" charset="0"/>
+                <a:ea typeface="Apple SD Gothic Neo" pitchFamily="34" charset="-122"/>
+                <a:cs typeface="Apple SD Gothic Neo" pitchFamily="34" charset="-120"/>
+              </a:rPr>
+              <a:t>약 +15%</a:t>
+            </a:r>
+            <a:endParaRPr lang="en-US" sz="4400" dirty="0"/>
+          </a:p>
+        </p:txBody>
+      </p:sp>
+      <p:sp>
+        <p:nvSpPr>
+          <p:cNvPr id="16" name="Text 10"/>
+          <p:cNvSpPr txBox="1"/>
+          <p:nvPr/>
+        </p:nvSpPr>
+        <p:spPr>
+          <a:xfrm>
+            <a:off x="9418320" y="2331720"/>
+            <a:ext cx="2194560" cy="822960"/>
+          </a:xfrm>
+          <a:prstGeom prst="rect">
+            <a:avLst/>
+          </a:prstGeom>
+          <a:noFill/>
+          <a:ln/>
+        </p:spPr>
+        <p:txBody>
+          <a:bodyPr wrap="square" lIns="0" tIns="0" rIns="0" bIns="0" rtlCol="0" anchor="t"/>
+          <a:lstStyle/>
+          <a:p>
+            <a:pPr indent="0" marL="0">
+              <a:buNone/>
+            </a:pPr>
+            <a:r>
+              <a:rPr lang="en-US" sz="1400" dirty="0">
+                <a:solidFill>
+                  <a:schemeClr val="tx1"/>
+                </a:solidFill>
+                <a:latin typeface="Apple SD Gothic Neo" pitchFamily="34" charset="0"/>
+                <a:ea typeface="Apple SD Gothic Neo" pitchFamily="34" charset="-122"/>
+                <a:cs typeface="Apple SD Gothic Neo" pitchFamily="34" charset="-120"/>
+              </a:rPr>
+              <a:t>시간은 오히려 증가</a:t>
+            </a:r>
+            <a:endParaRPr lang="en-US" sz="1400" dirty="0"/>
+          </a:p>
+        </p:txBody>
+      </p:sp>
+      <p:sp>
+        <p:nvSpPr>
+          <p:cNvPr id="17" name="alu card"/>
+          <p:cNvSpPr/>
+          <p:nvPr/>
+        </p:nvSpPr>
+        <p:spPr>
+          <a:xfrm>
+            <a:off x="6949440" y="3383280"/>
+            <a:ext cx="4663440" cy="2834640"/>
+          </a:xfrm>
+          <a:prstGeom prst="roundRect">
+            <a:avLst>
+              <a:gd name="adj" fmla="val 3871"/>
+            </a:avLst>
+          </a:prstGeom>
+          <a:solidFill>
+            <a:schemeClr val="bg2"/>
+          </a:solidFill>
+          <a:ln w="12700">
+            <a:solidFill>
+              <a:schemeClr val="bg2"/>
+            </a:solidFill>
+            <a:prstDash val="solid"/>
+          </a:ln>
+        </p:spPr>
+      </p:sp>
+      <p:sp>
+        <p:nvSpPr>
+          <p:cNvPr id="18" name="Text 12"/>
+          <p:cNvSpPr txBox="1"/>
+          <p:nvPr/>
+        </p:nvSpPr>
+        <p:spPr>
+          <a:xfrm>
+            <a:off x="7178040" y="3547872"/>
+            <a:ext cx="4206240" cy="365760"/>
+          </a:xfrm>
+          <a:prstGeom prst="rect">
+            <a:avLst/>
+          </a:prstGeom>
+          <a:noFill/>
+          <a:ln/>
+        </p:spPr>
+        <p:txBody>
+          <a:bodyPr wrap="square" lIns="0" tIns="0" rIns="0" bIns="0" rtlCol="0" anchor="ctr"/>
+          <a:lstStyle/>
+          <a:p>
+            <a:pPr indent="0" marL="0">
+              <a:buNone/>
+            </a:pPr>
+            <a:r>
+              <a:rPr lang="en-US" sz="1600" b="1" dirty="0">
+                <a:solidFill>
+                  <a:schemeClr val="accent1"/>
+                </a:solidFill>
+                <a:latin typeface="Apple SD Gothic Neo" pitchFamily="34" charset="0"/>
+                <a:ea typeface="Apple SD Gothic Neo" pitchFamily="34" charset="-122"/>
+                <a:cs typeface="Apple SD Gothic Neo" pitchFamily="34" charset="-120"/>
+              </a:rPr>
+              <a:t>infeasible 인스턴스는 다르다</a:t>
+            </a:r>
+            <a:endParaRPr lang="en-US" sz="1600" dirty="0"/>
+          </a:p>
+        </p:txBody>
+      </p:sp>
+      <p:sp>
+        <p:nvSpPr>
+          <p:cNvPr id="19" name="Text 13"/>
+          <p:cNvSpPr txBox="1"/>
+          <p:nvPr/>
+        </p:nvSpPr>
+        <p:spPr>
+          <a:xfrm>
+            <a:off x="7178040" y="4023360"/>
+            <a:ext cx="4206240" cy="2057400"/>
+          </a:xfrm>
+          <a:prstGeom prst="rect">
+            <a:avLst/>
+          </a:prstGeom>
+          <a:noFill/>
+          <a:ln/>
+        </p:spPr>
+        <p:txBody>
+          <a:bodyPr wrap="square" lIns="0" tIns="0" rIns="0" bIns="0" rtlCol="0" anchor="t"/>
+          <a:lstStyle/>
+          <a:p>
+            <a:pPr marL="342900" indent="-342900">
+              <a:spcAft>
+                <a:spcPts val="600"/>
+              </a:spcAft>
+              <a:buSzPct val="100000"/>
+              <a:buChar char="•"/>
+            </a:pPr>
+            <a:r>
+              <a:rPr lang="en-US" sz="1400" dirty="0">
+                <a:solidFill>
+                  <a:schemeClr val="tx1"/>
+                </a:solidFill>
+                <a:latin typeface="Apple SD Gothic Neo" pitchFamily="34" charset="0"/>
+                <a:ea typeface="Apple SD Gothic Neo" pitchFamily="34" charset="-122"/>
+                <a:cs typeface="Apple SD Gothic Neo" pitchFamily="34" charset="-120"/>
+              </a:rPr>
+              <a:t>ALU 검증 인스턴스에서 노드·시간 모두 크게 개선</a:t>
+            </a:r>
+            <a:endParaRPr lang="en-US" sz="1400" dirty="0"/>
+          </a:p>
+          <a:p>
+            <a:pPr marL="342900" indent="-342900">
+              <a:spcAft>
+                <a:spcPts val="600"/>
+              </a:spcAft>
+              <a:buSzPct val="100000"/>
+              <a:buChar char="•"/>
+            </a:pPr>
+            <a:r>
+              <a:rPr lang="en-US" sz="1400" dirty="0">
+                <a:solidFill>
+                  <a:schemeClr val="tx1"/>
+                </a:solidFill>
+                <a:latin typeface="Apple SD Gothic Neo" pitchFamily="34" charset="0"/>
+                <a:ea typeface="Apple SD Gothic Neo" pitchFamily="34" charset="-122"/>
+                <a:cs typeface="Apple SD Gothic Neo" pitchFamily="34" charset="-120"/>
+              </a:rPr>
+              <a:t>property 1 은 10비트도 쉽게, 기본 설정은 100만 노드 이상</a:t>
+            </a:r>
+            <a:endParaRPr lang="en-US" sz="1400" dirty="0"/>
+          </a:p>
+          <a:p>
+            <a:pPr marL="342900" indent="-342900">
+              <a:spcAft>
+                <a:spcPts val="600"/>
+              </a:spcAft>
+              <a:buSzPct val="100000"/>
+              <a:buChar char="•"/>
+            </a:pPr>
+            <a:r>
+              <a:rPr lang="en-US" sz="1400" dirty="0">
+                <a:solidFill>
+                  <a:schemeClr val="tx1"/>
+                </a:solidFill>
+                <a:latin typeface="Apple SD Gothic Neo" pitchFamily="34" charset="0"/>
+                <a:ea typeface="Apple SD Gothic Neo" pitchFamily="34" charset="-122"/>
+                <a:cs typeface="Apple SD Gothic Neo" pitchFamily="34" charset="-120"/>
+              </a:rPr>
+              <a:t>학습된 절이 매우 짧아서 트리를 크게 자르기 때문</a:t>
+            </a:r>
+            <a:endParaRPr lang="en-US" sz="1400" dirty="0"/>
+          </a:p>
+        </p:txBody>
+      </p:sp>
+      <p:sp>
+        <p:nvSpPr>
+          <p:cNvPr id="20" name="Text 14"/>
+          <p:cNvSpPr txBox="1"/>
+          <p:nvPr/>
+        </p:nvSpPr>
+        <p:spPr>
+          <a:xfrm>
+            <a:off x="548640" y="6355080"/>
+            <a:ext cx="10607040" cy="274320"/>
+          </a:xfrm>
+          <a:prstGeom prst="rect">
+            <a:avLst/>
+          </a:prstGeom>
+          <a:noFill/>
+          <a:ln/>
+        </p:spPr>
+        <p:txBody>
+          <a:bodyPr wrap="square" lIns="0" tIns="0" rIns="0" bIns="0" rtlCol="0" anchor="ctr"/>
+          <a:lstStyle/>
+          <a:p>
+            <a:pPr indent="0" marL="0">
+              <a:buNone/>
+            </a:pPr>
+            <a:r>
+              <a:rPr lang="en-US" sz="1000" dirty="0">
+                <a:solidFill>
+                  <a:schemeClr val="accent3"/>
+                </a:solidFill>
+                <a:latin typeface="Apple SD Gothic Neo" pitchFamily="34" charset="0"/>
+                <a:ea typeface="Apple SD Gothic Neo" pitchFamily="34" charset="-122"/>
+                <a:cs typeface="Apple SD Gothic Neo" pitchFamily="34" charset="-120"/>
+              </a:rPr>
+              <a:t>Achterberg (2007; ZIB 05-19), 3.4절·Example 3.7, 4장 Table 1·3</a:t>
+            </a:r>
+            <a:endParaRPr lang="en-US" sz="1000" dirty="0"/>
+          </a:p>
+        </p:txBody>
+      </p:sp>
+      <p:sp>
+        <p:nvSpPr>
+          <p:cNvPr id="25" name="Slide Number Placeholder 0"/>
+          <p:cNvSpPr>
+            <a:spLocks noGrp="1"/>
+          </p:cNvSpPr>
+          <p:nvPr>
+            <p:ph type="sldNum" sz="quarter" idx="4294967295"/>
+          </p:nvPr>
+        </p:nvSpPr>
+        <p:spPr>
+          <a:xfrm>
+            <a:off x="11338560" y="6400800"/>
+            <a:ext cx="548640" cy="274320"/>
+          </a:xfrm>
+          <a:prstGeom prst="rect">
+            <a:avLst/>
+          </a:prstGeom>
+          <a:extLst>
+            <a:ext uri="{C572A759-6A51-4108-AA02-DFA0A04FC94B}">
+              <ma14:wrappingTextBoxFlag xmlns:ma14="http://schemas.microsoft.com/office/mac/drawingml/2011/main" val="0"/>
+            </a:ext>
+          </a:extLst>
+        </p:spPr>
+        <p:txBody>
+          <a:bodyPr/>
+          <a:lstStyle>
+            <a:lvl1pPr>
+              <a:defRPr sz="1000">
+                <a:solidFill>
+                  <a:schemeClr val="accent3"/>
+                </a:solidFill>
+              </a:defRPr>
+            </a:lvl1pPr>
+          </a:lstStyle>
+          <a:p>
+            <a:pPr algn="r"/>
+            <a:fld id="{F7021451-1387-4CA6-816F-3879F97B5CBC}" type="slidenum">
+              <a:rPr b="0" lang="en-US"/>
+              <a:t>18</a:t>
+            </a:fld>
+            <a:endParaRPr lang="en-US"/>
+          </a:p>
+        </p:txBody>
+      </p:sp>
+    </p:spTree>
+  </p:cSld>
+  <p:clrMapOvr>
+    <a:masterClrMapping/>
+  </p:clrMapOvr>
+</p:sld>
+</file>
+
+<file path=ppt/slides/slide21.xml><?xml version="1.0" encoding="utf-8"?>
+<p:sld xmlns:a="http://schemas.openxmlformats.org/drawingml/2006/main" xmlns:r="http://schemas.openxmlformats.org/officeDocument/2006/relationships" xmlns:p="http://schemas.openxmlformats.org/presentationml/2006/main">
+  <p:cSld name="Slide 19">
+    <p:spTree>
+      <p:nvGrpSpPr>
+        <p:cNvPr id="1" name=""/>
+        <p:cNvGrpSpPr/>
+        <p:nvPr/>
+      </p:nvGrpSpPr>
+      <p:grpSpPr>
+        <a:xfrm>
+          <a:off x="0" y="0"/>
+          <a:ext cx="0" cy="0"/>
+          <a:chOff x="0" y="0"/>
+          <a:chExt cx="0" cy="0"/>
+        </a:xfrm>
+      </p:grpSpPr>
+      <p:sp>
+        <p:nvSpPr>
+          <p:cNvPr id="2" name="Text 0"/>
+          <p:cNvSpPr/>
+          <p:nvPr>
+            <p:ph idx="100" type="title" hasCustomPrompt="1"/>
+          </p:nvPr>
+        </p:nvSpPr>
+        <p:spPr>
+          <a:xfrm>
+            <a:off x="548640" y="320040"/>
+            <a:ext cx="11064240" cy="822960"/>
+          </a:xfrm>
+          <a:prstGeom prst="rect">
+            <a:avLst/>
+          </a:prstGeom>
+          <a:noFill/>
+          <a:ln/>
+        </p:spPr>
+        <p:txBody>
+          <a:bodyPr wrap="square" rtlCol="0" anchor="ctr"/>
+          <a:lstStyle/>
+          <a:p>
+            <a:pPr indent="0" marL="0">
+              <a:buNone/>
+            </a:pPr>
+            <a:r>
+              <a:rPr lang="en-US" sz="3000" b="1" dirty="0">
+                <a:solidFill>
+                  <a:schemeClr val="tx2"/>
+                </a:solidFill>
+              </a:rPr>
+              <a:t>대칭성: 논문의 Example 9와 Orbital fixing</a:t>
+            </a:r>
+            <a:endParaRPr lang="en-US" sz="3000" dirty="0"/>
+          </a:p>
+        </p:txBody>
+      </p:sp>
+      <p:sp>
+        <p:nvSpPr>
+          <p:cNvPr id="4" name="formula card"/>
+          <p:cNvSpPr/>
+          <p:nvPr/>
+        </p:nvSpPr>
+        <p:spPr>
+          <a:xfrm>
+            <a:off x="548640" y="1371600"/>
+            <a:ext cx="6309360" cy="4846320"/>
+          </a:xfrm>
+          <a:prstGeom prst="roundRect">
+            <a:avLst>
+              <a:gd name="adj" fmla="val 2264"/>
+            </a:avLst>
+          </a:prstGeom>
+          <a:solidFill>
+            <a:schemeClr val="bg2"/>
+          </a:solidFill>
+          <a:ln w="12700">
+            <a:solidFill>
+              <a:schemeClr val="bg2"/>
+            </a:solidFill>
+            <a:prstDash val="solid"/>
+          </a:ln>
+        </p:spPr>
+      </p:sp>
+      <p:sp>
+        <p:nvSpPr>
+          <p:cNvPr id="5" name="Text 2"/>
+          <p:cNvSpPr txBox="1"/>
+          <p:nvPr/>
+        </p:nvSpPr>
+        <p:spPr>
+          <a:xfrm>
+            <a:off x="822960" y="1508760"/>
+            <a:ext cx="5760720" cy="320040"/>
+          </a:xfrm>
+          <a:prstGeom prst="rect">
+            <a:avLst/>
+          </a:prstGeom>
+          <a:noFill/>
+          <a:ln/>
+        </p:spPr>
+        <p:txBody>
+          <a:bodyPr wrap="square" lIns="0" tIns="0" rIns="0" bIns="0" rtlCol="0" anchor="ctr"/>
+          <a:lstStyle/>
+          <a:p>
+            <a:pPr indent="0" marL="0">
+              <a:buNone/>
+            </a:pPr>
+            <a:r>
+              <a:rPr lang="en-US" sz="1400" b="1" dirty="0">
+                <a:solidFill>
+                  <a:schemeClr val="accent1"/>
+                </a:solidFill>
+                <a:latin typeface="Apple SD Gothic Neo" pitchFamily="34" charset="0"/>
+                <a:ea typeface="Apple SD Gothic Neo" pitchFamily="34" charset="-122"/>
+                <a:cs typeface="Apple SD Gothic Neo" pitchFamily="34" charset="-120"/>
+              </a:rPr>
+              <a:t>Example 9: 대칭 변수를 하나로 합친다</a:t>
+            </a:r>
+            <a:endParaRPr lang="en-US" sz="1400" dirty="0"/>
+          </a:p>
+        </p:txBody>
+      </p:sp>
+      <p:pic>
+        <p:nvPicPr>
+          <p:cNvPr id="6" name="eq ex9a" descr="ex9a">    </p:cNvPr>
+          <p:cNvPicPr>
+            <a:picLocks noChangeAspect="1"/>
+          </p:cNvPicPr>
+          <p:nvPr/>
+        </p:nvPicPr>
+        <p:blipFill>
+          <a:blip r:embed="rId1"/>
+          <a:stretch>
+            <a:fillRect/>
+          </a:stretch>
+        </p:blipFill>
+        <p:spPr>
+          <a:xfrm>
+            <a:off x="777240" y="2126556"/>
+            <a:ext cx="5852160" cy="346321"/>
+          </a:xfrm>
+          <a:prstGeom prst="rect">
+            <a:avLst/>
+          </a:prstGeom>
+        </p:spPr>
+      </p:pic>
+      <p:pic>
+        <p:nvPicPr>
+          <p:cNvPr id="7" name="eq ex9b" descr="ex9b">    </p:cNvPr>
+          <p:cNvPicPr>
+            <a:picLocks noChangeAspect="1"/>
+          </p:cNvPicPr>
+          <p:nvPr/>
+        </p:nvPicPr>
+        <p:blipFill>
+          <a:blip r:embed="rId2"/>
+          <a:stretch>
+            <a:fillRect/>
+          </a:stretch>
+        </p:blipFill>
+        <p:spPr>
+          <a:xfrm>
+            <a:off x="1728216" y="2970657"/>
+            <a:ext cx="3950208" cy="358902"/>
+          </a:xfrm>
+          <a:prstGeom prst="rect">
+            <a:avLst/>
+          </a:prstGeom>
+        </p:spPr>
+      </p:pic>
+      <p:pic>
+        <p:nvPicPr>
+          <p:cNvPr id="8" name="eq ex9c" descr="ex9c">    </p:cNvPr>
+          <p:cNvPicPr>
+            <a:picLocks noChangeAspect="1"/>
+          </p:cNvPicPr>
+          <p:nvPr/>
+        </p:nvPicPr>
+        <p:blipFill>
+          <a:blip r:embed="rId3"/>
+          <a:stretch>
+            <a:fillRect/>
+          </a:stretch>
+        </p:blipFill>
+        <p:spPr>
+          <a:xfrm>
+            <a:off x="1728216" y="3821049"/>
+            <a:ext cx="3950208" cy="358902"/>
+          </a:xfrm>
+          <a:prstGeom prst="rect">
+            <a:avLst/>
+          </a:prstGeom>
+        </p:spPr>
+      </p:pic>
+      <p:pic>
+        <p:nvPicPr>
+          <p:cNvPr id="9" name="eq ex9d" descr="ex9d">    </p:cNvPr>
+          <p:cNvPicPr>
+            <a:picLocks noChangeAspect="1"/>
+          </p:cNvPicPr>
+          <p:nvPr/>
+        </p:nvPicPr>
+        <p:blipFill>
+          <a:blip r:embed="rId4"/>
+          <a:stretch>
+            <a:fillRect/>
+          </a:stretch>
+        </p:blipFill>
+        <p:spPr>
+          <a:xfrm>
+            <a:off x="777240" y="4453128"/>
+            <a:ext cx="5852160" cy="359264"/>
+          </a:xfrm>
+          <a:prstGeom prst="rect">
+            <a:avLst/>
+          </a:prstGeom>
+        </p:spPr>
+      </p:pic>
+      <p:sp>
+        <p:nvSpPr>
+          <p:cNvPr id="10" name="Text 3"/>
+          <p:cNvSpPr txBox="1"/>
+          <p:nvPr/>
+        </p:nvSpPr>
+        <p:spPr>
+          <a:xfrm>
+            <a:off x="777240" y="4986955"/>
+            <a:ext cx="5852160" cy="272125"/>
+          </a:xfrm>
+          <a:prstGeom prst="rect">
+            <a:avLst/>
+          </a:prstGeom>
+          <a:noFill/>
+          <a:ln/>
+        </p:spPr>
+        <p:txBody>
+          <a:bodyPr wrap="square" lIns="0" tIns="0" rIns="0" bIns="0" rtlCol="0" anchor="t"/>
+          <a:lstStyle/>
+          <a:p>
+            <a:pPr algn="ctr" indent="0" marL="0">
+              <a:buNone/>
+            </a:pPr>
+            <a:r>
+              <a:rPr lang="en-US" sz="1200" dirty="0">
+                <a:solidFill>
+                  <a:schemeClr val="accent3"/>
+                </a:solidFill>
+                <a:latin typeface="Apple SD Gothic Neo" pitchFamily="34" charset="0"/>
+                <a:ea typeface="Apple SD Gothic Neo" pitchFamily="34" charset="-122"/>
+                <a:cs typeface="Apple SD Gothic Neo" pitchFamily="34" charset="-120"/>
+              </a:rPr>
+              <a:t>x₁↔x₂, x₃↔x₄ 를 바꾸고 행을 바꾸면 원래 식</a:t>
+            </a:r>
+            <a:endParaRPr lang="en-US" sz="1200" dirty="0"/>
+          </a:p>
+        </p:txBody>
+      </p:sp>
+      <p:pic>
+        <p:nvPicPr>
+          <p:cNvPr id="11" name="eq ex9e" descr="ex9e">    </p:cNvPr>
+          <p:cNvPicPr>
+            <a:picLocks noChangeAspect="1"/>
+          </p:cNvPicPr>
+          <p:nvPr/>
+        </p:nvPicPr>
+        <p:blipFill>
+          <a:blip r:embed="rId5"/>
+          <a:stretch>
+            <a:fillRect/>
+          </a:stretch>
+        </p:blipFill>
+        <p:spPr>
+          <a:xfrm>
+            <a:off x="1480185" y="5303520"/>
+            <a:ext cx="4446270" cy="358902"/>
+          </a:xfrm>
+          <a:prstGeom prst="rect">
+            <a:avLst/>
+          </a:prstGeom>
+        </p:spPr>
+      </p:pic>
+      <p:sp>
+        <p:nvSpPr>
+          <p:cNvPr id="12" name="Text 4"/>
+          <p:cNvSpPr txBox="1"/>
+          <p:nvPr/>
+        </p:nvSpPr>
+        <p:spPr>
+          <a:xfrm>
+            <a:off x="777240" y="5837347"/>
+            <a:ext cx="5852160" cy="272125"/>
+          </a:xfrm>
+          <a:prstGeom prst="rect">
+            <a:avLst/>
+          </a:prstGeom>
+          <a:noFill/>
+          <a:ln/>
+        </p:spPr>
+        <p:txBody>
+          <a:bodyPr wrap="square" lIns="0" tIns="0" rIns="0" bIns="0" rtlCol="0" anchor="t"/>
+          <a:lstStyle/>
+          <a:p>
+            <a:pPr algn="ctr" indent="0" marL="0">
+              <a:buNone/>
+            </a:pPr>
+            <a:r>
+              <a:rPr lang="en-US" sz="1200" dirty="0">
+                <a:solidFill>
+                  <a:schemeClr val="accent3"/>
+                </a:solidFill>
+                <a:latin typeface="Apple SD Gothic Neo" pitchFamily="34" charset="0"/>
+                <a:ea typeface="Apple SD Gothic Neo" pitchFamily="34" charset="-122"/>
+                <a:cs typeface="Apple SD Gothic Neo" pitchFamily="34" charset="-120"/>
+              </a:rPr>
+              <a:t>합친 뒤 두 제약이 같아져 하나가 삭제된다</a:t>
+            </a:r>
+            <a:endParaRPr lang="en-US" sz="1200" dirty="0"/>
+          </a:p>
+        </p:txBody>
+      </p:sp>
+      <p:sp>
+        <p:nvSpPr>
+          <p:cNvPr id="13" name="formula card"/>
+          <p:cNvSpPr/>
+          <p:nvPr/>
+        </p:nvSpPr>
+        <p:spPr>
+          <a:xfrm>
+            <a:off x="7132320" y="1371600"/>
+            <a:ext cx="4480560" cy="1828800"/>
+          </a:xfrm>
+          <a:prstGeom prst="roundRect">
+            <a:avLst>
+              <a:gd name="adj" fmla="val 6000"/>
+            </a:avLst>
+          </a:prstGeom>
+          <a:solidFill>
+            <a:schemeClr val="bg2"/>
+          </a:solidFill>
+          <a:ln w="12700">
+            <a:solidFill>
+              <a:schemeClr val="bg2"/>
+            </a:solidFill>
+            <a:prstDash val="solid"/>
+          </a:ln>
+        </p:spPr>
+      </p:sp>
+      <p:sp>
+        <p:nvSpPr>
+          <p:cNvPr id="14" name="Text 6"/>
+          <p:cNvSpPr txBox="1"/>
+          <p:nvPr/>
+        </p:nvSpPr>
+        <p:spPr>
+          <a:xfrm>
+            <a:off x="7406640" y="1508760"/>
+            <a:ext cx="3931920" cy="320040"/>
+          </a:xfrm>
+          <a:prstGeom prst="rect">
+            <a:avLst/>
+          </a:prstGeom>
+          <a:noFill/>
+          <a:ln/>
+        </p:spPr>
+        <p:txBody>
+          <a:bodyPr wrap="square" lIns="0" tIns="0" rIns="0" bIns="0" rtlCol="0" anchor="ctr"/>
+          <a:lstStyle/>
+          <a:p>
+            <a:pPr indent="0" marL="0">
+              <a:buNone/>
+            </a:pPr>
+            <a:r>
+              <a:rPr lang="en-US" sz="1400" b="1" dirty="0">
+                <a:solidFill>
+                  <a:schemeClr val="accent1"/>
+                </a:solidFill>
+                <a:latin typeface="Apple SD Gothic Neo" pitchFamily="34" charset="0"/>
+                <a:ea typeface="Apple SD Gothic Neo" pitchFamily="34" charset="-122"/>
+                <a:cs typeface="Apple SD Gothic Neo" pitchFamily="34" charset="-120"/>
+              </a:rPr>
+              <a:t>Orbital fixing (Margot 도입)</a:t>
+            </a:r>
+            <a:endParaRPr lang="en-US" sz="1400" dirty="0"/>
+          </a:p>
+        </p:txBody>
+      </p:sp>
+      <p:pic>
+        <p:nvPicPr>
+          <p:cNvPr id="15" name="eq orb" descr="orb">    </p:cNvPr>
+          <p:cNvPicPr>
+            <a:picLocks noChangeAspect="1"/>
+          </p:cNvPicPr>
+          <p:nvPr/>
+        </p:nvPicPr>
+        <p:blipFill>
+          <a:blip r:embed="rId6"/>
+          <a:stretch>
+            <a:fillRect/>
+          </a:stretch>
+        </p:blipFill>
+        <p:spPr>
+          <a:xfrm>
+            <a:off x="7360920" y="2288582"/>
+            <a:ext cx="4023360" cy="406315"/>
+          </a:xfrm>
+          <a:prstGeom prst="rect">
+            <a:avLst/>
+          </a:prstGeom>
+        </p:spPr>
+      </p:pic>
+      <p:sp>
+        <p:nvSpPr>
+          <p:cNvPr id="16" name="orbres card"/>
+          <p:cNvSpPr/>
+          <p:nvPr/>
+        </p:nvSpPr>
+        <p:spPr>
+          <a:xfrm>
+            <a:off x="7132320" y="3383280"/>
+            <a:ext cx="4480560" cy="2834640"/>
+          </a:xfrm>
+          <a:prstGeom prst="roundRect">
+            <a:avLst>
+              <a:gd name="adj" fmla="val 3871"/>
+            </a:avLst>
+          </a:prstGeom>
+          <a:solidFill>
+            <a:schemeClr val="bg2"/>
+          </a:solidFill>
+          <a:ln w="12700">
+            <a:solidFill>
+              <a:schemeClr val="bg2"/>
+            </a:solidFill>
+            <a:prstDash val="solid"/>
+          </a:ln>
+        </p:spPr>
+      </p:sp>
+      <p:sp>
+        <p:nvSpPr>
+          <p:cNvPr id="17" name="Text 8"/>
+          <p:cNvSpPr txBox="1"/>
+          <p:nvPr/>
+        </p:nvSpPr>
+        <p:spPr>
+          <a:xfrm>
+            <a:off x="7360920" y="3547872"/>
+            <a:ext cx="4023360" cy="365760"/>
+          </a:xfrm>
+          <a:prstGeom prst="rect">
+            <a:avLst/>
+          </a:prstGeom>
+          <a:noFill/>
+          <a:ln/>
+        </p:spPr>
+        <p:txBody>
+          <a:bodyPr wrap="square" lIns="0" tIns="0" rIns="0" bIns="0" rtlCol="0" anchor="ctr"/>
+          <a:lstStyle/>
+          <a:p>
+            <a:pPr indent="0" marL="0">
+              <a:buNone/>
+            </a:pPr>
+            <a:r>
+              <a:rPr lang="en-US" sz="1600" b="1" dirty="0">
+                <a:solidFill>
+                  <a:schemeClr val="accent2"/>
+                </a:solidFill>
+                <a:latin typeface="Apple SD Gothic Neo" pitchFamily="34" charset="0"/>
+                <a:ea typeface="Apple SD Gothic Neo" pitchFamily="34" charset="-122"/>
+                <a:cs typeface="Apple SD Gothic Neo" pitchFamily="34" charset="-120"/>
+              </a:rPr>
+              <a:t>효과 (10초 이상 구간)</a:t>
+            </a:r>
+            <a:endParaRPr lang="en-US" sz="1600" dirty="0"/>
+          </a:p>
+        </p:txBody>
+      </p:sp>
+      <p:sp>
+        <p:nvSpPr>
+          <p:cNvPr id="18" name="Text 9"/>
+          <p:cNvSpPr txBox="1"/>
+          <p:nvPr/>
+        </p:nvSpPr>
+        <p:spPr>
+          <a:xfrm>
+            <a:off x="7360920" y="4023360"/>
+            <a:ext cx="4023360" cy="2057400"/>
+          </a:xfrm>
+          <a:prstGeom prst="rect">
+            <a:avLst/>
+          </a:prstGeom>
+          <a:noFill/>
+          <a:ln/>
+        </p:spPr>
+        <p:txBody>
+          <a:bodyPr wrap="square" lIns="0" tIns="0" rIns="0" bIns="0" rtlCol="0" anchor="t"/>
+          <a:lstStyle/>
+          <a:p>
+            <a:pPr marL="342900" indent="-342900">
+              <a:spcAft>
+                <a:spcPts val="600"/>
+              </a:spcAft>
+              <a:buSzPct val="100000"/>
+              <a:buChar char="•"/>
+            </a:pPr>
+            <a:r>
+              <a:rPr lang="en-US" sz="1400" dirty="0">
+                <a:solidFill>
+                  <a:schemeClr val="tx1"/>
+                </a:solidFill>
+                <a:latin typeface="Apple SD Gothic Neo" pitchFamily="34" charset="0"/>
+                <a:ea typeface="Apple SD Gothic Neo" pitchFamily="34" charset="-122"/>
+                <a:cs typeface="Apple SD Gothic Neo" pitchFamily="34" charset="-120"/>
+              </a:rPr>
+              <a:t>모델의 약 20%에 적용, 그 모델에서 시간 1.77배 차이</a:t>
+            </a:r>
+            <a:endParaRPr lang="en-US" sz="1400" dirty="0"/>
+          </a:p>
+          <a:p>
+            <a:pPr marL="342900" indent="-342900">
+              <a:spcAft>
+                <a:spcPts val="600"/>
+              </a:spcAft>
+              <a:buSzPct val="100000"/>
+              <a:buChar char="•"/>
+            </a:pPr>
+            <a:r>
+              <a:rPr lang="en-US" sz="1400" dirty="0">
+                <a:solidFill>
+                  <a:schemeClr val="tx1"/>
+                </a:solidFill>
+                <a:latin typeface="Apple SD Gothic Neo" pitchFamily="34" charset="0"/>
+                <a:ea typeface="Apple SD Gothic Neo" pitchFamily="34" charset="-122"/>
+                <a:cs typeface="Apple SD Gothic Neo" pitchFamily="34" charset="-120"/>
+              </a:rPr>
+              <a:t>끄면 시간 초과 모델이 37개 늘어난다</a:t>
+            </a:r>
+            <a:endParaRPr lang="en-US" sz="1400" dirty="0"/>
+          </a:p>
+          <a:p>
+            <a:pPr marL="342900" indent="-342900">
+              <a:spcAft>
+                <a:spcPts val="600"/>
+              </a:spcAft>
+              <a:buSzPct val="100000"/>
+              <a:buChar char="•"/>
+            </a:pPr>
+            <a:r>
+              <a:rPr lang="en-US" sz="1400" dirty="0">
+                <a:solidFill>
+                  <a:schemeClr val="tx1"/>
+                </a:solidFill>
+                <a:latin typeface="Apple SD Gothic Neo" pitchFamily="34" charset="0"/>
+                <a:ea typeface="Apple SD Gothic Neo" pitchFamily="34" charset="-122"/>
+                <a:cs typeface="Apple SD Gothic Neo" pitchFamily="34" charset="-120"/>
+              </a:rPr>
+              <a:t>대칭 기법은 일부 모델에만 듣지만 듣는 곳에서 크다</a:t>
+            </a:r>
+            <a:endParaRPr lang="en-US" sz="1400" dirty="0"/>
+          </a:p>
+        </p:txBody>
+      </p:sp>
+      <p:sp>
+        <p:nvSpPr>
+          <p:cNvPr id="19" name="Text 10"/>
+          <p:cNvSpPr txBox="1"/>
+          <p:nvPr/>
+        </p:nvSpPr>
+        <p:spPr>
+          <a:xfrm>
+            <a:off x="548640" y="6355080"/>
+            <a:ext cx="10607040" cy="274320"/>
+          </a:xfrm>
+          <a:prstGeom prst="rect">
+            <a:avLst/>
+          </a:prstGeom>
+          <a:noFill/>
+          <a:ln/>
+        </p:spPr>
+        <p:txBody>
+          <a:bodyPr wrap="square" lIns="0" tIns="0" rIns="0" bIns="0" rtlCol="0" anchor="ctr"/>
+          <a:lstStyle/>
+          <a:p>
+            <a:pPr indent="0" marL="0">
+              <a:buNone/>
+            </a:pPr>
+            <a:r>
+              <a:rPr lang="en-US" sz="1000" dirty="0">
+                <a:solidFill>
+                  <a:schemeClr val="accent3"/>
+                </a:solidFill>
+                <a:latin typeface="Apple SD Gothic Neo" pitchFamily="34" charset="0"/>
+                <a:ea typeface="Apple SD Gothic Neo" pitchFamily="34" charset="-122"/>
+                <a:cs typeface="Apple SD Gothic Neo" pitchFamily="34" charset="-120"/>
+              </a:rPr>
+              <a:t>Achterberg et al. (ZIB 16-44), 7.1절 Example 9·Table 28, 8.2절 Table 36 · Margot(2003)은 2차 인용</a:t>
+            </a:r>
+            <a:endParaRPr lang="en-US" sz="1000" dirty="0"/>
+          </a:p>
+        </p:txBody>
+      </p:sp>
+      <p:sp>
+        <p:nvSpPr>
+          <p:cNvPr id="25" name="Slide Number Placeholder 0"/>
+          <p:cNvSpPr>
+            <a:spLocks noGrp="1"/>
+          </p:cNvSpPr>
+          <p:nvPr>
+            <p:ph type="sldNum" sz="quarter" idx="4294967295"/>
+          </p:nvPr>
+        </p:nvSpPr>
+        <p:spPr>
+          <a:xfrm>
+            <a:off x="11338560" y="6400800"/>
+            <a:ext cx="548640" cy="274320"/>
+          </a:xfrm>
+          <a:prstGeom prst="rect">
+            <a:avLst/>
+          </a:prstGeom>
+          <a:extLst>
+            <a:ext uri="{C572A759-6A51-4108-AA02-DFA0A04FC94B}">
+              <ma14:wrappingTextBoxFlag xmlns:ma14="http://schemas.microsoft.com/office/mac/drawingml/2011/main" val="0"/>
+            </a:ext>
+          </a:extLst>
+        </p:spPr>
+        <p:txBody>
+          <a:bodyPr/>
+          <a:lstStyle>
+            <a:lvl1pPr>
+              <a:defRPr sz="1000">
+                <a:solidFill>
+                  <a:schemeClr val="accent3"/>
+                </a:solidFill>
+              </a:defRPr>
+            </a:lvl1pPr>
+          </a:lstStyle>
+          <a:p>
+            <a:pPr algn="r"/>
+            <a:fld id="{F7021451-1387-4CA6-816F-3879F97B5CBC}" type="slidenum">
+              <a:rPr b="0" lang="en-US"/>
+              <a:t>19</a:t>
+            </a:fld>
+            <a:endParaRPr lang="en-US"/>
+          </a:p>
+        </p:txBody>
+      </p:sp>
+    </p:spTree>
+  </p:cSld>
+  <p:clrMapOvr>
+    <a:masterClrMapping/>
+  </p:clrMapOvr>
+</p:sld>
+</file>
+
+<file path=ppt/slides/slide22.xml><?xml version="1.0" encoding="utf-8"?>
+<p:sld xmlns:a="http://schemas.openxmlformats.org/drawingml/2006/main" xmlns:r="http://schemas.openxmlformats.org/officeDocument/2006/relationships" xmlns:p="http://schemas.openxmlformats.org/presentationml/2006/main">
   <p:cSld name="Slide 20">
     <p:spTree>
       <p:nvGrpSpPr>
@@ -13001,7 +14056,7 @@
 </p:sld>
 </file>
 
-<file path=ppt/slides/slide21.xml><?xml version="1.0" encoding="utf-8"?>
+<file path=ppt/slides/slide23.xml><?xml version="1.0" encoding="utf-8"?>
 <p:sld xmlns:a="http://schemas.openxmlformats.org/drawingml/2006/main" xmlns:r="http://schemas.openxmlformats.org/officeDocument/2006/relationships" xmlns:p="http://schemas.openxmlformats.org/presentationml/2006/main">
   <p:cSld name="Slide 21">
     <p:spTree>
@@ -13662,7 +14717,7 @@
 </p:sld>
 </file>
 
-<file path=ppt/slides/slide22.xml><?xml version="1.0" encoding="utf-8"?>
+<file path=ppt/slides/slide24.xml><?xml version="1.0" encoding="utf-8"?>
 <p:sld xmlns:a="http://schemas.openxmlformats.org/drawingml/2006/main" xmlns:r="http://schemas.openxmlformats.org/officeDocument/2006/relationships" xmlns:p="http://schemas.openxmlformats.org/presentationml/2006/main">
   <p:cSld name="Slide 22">
     <p:spTree>
@@ -14299,7 +15354,7 @@
 </p:sld>
 </file>
 
-<file path=ppt/slides/slide23.xml><?xml version="1.0" encoding="utf-8"?>
+<file path=ppt/slides/slide25.xml><?xml version="1.0" encoding="utf-8"?>
 <p:sld xmlns:a="http://schemas.openxmlformats.org/drawingml/2006/main" xmlns:r="http://schemas.openxmlformats.org/officeDocument/2006/relationships" xmlns:p="http://schemas.openxmlformats.org/presentationml/2006/main">
   <p:cSld name="Slide 23">
     <p:spTree>
@@ -14831,7 +15886,7 @@
 </p:sld>
 </file>
 
-<file path=ppt/slides/slide24.xml><?xml version="1.0" encoding="utf-8"?>
+<file path=ppt/slides/slide26.xml><?xml version="1.0" encoding="utf-8"?>
 <p:sld xmlns:a="http://schemas.openxmlformats.org/drawingml/2006/main" xmlns:r="http://schemas.openxmlformats.org/officeDocument/2006/relationships" xmlns:p="http://schemas.openxmlformats.org/presentationml/2006/main">
   <p:cSld name="Slide 24">
     <p:spTree>
@@ -16856,7 +17911,7 @@
 </p:sld>
 </file>
 
-<file path=ppt/slides/slide25.xml><?xml version="1.0" encoding="utf-8"?>
+<file path=ppt/slides/slide27.xml><?xml version="1.0" encoding="utf-8"?>
 <p:sld xmlns:a="http://schemas.openxmlformats.org/drawingml/2006/main" xmlns:r="http://schemas.openxmlformats.org/officeDocument/2006/relationships" xmlns:p="http://schemas.openxmlformats.org/presentationml/2006/main">
   <p:cSld name="Slide 25">
     <p:spTree>
@@ -17683,7 +18738,7 @@
 </p:sld>
 </file>
 
-<file path=ppt/slides/slide26.xml><?xml version="1.0" encoding="utf-8"?>
+<file path=ppt/slides/slide28.xml><?xml version="1.0" encoding="utf-8"?>
 <p:sld xmlns:a="http://schemas.openxmlformats.org/drawingml/2006/main" xmlns:r="http://schemas.openxmlformats.org/officeDocument/2006/relationships" xmlns:p="http://schemas.openxmlformats.org/presentationml/2006/main">
   <p:cSld name="Slide 26">
     <p:spTree>
@@ -18012,6 +19067,532 @@
               <a:t>26</a:t>
             </a:fld>
             <a:endParaRPr lang="en-US"/>
+          </a:p>
+        </p:txBody>
+      </p:sp>
+    </p:spTree>
+  </p:cSld>
+  <p:clrMapOvr>
+    <a:masterClrMapping/>
+  </p:clrMapOvr>
+</p:sld>
+</file>
+
+<file path=ppt/slides/slide29.xml><?xml version="1.0" encoding="utf-8"?>
+<p:sld xmlns:a="http://schemas.openxmlformats.org/drawingml/2006/main" xmlns:p="http://schemas.openxmlformats.org/presentationml/2006/main" xmlns:r="http://schemas.openxmlformats.org/officeDocument/2006/relationships">
+  <p:cSld>
+    <p:spTree>
+      <p:nvGrpSpPr>
+        <p:cNvPr id="1" name=""/>
+        <p:cNvGrpSpPr/>
+        <p:nvPr/>
+      </p:nvGrpSpPr>
+      <p:grpSpPr/>
+      <p:sp>
+        <p:nvSpPr>
+          <p:cNvPr id="2" name="Text 0"/>
+          <p:cNvSpPr/>
+          <p:nvPr>
+            <p:ph idx="100" type="title" hasCustomPrompt="1"/>
+          </p:nvPr>
+        </p:nvSpPr>
+        <p:spPr>
+          <a:xfrm>
+            <a:off x="548640" y="320040"/>
+            <a:ext cx="11064240" cy="822960"/>
+          </a:xfrm>
+          <a:prstGeom prst="rect">
+            <a:avLst/>
+          </a:prstGeom>
+          <a:noFill/>
+          <a:ln/>
+        </p:spPr>
+        <p:txBody>
+          <a:bodyPr wrap="square" rtlCol="0" anchor="ctr"/>
+          <a:lstStyle/>
+          <a:p>
+            <a:pPr indent="0" marL="0">
+              <a:buNone/>
+            </a:pPr>
+            <a:r>
+              <a:rPr lang="en-US" sz="3000" b="1" dirty="0">
+                <a:solidFill>
+                  <a:schemeClr val="tx2"/>
+                </a:solidFill>
+              </a:rPr>
+              <a:t>대칭성: 어떻게 찾나</a:t>
+            </a:r>
+            <a:endParaRPr lang="en-US" sz="3000" dirty="0"/>
+          </a:p>
+        </p:txBody>
+      </p:sp>
+      <p:sp>
+        <p:nvSpPr>
+          <p:cNvPr id="4" name="formula card"/>
+          <p:cNvSpPr/>
+          <p:nvPr/>
+        </p:nvSpPr>
+        <p:spPr>
+          <a:xfrm>
+            <a:off x="548640" y="1371600"/>
+            <a:ext cx="6675120" cy="4846320"/>
+          </a:xfrm>
+          <a:prstGeom prst="roundRect">
+            <a:avLst>
+              <a:gd name="adj" fmla="val 2264"/>
+            </a:avLst>
+          </a:prstGeom>
+          <a:solidFill>
+            <a:schemeClr val="bg2"/>
+          </a:solidFill>
+          <a:ln w="12700">
+            <a:solidFill>
+              <a:schemeClr val="bg2"/>
+            </a:solidFill>
+            <a:prstDash val="solid"/>
+          </a:ln>
+        </p:spPr>
+      </p:sp>
+      <p:sp>
+        <p:nvSpPr>
+          <p:cNvPr id="5" name="Text 2"/>
+          <p:cNvSpPr txBox="1"/>
+          <p:nvPr/>
+        </p:nvSpPr>
+        <p:spPr>
+          <a:xfrm>
+            <a:off x="822960" y="1508760"/>
+            <a:ext cx="6126480" cy="320040"/>
+          </a:xfrm>
+          <a:prstGeom prst="rect">
+            <a:avLst/>
+          </a:prstGeom>
+          <a:noFill/>
+          <a:ln/>
+        </p:spPr>
+        <p:txBody>
+          <a:bodyPr wrap="square" lIns="0" tIns="0" rIns="0" bIns="0" rtlCol="0" anchor="ctr"/>
+          <a:lstStyle/>
+          <a:p>
+            <a:pPr indent="0" marL="0">
+              <a:buNone/>
+            </a:pPr>
+            <a:r>
+              <a:rPr lang="en-US" sz="1400" b="1" dirty="0">
+                <a:solidFill>
+                  <a:schemeClr val="accent1"/>
+                </a:solidFill>
+                <a:latin typeface="Apple SD Gothic Neo" pitchFamily="34" charset="0"/>
+                <a:ea typeface="Apple SD Gothic Neo" pitchFamily="34" charset="-122"/>
+                <a:cs typeface="Apple SD Gothic Neo" pitchFamily="34" charset="-120"/>
+              </a:rPr>
+              <a:t>MIP를 색칠한 그래프로 바꾸고, 그래프의 대칭을 찾는다</a:t>
+            </a:r>
+            <a:endParaRPr lang="en-US" sz="1400" dirty="0"/>
+          </a:p>
+        </p:txBody>
+      </p:sp>
+      <p:sp>
+        <p:nvSpPr>
+          <p:cNvPr id="12" name="param card"/>
+          <p:cNvSpPr/>
+          <p:nvPr/>
+        </p:nvSpPr>
+        <p:spPr>
+          <a:xfrm>
+            <a:off x="7589520" y="1371600"/>
+            <a:ext cx="4023360" cy="4846320"/>
+          </a:xfrm>
+          <a:prstGeom prst="roundRect">
+            <a:avLst>
+              <a:gd name="adj" fmla="val 2727"/>
+            </a:avLst>
+          </a:prstGeom>
+          <a:solidFill>
+            <a:schemeClr val="bg2"/>
+          </a:solidFill>
+          <a:ln w="12700">
+            <a:solidFill>
+              <a:schemeClr val="bg2"/>
+            </a:solidFill>
+            <a:prstDash val="solid"/>
+          </a:ln>
+        </p:spPr>
+      </p:sp>
+      <p:sp>
+        <p:nvSpPr>
+          <p:cNvPr id="13" name="Text 7"/>
+          <p:cNvSpPr txBox="1"/>
+          <p:nvPr/>
+        </p:nvSpPr>
+        <p:spPr>
+          <a:xfrm>
+            <a:off x="7818120" y="1536192"/>
+            <a:ext cx="3566160" cy="365760"/>
+          </a:xfrm>
+          <a:prstGeom prst="rect">
+            <a:avLst/>
+          </a:prstGeom>
+          <a:noFill/>
+          <a:ln/>
+        </p:spPr>
+        <p:txBody>
+          <a:bodyPr wrap="square" lIns="0" tIns="0" rIns="0" bIns="0" rtlCol="0" anchor="ctr"/>
+          <a:lstStyle/>
+          <a:p>
+            <a:pPr indent="0" marL="0">
+              <a:buNone/>
+            </a:pPr>
+            <a:r>
+              <a:rPr lang="en-US" sz="1600" b="1" dirty="0">
+                <a:solidFill>
+                  <a:schemeClr val="accent1"/>
+                </a:solidFill>
+                <a:latin typeface="Apple SD Gothic Neo" pitchFamily="34" charset="0"/>
+                <a:ea typeface="Apple SD Gothic Neo" pitchFamily="34" charset="-122"/>
+                <a:cs typeface="Apple SD Gothic Neo" pitchFamily="34" charset="-120"/>
+              </a:rPr>
+              <a:t>Example 9로 확인</a:t>
+            </a:r>
+            <a:endParaRPr lang="en-US" sz="1600" dirty="0"/>
+          </a:p>
+        </p:txBody>
+      </p:sp>
+      <p:sp>
+        <p:nvSpPr>
+          <p:cNvPr id="14" name="Text 8"/>
+          <p:cNvSpPr txBox="1"/>
+          <p:nvPr/>
+        </p:nvSpPr>
+        <p:spPr>
+          <a:xfrm>
+            <a:off x="7818120" y="2011680"/>
+            <a:ext cx="3566160" cy="4069080"/>
+          </a:xfrm>
+          <a:prstGeom prst="rect">
+            <a:avLst/>
+          </a:prstGeom>
+          <a:noFill/>
+          <a:ln/>
+        </p:spPr>
+        <p:txBody>
+          <a:bodyPr wrap="square" lIns="0" tIns="0" rIns="0" bIns="0" rtlCol="0" anchor="t"/>
+          <a:lstStyle/>
+          <a:p>
+            <a:pPr marL="342900" indent="-342900">
+              <a:spcAft>
+                <a:spcPts val="600"/>
+              </a:spcAft>
+              <a:buSzPct val="100000"/>
+              <a:buChar char="•"/>
+            </a:pPr>
+            <a:r>
+              <a:rPr lang="en-US" sz="1400" dirty="0">
+                <a:solidFill>
+                  <a:schemeClr val="tx1"/>
+                </a:solidFill>
+                <a:latin typeface="Apple SD Gothic Neo" pitchFamily="34" charset="0"/>
+                <a:ea typeface="Apple SD Gothic Neo" pitchFamily="34" charset="-122"/>
+                <a:cs typeface="Apple SD Gothic Neo" pitchFamily="34" charset="-120"/>
+              </a:rPr>
+              <a:t>x₁, x₂, x₆ 은 목적계수 4로 같은 색이지만, x₆ 은 두 제약에 모두 붙어 있어 x₁ 과 바뀔 수 없다</a:t>
+            </a:r>
+            <a:endParaRPr lang="en-US" sz="1400" dirty="0"/>
+          </a:p>
+          <a:p>
+            <a:pPr marL="342900" indent="-342900">
+              <a:spcAft>
+                <a:spcPts val="600"/>
+              </a:spcAft>
+              <a:buSzPct val="100000"/>
+              <a:buChar char="•"/>
+            </a:pPr>
+            <a:r>
+              <a:rPr lang="en-US" sz="1400" dirty="0">
+                <a:solidFill>
+                  <a:schemeClr val="tx1"/>
+                </a:solidFill>
+                <a:latin typeface="Apple SD Gothic Neo" pitchFamily="34" charset="0"/>
+                <a:ea typeface="Apple SD Gothic Neo" pitchFamily="34" charset="-122"/>
+                <a:cs typeface="Apple SD Gothic Neo" pitchFamily="34" charset="-120"/>
+              </a:rPr>
+              <a:t>(1 2)(3 4) 와 제약 1↔2 로 바꿔도 모든 간선이 보존된다 → 대칭 생성원</a:t>
+            </a:r>
+            <a:endParaRPr lang="en-US" sz="1400" dirty="0"/>
+          </a:p>
+          <a:p>
+            <a:pPr marL="342900" indent="-342900">
+              <a:spcAft>
+                <a:spcPts val="600"/>
+              </a:spcAft>
+              <a:buSzPct val="100000"/>
+              <a:buChar char="•"/>
+            </a:pPr>
+            <a:r>
+              <a:rPr lang="en-US" sz="1400" dirty="0">
+                <a:solidFill>
+                  <a:schemeClr val="tx1"/>
+                </a:solidFill>
+                <a:latin typeface="Apple SD Gothic Neo" pitchFamily="34" charset="0"/>
+                <a:ea typeface="Apple SD Gothic Neo" pitchFamily="34" charset="-122"/>
+                <a:cs typeface="Apple SD Gothic Neo" pitchFamily="34" charset="-120"/>
+              </a:rPr>
+              <a:t>궤도: {x₁, x₂}, {x₃, x₄}</a:t>
+            </a:r>
+            <a:endParaRPr lang="en-US" sz="1400" dirty="0"/>
+          </a:p>
+          <a:p>
+            <a:pPr marL="342900" indent="-342900">
+              <a:spcAft>
+                <a:spcPts val="600"/>
+              </a:spcAft>
+              <a:buSzPct val="100000"/>
+              <a:buChar char="•"/>
+            </a:pPr>
+            <a:r>
+              <a:rPr lang="en-US" sz="1400" dirty="0">
+                <a:solidFill>
+                  <a:schemeClr val="tx1"/>
+                </a:solidFill>
+                <a:latin typeface="Apple SD Gothic Neo" pitchFamily="34" charset="0"/>
+                <a:ea typeface="Apple SD Gothic Neo" pitchFamily="34" charset="-122"/>
+                <a:cs typeface="Apple SD Gothic Neo" pitchFamily="34" charset="-120"/>
+              </a:rPr>
+              <a:t>x₁, x₂ 는 같은 제약에 함께 나오지 않으므로 비중첩 → 병합 가능</a:t>
+            </a:r>
+            <a:endParaRPr lang="en-US" sz="1400" dirty="0"/>
+          </a:p>
+        </p:txBody>
+      </p:sp>
+      <p:sp>
+        <p:nvSpPr>
+          <p:cNvPr id="15" name="Text 9"/>
+          <p:cNvSpPr txBox="1"/>
+          <p:nvPr/>
+        </p:nvSpPr>
+        <p:spPr>
+          <a:xfrm>
+            <a:off x="548640" y="6355080"/>
+            <a:ext cx="10607040" cy="274320"/>
+          </a:xfrm>
+          <a:prstGeom prst="rect">
+            <a:avLst/>
+          </a:prstGeom>
+          <a:noFill/>
+          <a:ln/>
+        </p:spPr>
+        <p:txBody>
+          <a:bodyPr wrap="square" lIns="0" tIns="0" rIns="0" bIns="0" rtlCol="0" anchor="ctr"/>
+          <a:lstStyle/>
+          <a:p>
+            <a:pPr indent="0" marL="0">
+              <a:buNone/>
+            </a:pPr>
+            <a:r>
+              <a:rPr lang="en-US" sz="1000" dirty="0">
+                <a:solidFill>
+                  <a:schemeClr val="accent3"/>
+                </a:solidFill>
+                <a:latin typeface="Apple SD Gothic Neo" pitchFamily="34" charset="0"/>
+                <a:ea typeface="Apple SD Gothic Neo" pitchFamily="34" charset="-122"/>
+                <a:cs typeface="Apple SD Gothic Neo" pitchFamily="34" charset="-120"/>
+              </a:rPr>
+              <a:t>Achterberg 외 (2016/2019), 7.1·8.2절. Gurobi는 Saucy 기반 탐지라고만 서술. 그래프 변환은 일반적인 탐지 방식 설명(논문 외)</a:t>
+            </a:r>
+            <a:endParaRPr lang="en-US" sz="1000" dirty="0"/>
+          </a:p>
+        </p:txBody>
+      </p:sp>
+      <p:sp>
+        <p:nvSpPr>
+          <p:cNvPr id="25" name="Slide Number Placeholder 0"/>
+          <p:cNvSpPr>
+            <a:spLocks noGrp="1"/>
+          </p:cNvSpPr>
+          <p:nvPr>
+            <p:ph type="sldNum" sz="quarter" idx="4294967295"/>
+          </p:nvPr>
+        </p:nvSpPr>
+        <p:spPr>
+          <a:xfrm>
+            <a:off x="11338560" y="6400800"/>
+            <a:ext cx="548640" cy="274320"/>
+          </a:xfrm>
+          <a:prstGeom prst="rect">
+            <a:avLst/>
+          </a:prstGeom>
+          <a:extLst>
+            <a:ext uri="{C572A759-6A51-4108-AA02-DFA0A04FC94B}">
+              <ma14:wrappingTextBoxFlag xmlns:ma14="http://schemas.microsoft.com/office/mac/drawingml/2011/main" val="0"/>
+            </a:ext>
+          </a:extLst>
+        </p:spPr>
+        <p:txBody>
+          <a:bodyPr/>
+          <a:lstStyle>
+            <a:lvl1pPr>
+              <a:defRPr sz="1000">
+                <a:solidFill>
+                  <a:schemeClr val="accent3"/>
+                </a:solidFill>
+              </a:defRPr>
+            </a:lvl1pPr>
+          </a:lstStyle>
+          <a:p>
+            <a:pPr algn="r"/>
+            <a:fld id="{F7021451-1387-4CA6-816F-3879F97B5CBC}" type="slidenum">
+              <a:rPr b="0" lang="en-US"/>
+              <a:t>15</a:t>
+            </a:fld>
+            <a:endParaRPr lang="en-US"/>
+          </a:p>
+        </p:txBody>
+      </p:sp>
+      <p:sp>
+        <p:nvSpPr>
+          <p:cNvPr id="40" name="Text 10"/>
+          <p:cNvSpPr txBox="1"/>
+          <p:nvPr/>
+        </p:nvSpPr>
+        <p:spPr>
+          <a:xfrm>
+            <a:off x="822960" y="2011680"/>
+            <a:ext cx="6126480" cy="4069080"/>
+          </a:xfrm>
+          <a:prstGeom prst="rect">
+            <a:avLst/>
+          </a:prstGeom>
+          <a:noFill/>
+          <a:ln/>
+        </p:spPr>
+        <p:txBody>
+          <a:bodyPr wrap="square" lIns="0" tIns="0" rIns="0" bIns="0" rtlCol="0" anchor="t"/>
+          <a:lstStyle/>
+          <a:p>
+            <a:pPr marL="342900" indent="-342900">
+              <a:spcAft>
+                <a:spcPts val="600"/>
+              </a:spcAft>
+              <a:buSzPct val="100000"/>
+              <a:buChar char="•"/>
+            </a:pPr>
+            <a:r>
+              <a:rPr lang="en-US" sz="1400" dirty="0">
+                <a:solidFill>
+                  <a:schemeClr val="tx1"/>
+                </a:solidFill>
+                <a:latin typeface="Apple SD Gothic Neo" pitchFamily="34" charset="0"/>
+                <a:ea typeface="Apple SD Gothic Neo" pitchFamily="34" charset="-122"/>
+                <a:cs typeface="Apple SD Gothic Neo" pitchFamily="34" charset="-120"/>
+              </a:rPr>
+              <a:t>변수마다 정점: 색 = (목적계수, 상·하한, 정수 여부)</a:t>
+            </a:r>
+            <a:endParaRPr lang="en-US" sz="1400" dirty="0"/>
+          </a:p>
+          <a:p>
+            <a:pPr marL="342900" indent="-342900">
+              <a:spcAft>
+                <a:spcPts val="600"/>
+              </a:spcAft>
+              <a:buSzPct val="100000"/>
+              <a:buChar char="•"/>
+            </a:pPr>
+            <a:r>
+              <a:rPr lang="en-US" sz="1400" dirty="0">
+                <a:solidFill>
+                  <a:schemeClr val="tx1"/>
+                </a:solidFill>
+                <a:latin typeface="Apple SD Gothic Neo" pitchFamily="34" charset="0"/>
+                <a:ea typeface="Apple SD Gothic Neo" pitchFamily="34" charset="-122"/>
+                <a:cs typeface="Apple SD Gothic Neo" pitchFamily="34" charset="-120"/>
+              </a:rPr>
+              <a:t>제약마다 정점: 색 = (우변, 부등호 방향)</a:t>
+            </a:r>
+            <a:endParaRPr lang="en-US" sz="1400" dirty="0"/>
+          </a:p>
+          <a:p>
+            <a:pPr marL="342900" indent="-342900">
+              <a:spcAft>
+                <a:spcPts val="600"/>
+              </a:spcAft>
+              <a:buSzPct val="100000"/>
+              <a:buChar char="•"/>
+            </a:pPr>
+            <a:r>
+              <a:rPr lang="en-US" sz="1400" dirty="0">
+                <a:solidFill>
+                  <a:schemeClr val="tx1"/>
+                </a:solidFill>
+                <a:latin typeface="Apple SD Gothic Neo" pitchFamily="34" charset="0"/>
+                <a:ea typeface="Apple SD Gothic Neo" pitchFamily="34" charset="-122"/>
+                <a:cs typeface="Apple SD Gothic Neo" pitchFamily="34" charset="-120"/>
+              </a:rPr>
+              <a:t>0이 아닌 계수마다 간선: 색 = 계수 값</a:t>
+            </a:r>
+            <a:endParaRPr lang="en-US" sz="1400" dirty="0"/>
+          </a:p>
+          <a:p>
+            <a:pPr marL="342900" indent="-342900">
+              <a:spcAft>
+                <a:spcPts val="600"/>
+              </a:spcAft>
+              <a:buSzPct val="100000"/>
+              <a:buChar char="•"/>
+            </a:pPr>
+            <a:r>
+              <a:rPr lang="en-US" sz="1400" dirty="0">
+                <a:solidFill>
+                  <a:schemeClr val="tx1"/>
+                </a:solidFill>
+                <a:latin typeface="Apple SD Gothic Neo" pitchFamily="34" charset="0"/>
+                <a:ea typeface="Apple SD Gothic Neo" pitchFamily="34" charset="-122"/>
+                <a:cs typeface="Apple SD Gothic Neo" pitchFamily="34" charset="-120"/>
+              </a:rPr>
+              <a:t>색과 연결을 보존하며 정점을 재배치하는 방법 = 대칭 (automorphism)</a:t>
+            </a:r>
+            <a:endParaRPr lang="en-US" sz="1400" dirty="0"/>
+          </a:p>
+          <a:p>
+            <a:pPr marL="342900" indent="-342900">
+              <a:spcAft>
+                <a:spcPts val="600"/>
+              </a:spcAft>
+              <a:buSzPct val="100000"/>
+              <a:buChar char="•"/>
+            </a:pPr>
+            <a:r>
+              <a:rPr lang="en-US" sz="1400" dirty="0">
+                <a:solidFill>
+                  <a:schemeClr val="tx1"/>
+                </a:solidFill>
+                <a:latin typeface="Apple SD Gothic Neo" pitchFamily="34" charset="0"/>
+                <a:ea typeface="Apple SD Gothic Neo" pitchFamily="34" charset="-122"/>
+                <a:cs typeface="Apple SD Gothic Neo" pitchFamily="34" charset="-120"/>
+              </a:rPr>
+              <a:t>도구(nauty, bliss, Saucy)는 대칭 전부가 아니라 생성원만 찾는다</a:t>
+            </a:r>
+            <a:endParaRPr lang="en-US" sz="1400" dirty="0"/>
+          </a:p>
+          <a:p>
+            <a:pPr marL="342900" indent="-342900">
+              <a:spcAft>
+                <a:spcPts val="600"/>
+              </a:spcAft>
+              <a:buSzPct val="100000"/>
+              <a:buChar char="•"/>
+            </a:pPr>
+            <a:r>
+              <a:rPr lang="en-US" sz="1400" dirty="0">
+                <a:solidFill>
+                  <a:schemeClr val="tx1"/>
+                </a:solidFill>
+                <a:latin typeface="Apple SD Gothic Neo" pitchFamily="34" charset="0"/>
+                <a:ea typeface="Apple SD Gothic Neo" pitchFamily="34" charset="-122"/>
+                <a:cs typeface="Apple SD Gothic Neo" pitchFamily="34" charset="-120"/>
+              </a:rPr>
+              <a:t>묶인 변수 집합이 궤도(orbit)</a:t>
+            </a:r>
+            <a:endParaRPr lang="en-US" sz="1400" dirty="0"/>
           </a:p>
         </p:txBody>
       </p:sp>

</xml_diff>